<commit_message>
Slides: new dashboard and Discover screenshots, Moodle 5.2 note, wording fixes
Slide 28 shows the new 30-minute dashboard and slide 38 a new Discover
screenshot. Slides 1 and 5 state that Moodle 5.2 is the first version
with official OpenTelemetry support. OpenSearch is now configured before
the OpenTelemetry Collector is installed. Several titles and sentences
are reworded.
</commit_message>
<xml_diff>
--- a/Moodle-Otel-Opensearch/presentation/moodle-otel-deck.pptx
+++ b/Moodle-Otel-Opensearch/presentation/moodle-otel-deck.pptx
@@ -628,7 +628,7 @@
           <a:p>
             <a:r>
               <a:rPr lang="en-US" dirty="0"/>
-              <a:t>~1 min 30 s. Three statements, in this order. One: components 1 to 4 are not merely on the same server — they are inside the same PHP process, one per request. There is no deployment decision to make and nothing to install elsewhere. Two: the collector runs on the Moodle web server too, as a separate service. That is what the walk-through installs: one collector per Moodle server, talking over localhost, so the data never crosses the network on its way to the collector, and port 4318 stays closed. No extra server is needed. The other way is one shared collector on its own host for every web server you run — fewer things to configure and one place to filter personal data — the pattern we run; it needs the endpoint variable pointed at that host and port 4318 open there. Three: OpenSearch is always separate, and it is the one component most of them already have. If asked which to pick: the shared host for a small estate, one per server once traffic is large enough that you want the buffering close to the source. Two glosses to give in passing: OTLP on the arrow is simply the message format, properly defined in part two; and the reason for a relay at all is buffering — PHP hands the data off in a millisecond and gets back to serving the page, and if OpenSearch is slow or down the collector absorbs it instead of the request failing.</a:t>
+              <a:t>~1 min 30 s. Three statements, in this order. One: components 1 to 4 are not merely on the same server — they are inside the same PHP process, the one that runs Moodle's code. There is no deployment decision to make and nothing to install elsewhere. Two: the collector runs on the Moodle web server too, as a separate service. That is what the walk-through installs: one collector per Moodle server, talking over localhost, so the data never crosses the network on its way to the collector, and port 4318 stays closed. No extra server is needed. The other way is one shared collector on its own host for every web server you run — fewer things to configure and one place to filter personal data — the pattern we run; it needs the endpoint variable pointed at that host and port 4318 open there. Three: OpenSearch is always separate, and it is the one component most of them already have. If asked which to pick: the shared host for a small estate, one per server once traffic is large enough that you want the buffering close to the source. Two glosses to give in passing: OTLP on the arrow is simply the message format, properly defined in part two; and the reason for a relay at all is buffering — PHP hands the data off in a millisecond and gets back to serving the page, and if OpenSearch is slow or down the collector absorbs it instead of the request failing.</a:t>
             </a:r>
             <a:endParaRPr lang="en-US" dirty="0"/>
           </a:p>
@@ -1596,7 +1596,7 @@
           <a:p>
             <a:r>
               <a:rPr lang="en-US" dirty="0"/>
-              <a:t>~1 min. Say why the version is pinned in a variable: the collector releases every few weeks and the config keys change between versions — you will see a concrete example on the next slide. Take contrib, not the core build: the OpenSearch exporter only exists in contrib. After installing, the service is enabled but the shipped config does nothing useful until the next slide replaces it. Checked in the 0.159.0 package files: the postinstall script enables and starts the service at once, with the ready-made config file. That file listens on 0.0.0.0 on ports 4318 and 4317 (OTLP), 14250, 14268, 6831 and 6832 (Jaeger) and 9411 (Zipkin), and its debug exporter writes every record in full to the system log. Step 8 replaces the whole content of the file, and that closes the extra ports. Say this aloud; it is not on the slide. Also say that the Collector is the only new service. The PHP extension and the PHP packages run inside PHP, so after a change to them you restart PHP-FPM, and after a change to the Collector configuration you run systemctl restart otelcol-contrib.</a:t>
+              <a:t>~1 min 30 s. This is the slide the OpenSearch administrator in the room has been waiting for, and the one the Moodle administrator will hand to a colleague. Say the split out loud: the collector is yours, the four rows here are done by whoever runs OpenSearch. Row one: the action group names are OpenSearch's own — write means create and update documents in existing indices, create_index means create indices and mappings, and the cluster-level cluster_manage_index_templates is what manage_index_template needs, and the cluster-level indices:data/write/bulk lets the collector send its records in bulk. Without it OpenSearch answers 403 to every batch; a fresh demo stack showed this on 2026-09-23. Row two: the exporter README says manage_index_template "creates composable index templates on startup" and is only valid with otel-v1 mode; the version numbers are from the collector changelog. Row three: the demo stack's README has this exact step, and creating the pattern through the API instead of the screen gives a pattern without a field list that Discover rejects. Row four: the ISM documentation says the policy is attached "when an index that matches the ISM template pattern is created" — so create the policy before the first monthly index, or attach it by hand. Moved off the slide: the security plugin is part of every OpenSearch install and is on unless someone switched it off; the collector logs in with a basicauth extension, an https endpoint and a tls setting, shown in step 8; mode: otel-v1 arrived in collector 0.154.0 and manage_index_template in 0.157.0, and older builds such as 0.144.0 have neither key.</a:t>
             </a:r>
             <a:endParaRPr lang="en-US" dirty="0"/>
           </a:p>
@@ -1684,7 +1684,7 @@
           <a:p>
             <a:r>
               <a:rPr lang="en-US" dirty="0"/>
-              <a:t>~1 min 30 s. This is the slide the OpenSearch administrator in the room has been waiting for, and the one the Moodle administrator will hand to a colleague. Say the split out loud: the collector is yours, the four rows here are done by whoever runs OpenSearch. Row one: the action group names are OpenSearch's own — write means create and update documents in existing indices, create_index means create indices and mappings, and the cluster-level cluster_manage_index_templates is what manage_index_template needs, and the cluster-level indices:data/write/bulk lets the collector send its records in bulk. Without it OpenSearch answers 403 to every batch; a fresh demo stack showed this on 2026-09-23. Row two: the exporter README says manage_index_template "creates composable index templates on startup" and is only valid with otel-v1 mode; the version numbers are from the collector changelog. Row three: the demo stack's README has this exact step, and creating the pattern through the API instead of the screen gives a pattern without a field list that Discover rejects. Row four: the ISM documentation says the policy is attached "when an index that matches the ISM template pattern is created" — so create the policy before the first monthly index, or attach it by hand. Moved off the slide: the security plugin is part of every OpenSearch install and is on unless someone switched it off; the collector logs in with a basicauth extension, an https endpoint and a tls setting, shown in step 8; mode: otel-v1 arrived in collector 0.154.0 and manage_index_template in 0.157.0, and older builds such as 0.144.0 have neither key.</a:t>
+              <a:t>~1 min. Say why the version is pinned in a variable: the collector releases every few weeks and the config keys change between versions — you will see a concrete example on the next slide. Take contrib, not the core build: the OpenSearch exporter only exists in contrib. After installing, the service is enabled but the shipped config does nothing useful until the next slide replaces it. Checked in the 0.159.0 package files: the postinstall script enables and starts the service at once, with the ready-made config file. That file listens on 0.0.0.0 on ports 4318 and 4317 (OTLP), 14250, 14268, 6831 and 6832 (Jaeger) and 9411 (Zipkin), and its debug exporter writes every record in full to the system log. Step 8 replaces the whole content of the file, and that closes the extra ports. Say this aloud; it is not on the slide. Also say that the Collector is the only new service. The PHP extension and the PHP packages run inside PHP, so after a change to them you restart PHP-FPM, and after a change to the Collector configuration you run systemctl restart otelcol-contrib.</a:t>
             </a:r>
             <a:endParaRPr lang="en-US" dirty="0"/>
           </a:p>
@@ -1860,7 +1860,7 @@
           <a:p>
             <a:r>
               <a:rPr lang="en-US" dirty="0"/>
-              <a:t>~1 min 30 s. Say the host name out loud: opensearch1 is our name for the OpenSearch server in this and every following example, including the curl on the next slide — they substitute theirs. extensions holds the user name and the password of the OpenSearch user from step 7; the exporter points at this block by name and does not carry the credentials itself. insecure_skip_verify: true switches off every check of the OpenSearch certificate; with a real certificate, remove the line or set ca_file. One exporter, two pipelines: logs stores the events, traces stores the timing data that step 4 switched on with OTEL_TRACES_EXPORTER=otlp. Without the traces pipeline the collector answers 404 on /v1/traces, and PHP logs a warning on every request. traces_index stays otel-v1-apm-span: the Trace analytics page in OpenSearch Dashboards reads spans from that name only. Keys that carry the weight: logs_index must start with otel-v1-logs: the index template that the exporter installs applies only to the pattern otel-v1-logs*, tested on the demo stack. With any other name OpenSearch guesses the field types. The part after that is yours to name, and one events index per site is a sane default; Discover finds it by pattern. mapping.mode: otel-v1 writes one field layout for both kinds of data. The _time_format keys decide how many indices you create, and therefore how many shards — monthly, not daily. Flag honestly that this exporter is marked alpha upstream for both logs and traces (its README). manage_index_template was explained on the Configure OpenSearch slide, two back.</a:t>
+              <a:t>~1 min 30 s. Say the host name out loud: opensearch1 is our name for the OpenSearch server in this and every following example, including the curl on the next slide — they substitute theirs. extensions holds the user name and the password of the OpenSearch user from step 6; the exporter points at this block by name and does not carry the credentials itself. insecure_skip_verify: true switches off every check of the OpenSearch certificate; with a real certificate, remove the line or set ca_file. One exporter, two pipelines: logs stores the events, traces stores the timing data that step 4 switched on with OTEL_TRACES_EXPORTER=otlp. Without the traces pipeline the collector answers 404 on /v1/traces, and PHP logs a warning on every request. traces_index stays otel-v1-apm-span: the Trace analytics page in OpenSearch Dashboards reads spans from that name only. Keys that carry the weight: logs_index must start with otel-v1-logs: the index template that the exporter installs applies only to the pattern otel-v1-logs*, tested on the demo stack. With any other name OpenSearch guesses the field types. The part after that is yours to name, and one events index per site is a sane default; Discover finds it by pattern. mapping.mode: otel-v1 writes one field layout for both kinds of data. The _time_format keys decide how many indices you create, and therefore how many shards — monthly, not daily. Flag honestly that this exporter is marked alpha upstream for both logs and traces (its README). manage_index_template was explained on the Configure OpenSearch slide, two back.</a:t>
             </a:r>
             <a:endParaRPr lang="en-US" dirty="0"/>
           </a:p>
@@ -2300,7 +2300,7 @@
           <a:p>
             <a:r>
               <a:rPr lang="en-US" dirty="0"/>
-              <a:t>~1 min 30 s. A real screenshot from the Docker Compose stack. The dashboard has six charts on the events index, built by hand in OpenSearch Dashboards for this picture. The data is demo data, 3,143 events over seven days. Point at three things. First, the daytime shape in events per hour. Second, the burst in failed logins on 2026-09-03 at 03:00, which answers the opening question about failed logins. Third, the event types list, where every bar is a Moodle event name. Say that every chart is built from the same records that the searches read.</a:t>
+              <a:t>~1 min 30 s. A real screenshot from the Docker Compose stack. The dashboard shows the last 30 minutes and refreshes every 10 seconds. It has five charts and one list, and dashboards-init loads them at the first start. Point at three things. First, the failure line in "Logins per minute", where one minute has ten failed logins. This answers the opening question about failed logins. Second, the table of usernames with failed logins, which shows which username was attacked. Third, the list of latest events, where each click in Moodle shows as a new row. Say that every chart is built from the same records that the searches read.</a:t>
             </a:r>
             <a:endParaRPr lang="en-US" dirty="0"/>
           </a:p>
@@ -3268,7 +3268,7 @@
           <a:p>
             <a:r>
               <a:rPr lang="en-US" dirty="0"/>
-              <a:t>Use only if the live system fails. A real screenshot from the Docker Compose stack, taken beforehand: Discover on the events index, the same screen as demo move 2. Read one body out loud, then point at the columns: they are the attributes of the log record, chosen from the field list on the left. The histogram is the count of events per three hours.</a:t>
+              <a:t>Use only if the live system fails. A real screenshot from the Docker Compose stack, taken beforehand: Discover on the events index, the same screen as demo move 2. Read one body out loud, then point at the columns: they are the attributes of the log record, chosen from the field list on the left. The histogram is the count of events per 30 seconds.</a:t>
             </a:r>
             <a:endParaRPr lang="en-US" dirty="0"/>
           </a:p>
@@ -4272,7 +4272,7 @@
         </p:nvSpPr>
         <p:spPr>
           <a:xfrm>
-            <a:off x="647700" y="4453086"/>
+            <a:off x="647700" y="4824561"/>
             <a:ext cx="10896600" cy="695325"/>
           </a:xfrm>
           <a:prstGeom prst="roundRect">
@@ -4299,7 +4299,7 @@
         </p:nvSpPr>
         <p:spPr>
           <a:xfrm>
-            <a:off x="647700" y="1345019"/>
+            <a:off x="647700" y="973544"/>
             <a:ext cx="10953750" cy="185738"/>
           </a:xfrm>
           <a:prstGeom prst="rect">
@@ -4341,7 +4341,7 @@
         </p:nvSpPr>
         <p:spPr>
           <a:xfrm>
-            <a:off x="647700" y="1685776"/>
+            <a:off x="647700" y="1314301"/>
             <a:ext cx="8109049" cy="1490960"/>
           </a:xfrm>
           <a:prstGeom prst="rect">
@@ -4383,8 +4383,8 @@
         </p:nvSpPr>
         <p:spPr>
           <a:xfrm>
-            <a:off x="647700" y="3342948"/>
-            <a:ext cx="10953750" cy="742950"/>
+            <a:off x="647700" y="2971473"/>
+            <a:ext cx="10953750" cy="1485900"/>
           </a:xfrm>
           <a:prstGeom prst="rect">
             <a:avLst/>
@@ -4411,7 +4411,7 @@
                 <a:ea typeface="Arial" pitchFamily="34" charset="-122"/>
                 <a:cs typeface="Arial" pitchFamily="34" charset="-120"/>
               </a:rPr>
-              <a:t>This presentation shows you how to send Moodle logs and timing data to OpenSearch using OpenTelemetry. In OpenSearch you can run searches to analyse the state of your Moodle site.</a:t>
+              <a:t>This presentation shows you how to send Moodle logs and timing data to OpenSearch using OpenTelemetry. In OpenSearch you can run searches to analyse the state of your Moodle site. Moodle 5.2 is the first Moodle version with official OpenTelemetry support. Older versions cannot use this setup.</a:t>
             </a:r>
             <a:endParaRPr lang="en-US" sz="1950" dirty="0"/>
           </a:p>
@@ -4425,7 +4425,7 @@
         </p:nvSpPr>
         <p:spPr>
           <a:xfrm>
-            <a:off x="809625" y="4529524"/>
+            <a:off x="809625" y="4900999"/>
             <a:ext cx="10629900" cy="485775"/>
           </a:xfrm>
           <a:prstGeom prst="rect">
@@ -6613,11 +6613,11 @@
         <p:spPr>
           <a:xfrm>
             <a:off x="6482358" y="1233636"/>
-            <a:ext cx="5061942" cy="1235869"/>
+            <a:ext cx="5061942" cy="735806"/>
           </a:xfrm>
           <a:prstGeom prst="roundRect">
             <a:avLst>
-              <a:gd name="adj" fmla="val 11405"/>
+              <a:gd name="adj" fmla="val 32174"/>
             </a:avLst>
           </a:prstGeom>
           <a:ln w="10160">
@@ -6636,12 +6636,12 @@
         </p:nvSpPr>
         <p:spPr>
           <a:xfrm>
-            <a:off x="6482358" y="2602855"/>
-            <a:ext cx="5061942" cy="735806"/>
+            <a:off x="6482358" y="2102793"/>
+            <a:ext cx="5061942" cy="1235869"/>
           </a:xfrm>
           <a:prstGeom prst="roundRect">
             <a:avLst>
-              <a:gd name="adj" fmla="val 32174"/>
+              <a:gd name="adj" fmla="val 11405"/>
             </a:avLst>
           </a:prstGeom>
           <a:ln w="10160">
@@ -6987,7 +6987,7 @@
                 <a:ea typeface="Arial" pitchFamily="34" charset="-122"/>
                 <a:cs typeface="Arial" pitchFamily="34" charset="-120"/>
               </a:rPr>
-              <a:t>These six environment variables configure the OpenTelemetry PHP libraries</a:t>
+              <a:t>Six environment variables configure the OpenTelemetry PHP libraries</a:t>
             </a:r>
             <a:endParaRPr lang="en-US" sz="1310" dirty="0"/>
           </a:p>
@@ -7071,7 +7071,7 @@
                 <a:ea typeface="Courier New" pitchFamily="34" charset="-122"/>
                 <a:cs typeface="Courier New" pitchFamily="34" charset="-120"/>
               </a:rPr>
-              <a:t>COMPONENT 5 · THE OPENTELEMETRY COLLECTOR</a:t>
+              <a:t>COMPONENT 6 · OPENSEARCH</a:t>
             </a:r>
             <a:endParaRPr lang="en-US" sz="980" dirty="0"/>
           </a:p>
@@ -7113,7 +7113,7 @@
                 <a:ea typeface="Arial" pitchFamily="34" charset="-122"/>
                 <a:cs typeface="Arial" pitchFamily="34" charset="-120"/>
               </a:rPr>
-              <a:t>Install the OpenTelemetry Collector</a:t>
+              <a:t>Configure OpenSearch</a:t>
             </a:r>
             <a:endParaRPr lang="en-US" sz="1310" dirty="0"/>
           </a:p>
@@ -7127,8 +7127,8 @@
         </p:nvSpPr>
         <p:spPr>
           <a:xfrm>
-            <a:off x="6968133" y="1890266"/>
-            <a:ext cx="4471392" cy="433388"/>
+            <a:off x="6644283" y="2204948"/>
+            <a:ext cx="4795242" cy="185738"/>
           </a:xfrm>
           <a:prstGeom prst="rect">
             <a:avLst/>
@@ -7137,7 +7137,49 @@
           <a:ln/>
         </p:spPr>
         <p:txBody>
-          <a:bodyPr wrap="square" lIns="0" tIns="0" rIns="0" bIns="0" rtlCol="0" anchor="t"/>
+          <a:bodyPr wrap="none" lIns="0" tIns="0" rIns="0" bIns="0" rtlCol="0" anchor="t"/>
+          <a:lstStyle/>
+          <a:p>
+            <a:pPr algn="l" indent="0" marL="0">
+              <a:lnSpc>
+                <a:spcPts val="1460"/>
+              </a:lnSpc>
+              <a:buNone/>
+            </a:pPr>
+            <a:r>
+              <a:rPr lang="en-US" sz="980" spc="80" kern="0" dirty="0">
+                <a:solidFill>
+                  <a:srgbClr val="6FC7EE"/>
+                </a:solidFill>
+                <a:latin typeface="Courier New" pitchFamily="34" charset="0"/>
+                <a:ea typeface="Courier New" pitchFamily="34" charset="-122"/>
+                <a:cs typeface="Courier New" pitchFamily="34" charset="-120"/>
+              </a:rPr>
+              <a:t>COMPONENT 5 · THE OPENTELEMETRY COLLECTOR</a:t>
+            </a:r>
+            <a:endParaRPr lang="en-US" sz="980" dirty="0"/>
+          </a:p>
+        </p:txBody>
+      </p:sp>
+      <p:sp>
+        <p:nvSpPr>
+          <p:cNvPr id="19" name="Text 17"/>
+          <p:cNvSpPr txBox="1"/>
+          <p:nvPr/>
+        </p:nvSpPr>
+        <p:spPr>
+          <a:xfrm>
+            <a:off x="6968133" y="2476054"/>
+            <a:ext cx="4471392" cy="216694"/>
+          </a:xfrm>
+          <a:prstGeom prst="rect">
+            <a:avLst/>
+          </a:prstGeom>
+          <a:noFill/>
+          <a:ln/>
+        </p:spPr>
+        <p:txBody>
+          <a:bodyPr wrap="none" lIns="0" tIns="0" rIns="0" bIns="0" rtlCol="0" anchor="t"/>
           <a:lstStyle/>
           <a:p>
             <a:pPr algn="l" indent="0" marL="0">
@@ -7155,51 +7197,9 @@
                 <a:ea typeface="Arial" pitchFamily="34" charset="-122"/>
                 <a:cs typeface="Arial" pitchFamily="34" charset="-120"/>
               </a:rPr>
-              <a:t>Configure the OpenTelemetry Collector to receive and send the records</a:t>
+              <a:t>Install the OpenTelemetry Collector</a:t>
             </a:r>
             <a:endParaRPr lang="en-US" sz="1310" dirty="0"/>
-          </a:p>
-        </p:txBody>
-      </p:sp>
-      <p:sp>
-        <p:nvSpPr>
-          <p:cNvPr id="19" name="Text 17"/>
-          <p:cNvSpPr txBox="1"/>
-          <p:nvPr/>
-        </p:nvSpPr>
-        <p:spPr>
-          <a:xfrm>
-            <a:off x="6644283" y="2705011"/>
-            <a:ext cx="4795242" cy="185738"/>
-          </a:xfrm>
-          <a:prstGeom prst="rect">
-            <a:avLst/>
-          </a:prstGeom>
-          <a:noFill/>
-          <a:ln/>
-        </p:spPr>
-        <p:txBody>
-          <a:bodyPr wrap="none" lIns="0" tIns="0" rIns="0" bIns="0" rtlCol="0" anchor="t"/>
-          <a:lstStyle/>
-          <a:p>
-            <a:pPr algn="l" indent="0" marL="0">
-              <a:lnSpc>
-                <a:spcPts val="1460"/>
-              </a:lnSpc>
-              <a:buNone/>
-            </a:pPr>
-            <a:r>
-              <a:rPr lang="en-US" sz="980" spc="80" kern="0" dirty="0">
-                <a:solidFill>
-                  <a:srgbClr val="6FC7EE"/>
-                </a:solidFill>
-                <a:latin typeface="Courier New" pitchFamily="34" charset="0"/>
-                <a:ea typeface="Courier New" pitchFamily="34" charset="-122"/>
-                <a:cs typeface="Courier New" pitchFamily="34" charset="-120"/>
-              </a:rPr>
-              <a:t>COMPONENT 6 · OPENSEARCH</a:t>
-            </a:r>
-            <a:endParaRPr lang="en-US" sz="980" dirty="0"/>
           </a:p>
         </p:txBody>
       </p:sp>
@@ -7211,8 +7211,8 @@
         </p:nvSpPr>
         <p:spPr>
           <a:xfrm>
-            <a:off x="6968133" y="2976116"/>
-            <a:ext cx="4471392" cy="216694"/>
+            <a:off x="6968133" y="2759422"/>
+            <a:ext cx="4471392" cy="433388"/>
           </a:xfrm>
           <a:prstGeom prst="rect">
             <a:avLst/>
@@ -7221,7 +7221,7 @@
           <a:ln/>
         </p:spPr>
         <p:txBody>
-          <a:bodyPr wrap="none" lIns="0" tIns="0" rIns="0" bIns="0" rtlCol="0" anchor="t"/>
+          <a:bodyPr wrap="square" lIns="0" tIns="0" rIns="0" bIns="0" rtlCol="0" anchor="t"/>
           <a:lstStyle/>
           <a:p>
             <a:pPr algn="l" indent="0" marL="0">
@@ -7239,7 +7239,7 @@
                 <a:ea typeface="Arial" pitchFamily="34" charset="-122"/>
                 <a:cs typeface="Arial" pitchFamily="34" charset="-120"/>
               </a:rPr>
-              <a:t>Configure OpenSearch</a:t>
+              <a:t>Configure the OpenTelemetry Collector to receive and send the records</a:t>
             </a:r>
             <a:endParaRPr lang="en-US" sz="1310" dirty="0"/>
           </a:p>
@@ -7673,7 +7673,7 @@
         </p:nvSpPr>
         <p:spPr>
           <a:xfrm>
-            <a:off x="6606183" y="1902768"/>
+            <a:off x="6606183" y="2488555"/>
             <a:ext cx="285750" cy="216694"/>
           </a:xfrm>
           <a:prstGeom prst="rect">
@@ -7701,7 +7701,7 @@
                 <a:ea typeface="Courier New" pitchFamily="34" charset="-122"/>
                 <a:cs typeface="Courier New" pitchFamily="34" charset="-120"/>
               </a:rPr>
-              <a:t>8.</a:t>
+              <a:t>7.</a:t>
             </a:r>
             <a:endParaRPr lang="en-US" sz="1050" dirty="0"/>
           </a:p>
@@ -7715,7 +7715,7 @@
         </p:nvSpPr>
         <p:spPr>
           <a:xfrm>
-            <a:off x="6606183" y="2988618"/>
+            <a:off x="6606183" y="2771924"/>
             <a:ext cx="285750" cy="216694"/>
           </a:xfrm>
           <a:prstGeom prst="rect">
@@ -7743,7 +7743,7 @@
                 <a:ea typeface="Courier New" pitchFamily="34" charset="-122"/>
                 <a:cs typeface="Courier New" pitchFamily="34" charset="-120"/>
               </a:rPr>
-              <a:t>7.</a:t>
+              <a:t>8.</a:t>
             </a:r>
             <a:endParaRPr lang="en-US" sz="1050" dirty="0"/>
           </a:p>
@@ -10290,7 +10290,7 @@
         </p:nvSpPr>
         <p:spPr>
           <a:xfrm>
-            <a:off x="647700" y="2831306"/>
+            <a:off x="647700" y="2461022"/>
             <a:ext cx="10896600" cy="1455837"/>
           </a:xfrm>
           <a:prstGeom prst="roundRect">
@@ -10378,7 +10378,7 @@
         <p:spPr>
           <a:xfrm>
             <a:off x="647700" y="852488"/>
-            <a:ext cx="10953750" cy="740569"/>
+            <a:ext cx="10953750" cy="370332"/>
           </a:xfrm>
           <a:prstGeom prst="rect">
             <a:avLst/>
@@ -10387,7 +10387,7 @@
           <a:ln/>
         </p:spPr>
         <p:txBody>
-          <a:bodyPr wrap="square" lIns="0" tIns="0" rIns="0" bIns="0" rtlCol="0" anchor="t"/>
+          <a:bodyPr wrap="none" lIns="0" tIns="0" rIns="0" bIns="0" rtlCol="0" anchor="t"/>
           <a:lstStyle/>
           <a:p>
             <a:pPr algn="l" indent="0" marL="0">
@@ -10405,7 +10405,7 @@
                 <a:ea typeface="Arial" pitchFamily="34" charset="-122"/>
                 <a:cs typeface="Arial" pitchFamily="34" charset="-120"/>
               </a:rPr>
-              <a:t>These six environment variables configure the OpenTelemetry PHP libraries</a:t>
+              <a:t>Six environment variables configure the OpenTelemetry PHP libraries</a:t>
             </a:r>
             <a:endParaRPr lang="en-US" sz="2700" dirty="0"/>
           </a:p>
@@ -10419,7 +10419,7 @@
         </p:nvSpPr>
         <p:spPr>
           <a:xfrm>
-            <a:off x="647700" y="1797368"/>
+            <a:off x="647700" y="1427083"/>
             <a:ext cx="10953750" cy="742950"/>
           </a:xfrm>
           <a:prstGeom prst="rect">
@@ -10461,7 +10461,7 @@
         </p:nvSpPr>
         <p:spPr>
           <a:xfrm>
-            <a:off x="819150" y="2958941"/>
+            <a:off x="819150" y="2588657"/>
             <a:ext cx="10610850" cy="1151037"/>
           </a:xfrm>
           <a:prstGeom prst="rect">
@@ -10790,7 +10790,7 @@
         </p:nvSpPr>
         <p:spPr>
           <a:xfrm>
-            <a:off x="647700" y="4415254"/>
+            <a:off x="647700" y="4044970"/>
             <a:ext cx="10953750" cy="745927"/>
           </a:xfrm>
           <a:prstGeom prst="rect">
@@ -11769,7 +11769,7 @@
                 <a:ea typeface="Arial" pitchFamily="34" charset="-122"/>
                 <a:cs typeface="Arial" pitchFamily="34" charset="-120"/>
               </a:rPr>
-              <a:t>The problem with the Moodle log table</a:t>
+              <a:t>The Moodle log table and its limits</a:t>
             </a:r>
             <a:endParaRPr lang="en-US" sz="1750" dirty="0"/>
           </a:p>
@@ -12529,50 +12529,6 @@
         </p:nvSpPr>
         <p:spPr>
           <a:xfrm>
-            <a:off x="1223585" y="3215437"/>
-            <a:ext cx="4702050" cy="1301955"/>
-          </a:xfrm>
-          <a:prstGeom prst="roundRect">
-            <a:avLst>
-              <a:gd name="adj" fmla="val 9187"/>
-            </a:avLst>
-          </a:prstGeom>
-          <a:solidFill>
-            <a:srgbClr val="0F2027"/>
-          </a:solidFill>
-          <a:ln/>
-        </p:spPr>
-      </p:sp>
-      <p:sp>
-        <p:nvSpPr>
-          <p:cNvPr id="3" name="Shape 1"/>
-          <p:cNvSpPr/>
-          <p:nvPr/>
-        </p:nvSpPr>
-        <p:spPr>
-          <a:xfrm>
-            <a:off x="6266364" y="3215437"/>
-            <a:ext cx="4702050" cy="1301955"/>
-          </a:xfrm>
-          <a:prstGeom prst="roundRect">
-            <a:avLst>
-              <a:gd name="adj" fmla="val 9187"/>
-            </a:avLst>
-          </a:prstGeom>
-          <a:solidFill>
-            <a:srgbClr val="0F2027"/>
-          </a:solidFill>
-          <a:ln/>
-        </p:spPr>
-      </p:sp>
-      <p:sp>
-        <p:nvSpPr>
-          <p:cNvPr id="4" name="Shape 2"/>
-          <p:cNvSpPr/>
-          <p:nvPr/>
-        </p:nvSpPr>
-        <p:spPr>
-          <a:xfrm>
             <a:off x="647700" y="6343650"/>
             <a:ext cx="10896600" cy="0"/>
           </a:xfrm>
@@ -12588,826 +12544,9 @@
           </a:ln>
         </p:spPr>
       </p:sp>
-      <p:sp>
-        <p:nvSpPr>
-          <p:cNvPr id="5" name="Text 3"/>
-          <p:cNvSpPr txBox="1"/>
-          <p:nvPr/>
-        </p:nvSpPr>
-        <p:spPr>
-          <a:xfrm>
-            <a:off x="1223585" y="514028"/>
-            <a:ext cx="9801978" cy="166105"/>
-          </a:xfrm>
-          <a:prstGeom prst="rect">
-            <a:avLst/>
-          </a:prstGeom>
-          <a:noFill/>
-          <a:ln/>
-        </p:spPr>
-        <p:txBody>
-          <a:bodyPr wrap="none" lIns="0" tIns="0" rIns="0" bIns="0" rtlCol="0" anchor="t"/>
-          <a:lstStyle/>
-          <a:p>
-            <a:pPr algn="l" indent="0" marL="0">
-              <a:lnSpc>
-                <a:spcPts val="1310"/>
-              </a:lnSpc>
-              <a:buNone/>
-            </a:pPr>
-            <a:r>
-              <a:rPr lang="en-US" sz="870" spc="140" kern="0" dirty="0">
-                <a:solidFill>
-                  <a:srgbClr val="0B6E99"/>
-                </a:solidFill>
-                <a:latin typeface="Courier New" pitchFamily="34" charset="0"/>
-                <a:ea typeface="Courier New" pitchFamily="34" charset="-122"/>
-                <a:cs typeface="Courier New" pitchFamily="34" charset="-120"/>
-              </a:rPr>
-              <a:t>STEP 6 OF 9</a:t>
-            </a:r>
-            <a:endParaRPr lang="en-US" sz="870" dirty="0"/>
-          </a:p>
-        </p:txBody>
-      </p:sp>
-      <p:sp>
-        <p:nvSpPr>
-          <p:cNvPr id="6" name="Text 4"/>
-          <p:cNvSpPr txBox="1"/>
-          <p:nvPr/>
-        </p:nvSpPr>
-        <p:spPr>
-          <a:xfrm>
-            <a:off x="1223585" y="818760"/>
-            <a:ext cx="9801978" cy="386381"/>
-          </a:xfrm>
-          <a:prstGeom prst="rect">
-            <a:avLst/>
-          </a:prstGeom>
-          <a:noFill/>
-          <a:ln/>
-        </p:spPr>
-        <p:txBody>
-          <a:bodyPr wrap="none" lIns="0" tIns="0" rIns="0" bIns="0" rtlCol="0" anchor="t"/>
-          <a:lstStyle/>
-          <a:p>
-            <a:pPr algn="l" indent="0" marL="0">
-              <a:lnSpc>
-                <a:spcPts val="3040"/>
-              </a:lnSpc>
-              <a:buNone/>
-            </a:pPr>
-            <a:r>
-              <a:rPr lang="en-US" sz="2820" b="1" spc="-60" kern="0" dirty="0">
-                <a:solidFill>
-                  <a:srgbClr val="101A22"/>
-                </a:solidFill>
-                <a:latin typeface="Arial" pitchFamily="34" charset="0"/>
-                <a:ea typeface="Arial" pitchFamily="34" charset="-122"/>
-                <a:cs typeface="Arial" pitchFamily="34" charset="-120"/>
-              </a:rPr>
-              <a:t>Install the OpenTelemetry Collector</a:t>
-            </a:r>
-            <a:endParaRPr lang="en-US" sz="2820" dirty="0"/>
-          </a:p>
-        </p:txBody>
-      </p:sp>
-      <p:sp>
-        <p:nvSpPr>
-          <p:cNvPr id="7" name="Text 5"/>
-          <p:cNvSpPr txBox="1"/>
-          <p:nvPr/>
-        </p:nvSpPr>
-        <p:spPr>
-          <a:xfrm>
-            <a:off x="1223585" y="1387869"/>
-            <a:ext cx="9801978" cy="1328840"/>
-          </a:xfrm>
-          <a:prstGeom prst="rect">
-            <a:avLst/>
-          </a:prstGeom>
-          <a:noFill/>
-          <a:ln/>
-        </p:spPr>
-        <p:txBody>
-          <a:bodyPr wrap="square" lIns="0" tIns="0" rIns="0" bIns="0" rtlCol="0" anchor="t"/>
-          <a:lstStyle/>
-          <a:p>
-            <a:pPr algn="l" indent="0" marL="0">
-              <a:lnSpc>
-                <a:spcPts val="2610"/>
-              </a:lnSpc>
-              <a:buNone/>
-            </a:pPr>
-            <a:r>
-              <a:rPr lang="en-US" sz="1740" dirty="0">
-                <a:solidFill>
-                  <a:srgbClr val="5A6D7A"/>
-                </a:solidFill>
-                <a:latin typeface="Arial" pitchFamily="34" charset="0"/>
-                <a:ea typeface="Arial" pitchFamily="34" charset="-122"/>
-                <a:cs typeface="Arial" pitchFamily="34" charset="-120"/>
-              </a:rPr>
-              <a:t>The OpenTelemetry Collector runs as a service. It receives the records from Moodle and sends them to OpenSearch. These steps install it on the Moodle server, and it can also run on its own host. It is not in the standard Ubuntu and Red Hat repositories, so you download the .deb or .rpm package from GitHub. The releases page on GitHub shows the newest version.</a:t>
-            </a:r>
-            <a:endParaRPr lang="en-US" sz="1740" dirty="0"/>
-          </a:p>
-        </p:txBody>
-      </p:sp>
-      <p:sp>
-        <p:nvSpPr>
-          <p:cNvPr id="8" name="Text 6"/>
-          <p:cNvSpPr txBox="1"/>
-          <p:nvPr/>
-        </p:nvSpPr>
-        <p:spPr>
-          <a:xfrm>
-            <a:off x="1223585" y="2973521"/>
-            <a:ext cx="4759200" cy="163495"/>
-          </a:xfrm>
-          <a:prstGeom prst="rect">
-            <a:avLst/>
-          </a:prstGeom>
-          <a:noFill/>
-          <a:ln/>
-        </p:spPr>
-        <p:txBody>
-          <a:bodyPr wrap="none" lIns="0" tIns="0" rIns="0" bIns="0" rtlCol="0" anchor="t"/>
-          <a:lstStyle/>
-          <a:p>
-            <a:pPr algn="l" indent="0" marL="0">
-              <a:lnSpc>
-                <a:spcPts val="1290"/>
-              </a:lnSpc>
-              <a:buNone/>
-            </a:pPr>
-            <a:r>
-              <a:rPr lang="en-US" sz="1070" b="1" dirty="0">
-                <a:solidFill>
-                  <a:srgbClr val="0B6E99"/>
-                </a:solidFill>
-                <a:latin typeface="Courier New" pitchFamily="34" charset="0"/>
-                <a:ea typeface="Courier New" pitchFamily="34" charset="-122"/>
-                <a:cs typeface="Courier New" pitchFamily="34" charset="-120"/>
-              </a:rPr>
-              <a:t>Ubuntu 24.04 LTS</a:t>
-            </a:r>
-            <a:endParaRPr lang="en-US" sz="1070" dirty="0"/>
-          </a:p>
-        </p:txBody>
-      </p:sp>
-      <p:sp>
-        <p:nvSpPr>
-          <p:cNvPr id="9" name="Text 7"/>
-          <p:cNvSpPr txBox="1"/>
-          <p:nvPr/>
-        </p:nvSpPr>
-        <p:spPr>
-          <a:xfrm>
-            <a:off x="1376862" y="3329543"/>
-            <a:ext cx="4452648" cy="1029464"/>
-          </a:xfrm>
-          <a:prstGeom prst="rect">
-            <a:avLst/>
-          </a:prstGeom>
-          <a:noFill/>
-          <a:ln/>
-        </p:spPr>
-        <p:txBody>
-          <a:bodyPr wrap="square" lIns="0" tIns="0" rIns="0" bIns="0" rtlCol="0" anchor="t"/>
-          <a:lstStyle/>
-          <a:p>
-            <a:pPr algn="l" indent="0" marL="0">
-              <a:lnSpc>
-                <a:spcPts val="1350"/>
-              </a:lnSpc>
-              <a:buNone/>
-            </a:pPr>
-            <a:r>
-              <a:rPr lang="en-US" sz="870" dirty="0">
-                <a:solidFill>
-                  <a:srgbClr val="E4EDF2"/>
-                </a:solidFill>
-                <a:latin typeface="Courier New" pitchFamily="34" charset="0"/>
-                <a:ea typeface="Courier New" pitchFamily="34" charset="-122"/>
-                <a:cs typeface="Courier New" pitchFamily="34" charset="-120"/>
-              </a:rPr>
-              <a:t>V=0.161.0   </a:t>
-            </a:r>
-            <a:pPr algn="l" indent="0" marL="0">
-              <a:lnSpc>
-                <a:spcPts val="1350"/>
-              </a:lnSpc>
-              <a:buNone/>
-            </a:pPr>
-            <a:r>
-              <a:rPr lang="en-US" sz="870" dirty="0">
-                <a:solidFill>
-                  <a:srgbClr val="86A5B4"/>
-                </a:solidFill>
-                <a:latin typeface="Courier New" pitchFamily="34" charset="0"/>
-                <a:ea typeface="Courier New" pitchFamily="34" charset="-122"/>
-                <a:cs typeface="Courier New" pitchFamily="34" charset="-120"/>
-              </a:rPr>
-              <a:t># the version of the OpenTelemetry Collector</a:t>
-            </a:r>
-            <a:pPr algn="l" indent="0" marL="0">
-              <a:lnSpc>
-                <a:spcPts val="1350"/>
-              </a:lnSpc>
-              <a:buNone/>
-            </a:pPr>
-            <a:r>
-              <a:rPr lang="en-US" sz="870" dirty="0">
-                <a:solidFill>
-                  <a:srgbClr val="E4EDF2"/>
-                </a:solidFill>
-                <a:latin typeface="Courier New" pitchFamily="34" charset="0"/>
-                <a:ea typeface="Courier New" pitchFamily="34" charset="-122"/>
-                <a:cs typeface="Courier New" pitchFamily="34" charset="-120"/>
-              </a:rPr>
-              <a:t> </a:t>
-            </a:r>
-            <a:endParaRPr lang="en-US" sz="870" dirty="0"/>
-          </a:p>
-          <a:p>
-            <a:pPr algn="l" indent="0" marL="0">
-              <a:lnSpc>
-                <a:spcPts val="1350"/>
-              </a:lnSpc>
-              <a:buNone/>
-            </a:pPr>
-            <a:r>
-              <a:rPr lang="en-US" sz="870" dirty="0">
-                <a:solidFill>
-                  <a:srgbClr val="E4EDF2"/>
-                </a:solidFill>
-                <a:latin typeface="Courier New" pitchFamily="34" charset="0"/>
-                <a:ea typeface="Courier New" pitchFamily="34" charset="-122"/>
-                <a:cs typeface="Courier New" pitchFamily="34" charset="-120"/>
-              </a:rPr>
-              <a:t>wget https://github.com/open-telemetry/\</a:t>
-            </a:r>
-            <a:endParaRPr lang="en-US" sz="870" dirty="0"/>
-          </a:p>
-          <a:p>
-            <a:pPr algn="l" indent="0" marL="0">
-              <a:lnSpc>
-                <a:spcPts val="1350"/>
-              </a:lnSpc>
-              <a:buNone/>
-            </a:pPr>
-            <a:r>
-              <a:rPr lang="en-US" sz="870" dirty="0">
-                <a:solidFill>
-                  <a:srgbClr val="E4EDF2"/>
-                </a:solidFill>
-                <a:latin typeface="Courier New" pitchFamily="34" charset="0"/>
-                <a:ea typeface="Courier New" pitchFamily="34" charset="-122"/>
-                <a:cs typeface="Courier New" pitchFamily="34" charset="-120"/>
-              </a:rPr>
-              <a:t>opentelemetry-collector-releases/releases/\</a:t>
-            </a:r>
-            <a:endParaRPr lang="en-US" sz="870" dirty="0"/>
-          </a:p>
-          <a:p>
-            <a:pPr algn="l" indent="0" marL="0">
-              <a:lnSpc>
-                <a:spcPts val="1350"/>
-              </a:lnSpc>
-              <a:buNone/>
-            </a:pPr>
-            <a:r>
-              <a:rPr lang="en-US" sz="870" dirty="0">
-                <a:solidFill>
-                  <a:srgbClr val="E4EDF2"/>
-                </a:solidFill>
-                <a:latin typeface="Courier New" pitchFamily="34" charset="0"/>
-                <a:ea typeface="Courier New" pitchFamily="34" charset="-122"/>
-                <a:cs typeface="Courier New" pitchFamily="34" charset="-120"/>
-              </a:rPr>
-              <a:t>download/v$V/otelcol-contrib_${V}_linux_amd64.deb</a:t>
-            </a:r>
-            <a:endParaRPr lang="en-US" sz="870" dirty="0"/>
-          </a:p>
-          <a:p>
-            <a:pPr algn="l" indent="0" marL="0">
-              <a:lnSpc>
-                <a:spcPts val="1350"/>
-              </a:lnSpc>
-              <a:buNone/>
-            </a:pPr>
-            <a:r>
-              <a:rPr lang="en-US" sz="870" dirty="0">
-                <a:solidFill>
-                  <a:srgbClr val="E4EDF2"/>
-                </a:solidFill>
-                <a:latin typeface="Courier New" pitchFamily="34" charset="0"/>
-                <a:ea typeface="Courier New" pitchFamily="34" charset="-122"/>
-                <a:cs typeface="Courier New" pitchFamily="34" charset="-120"/>
-              </a:rPr>
-              <a:t> </a:t>
-            </a:r>
-            <a:endParaRPr lang="en-US" sz="870" dirty="0"/>
-          </a:p>
-          <a:p>
-            <a:pPr algn="l" indent="0" marL="0">
-              <a:lnSpc>
-                <a:spcPts val="1350"/>
-              </a:lnSpc>
-              <a:buNone/>
-            </a:pPr>
-            <a:r>
-              <a:rPr lang="en-US" sz="870" dirty="0">
-                <a:solidFill>
-                  <a:srgbClr val="E4EDF2"/>
-                </a:solidFill>
-                <a:latin typeface="Courier New" pitchFamily="34" charset="0"/>
-                <a:ea typeface="Courier New" pitchFamily="34" charset="-122"/>
-                <a:cs typeface="Courier New" pitchFamily="34" charset="-120"/>
-              </a:rPr>
-              <a:t>dpkg -i otelcol-contrib_${V}_linux_amd64.deb</a:t>
-            </a:r>
-            <a:endParaRPr lang="en-US" sz="870" dirty="0"/>
-          </a:p>
-        </p:txBody>
-      </p:sp>
-      <p:sp>
-        <p:nvSpPr>
-          <p:cNvPr id="10" name="Text 8"/>
-          <p:cNvSpPr txBox="1"/>
-          <p:nvPr/>
-        </p:nvSpPr>
-        <p:spPr>
-          <a:xfrm>
-            <a:off x="6266364" y="2973521"/>
-            <a:ext cx="4759200" cy="163495"/>
-          </a:xfrm>
-          <a:prstGeom prst="rect">
-            <a:avLst/>
-          </a:prstGeom>
-          <a:noFill/>
-          <a:ln/>
-        </p:spPr>
-        <p:txBody>
-          <a:bodyPr wrap="none" lIns="0" tIns="0" rIns="0" bIns="0" rtlCol="0" anchor="t"/>
-          <a:lstStyle/>
-          <a:p>
-            <a:pPr algn="l" indent="0" marL="0">
-              <a:lnSpc>
-                <a:spcPts val="1290"/>
-              </a:lnSpc>
-              <a:buNone/>
-            </a:pPr>
-            <a:r>
-              <a:rPr lang="en-US" sz="1070" b="1" dirty="0">
-                <a:solidFill>
-                  <a:srgbClr val="0B6E99"/>
-                </a:solidFill>
-                <a:latin typeface="Courier New" pitchFamily="34" charset="0"/>
-                <a:ea typeface="Courier New" pitchFamily="34" charset="-122"/>
-                <a:cs typeface="Courier New" pitchFamily="34" charset="-120"/>
-              </a:rPr>
-              <a:t>RHEL 9 · Rocky 9</a:t>
-            </a:r>
-            <a:endParaRPr lang="en-US" sz="1070" dirty="0"/>
-          </a:p>
-        </p:txBody>
-      </p:sp>
-      <p:sp>
-        <p:nvSpPr>
-          <p:cNvPr id="11" name="Text 9"/>
-          <p:cNvSpPr txBox="1"/>
-          <p:nvPr/>
-        </p:nvSpPr>
-        <p:spPr>
-          <a:xfrm>
-            <a:off x="6419640" y="3329543"/>
-            <a:ext cx="4452648" cy="1029464"/>
-          </a:xfrm>
-          <a:prstGeom prst="rect">
-            <a:avLst/>
-          </a:prstGeom>
-          <a:noFill/>
-          <a:ln/>
-        </p:spPr>
-        <p:txBody>
-          <a:bodyPr wrap="square" lIns="0" tIns="0" rIns="0" bIns="0" rtlCol="0" anchor="t"/>
-          <a:lstStyle/>
-          <a:p>
-            <a:pPr algn="l" indent="0" marL="0">
-              <a:lnSpc>
-                <a:spcPts val="1350"/>
-              </a:lnSpc>
-              <a:buNone/>
-            </a:pPr>
-            <a:r>
-              <a:rPr lang="en-US" sz="870" dirty="0">
-                <a:solidFill>
-                  <a:srgbClr val="E4EDF2"/>
-                </a:solidFill>
-                <a:latin typeface="Courier New" pitchFamily="34" charset="0"/>
-                <a:ea typeface="Courier New" pitchFamily="34" charset="-122"/>
-                <a:cs typeface="Courier New" pitchFamily="34" charset="-120"/>
-              </a:rPr>
-              <a:t>V=0.161.0   </a:t>
-            </a:r>
-            <a:pPr algn="l" indent="0" marL="0">
-              <a:lnSpc>
-                <a:spcPts val="1350"/>
-              </a:lnSpc>
-              <a:buNone/>
-            </a:pPr>
-            <a:r>
-              <a:rPr lang="en-US" sz="870" dirty="0">
-                <a:solidFill>
-                  <a:srgbClr val="86A5B4"/>
-                </a:solidFill>
-                <a:latin typeface="Courier New" pitchFamily="34" charset="0"/>
-                <a:ea typeface="Courier New" pitchFamily="34" charset="-122"/>
-                <a:cs typeface="Courier New" pitchFamily="34" charset="-120"/>
-              </a:rPr>
-              <a:t># the version of the OpenTelemetry Collector</a:t>
-            </a:r>
-            <a:pPr algn="l" indent="0" marL="0">
-              <a:lnSpc>
-                <a:spcPts val="1350"/>
-              </a:lnSpc>
-              <a:buNone/>
-            </a:pPr>
-            <a:r>
-              <a:rPr lang="en-US" sz="870" dirty="0">
-                <a:solidFill>
-                  <a:srgbClr val="E4EDF2"/>
-                </a:solidFill>
-                <a:latin typeface="Courier New" pitchFamily="34" charset="0"/>
-                <a:ea typeface="Courier New" pitchFamily="34" charset="-122"/>
-                <a:cs typeface="Courier New" pitchFamily="34" charset="-120"/>
-              </a:rPr>
-              <a:t> </a:t>
-            </a:r>
-            <a:endParaRPr lang="en-US" sz="870" dirty="0"/>
-          </a:p>
-          <a:p>
-            <a:pPr algn="l" indent="0" marL="0">
-              <a:lnSpc>
-                <a:spcPts val="1350"/>
-              </a:lnSpc>
-              <a:buNone/>
-            </a:pPr>
-            <a:r>
-              <a:rPr lang="en-US" sz="870" dirty="0">
-                <a:solidFill>
-                  <a:srgbClr val="E4EDF2"/>
-                </a:solidFill>
-                <a:latin typeface="Courier New" pitchFamily="34" charset="0"/>
-                <a:ea typeface="Courier New" pitchFamily="34" charset="-122"/>
-                <a:cs typeface="Courier New" pitchFamily="34" charset="-120"/>
-              </a:rPr>
-              <a:t>wget https://github.com/open-telemetry/\</a:t>
-            </a:r>
-            <a:endParaRPr lang="en-US" sz="870" dirty="0"/>
-          </a:p>
-          <a:p>
-            <a:pPr algn="l" indent="0" marL="0">
-              <a:lnSpc>
-                <a:spcPts val="1350"/>
-              </a:lnSpc>
-              <a:buNone/>
-            </a:pPr>
-            <a:r>
-              <a:rPr lang="en-US" sz="870" dirty="0">
-                <a:solidFill>
-                  <a:srgbClr val="E4EDF2"/>
-                </a:solidFill>
-                <a:latin typeface="Courier New" pitchFamily="34" charset="0"/>
-                <a:ea typeface="Courier New" pitchFamily="34" charset="-122"/>
-                <a:cs typeface="Courier New" pitchFamily="34" charset="-120"/>
-              </a:rPr>
-              <a:t>opentelemetry-collector-releases/releases/\</a:t>
-            </a:r>
-            <a:endParaRPr lang="en-US" sz="870" dirty="0"/>
-          </a:p>
-          <a:p>
-            <a:pPr algn="l" indent="0" marL="0">
-              <a:lnSpc>
-                <a:spcPts val="1350"/>
-              </a:lnSpc>
-              <a:buNone/>
-            </a:pPr>
-            <a:r>
-              <a:rPr lang="en-US" sz="870" dirty="0">
-                <a:solidFill>
-                  <a:srgbClr val="E4EDF2"/>
-                </a:solidFill>
-                <a:latin typeface="Courier New" pitchFamily="34" charset="0"/>
-                <a:ea typeface="Courier New" pitchFamily="34" charset="-122"/>
-                <a:cs typeface="Courier New" pitchFamily="34" charset="-120"/>
-              </a:rPr>
-              <a:t>download/v$V/otelcol-contrib_${V}_linux_amd64.rpm</a:t>
-            </a:r>
-            <a:endParaRPr lang="en-US" sz="870" dirty="0"/>
-          </a:p>
-          <a:p>
-            <a:pPr algn="l" indent="0" marL="0">
-              <a:lnSpc>
-                <a:spcPts val="1350"/>
-              </a:lnSpc>
-              <a:buNone/>
-            </a:pPr>
-            <a:r>
-              <a:rPr lang="en-US" sz="870" dirty="0">
-                <a:solidFill>
-                  <a:srgbClr val="E4EDF2"/>
-                </a:solidFill>
-                <a:latin typeface="Courier New" pitchFamily="34" charset="0"/>
-                <a:ea typeface="Courier New" pitchFamily="34" charset="-122"/>
-                <a:cs typeface="Courier New" pitchFamily="34" charset="-120"/>
-              </a:rPr>
-              <a:t> </a:t>
-            </a:r>
-            <a:endParaRPr lang="en-US" sz="870" dirty="0"/>
-          </a:p>
-          <a:p>
-            <a:pPr algn="l" indent="0" marL="0">
-              <a:lnSpc>
-                <a:spcPts val="1350"/>
-              </a:lnSpc>
-              <a:buNone/>
-            </a:pPr>
-            <a:r>
-              <a:rPr lang="en-US" sz="870" dirty="0">
-                <a:solidFill>
-                  <a:srgbClr val="E4EDF2"/>
-                </a:solidFill>
-                <a:latin typeface="Courier New" pitchFamily="34" charset="0"/>
-                <a:ea typeface="Courier New" pitchFamily="34" charset="-122"/>
-                <a:cs typeface="Courier New" pitchFamily="34" charset="-120"/>
-              </a:rPr>
-              <a:t>dnf install ./otelcol-contrib_${V}_linux_amd64.rpm</a:t>
-            </a:r>
-            <a:endParaRPr lang="en-US" sz="870" dirty="0"/>
-          </a:p>
-        </p:txBody>
-      </p:sp>
-      <p:sp>
-        <p:nvSpPr>
-          <p:cNvPr id="12" name="Text 10"/>
-          <p:cNvSpPr txBox="1"/>
-          <p:nvPr/>
-        </p:nvSpPr>
-        <p:spPr>
-          <a:xfrm>
-            <a:off x="1223585" y="4768266"/>
-            <a:ext cx="9801978" cy="1001954"/>
-          </a:xfrm>
-          <a:prstGeom prst="rect">
-            <a:avLst/>
-          </a:prstGeom>
-          <a:noFill/>
-          <a:ln/>
-        </p:spPr>
-        <p:txBody>
-          <a:bodyPr wrap="square" lIns="0" tIns="0" rIns="0" bIns="0" rtlCol="0" anchor="t"/>
-          <a:lstStyle/>
-          <a:p>
-            <a:pPr algn="l" indent="0" marL="0">
-              <a:lnSpc>
-                <a:spcPts val="2610"/>
-              </a:lnSpc>
-              <a:buNone/>
-            </a:pPr>
-            <a:r>
-              <a:rPr lang="en-US" sz="1740" dirty="0">
-                <a:solidFill>
-                  <a:srgbClr val="5A6D7A"/>
-                </a:solidFill>
-                <a:latin typeface="Arial" pitchFamily="34" charset="0"/>
-                <a:ea typeface="Arial" pitchFamily="34" charset="-122"/>
-                <a:cs typeface="Arial" pitchFamily="34" charset="-120"/>
-              </a:rPr>
-              <a:t>The package installs a systemd service with the name </a:t>
-            </a:r>
-            <a:pPr algn="l" indent="0" marL="0">
-              <a:lnSpc>
-                <a:spcPts val="2610"/>
-              </a:lnSpc>
-              <a:buNone/>
-            </a:pPr>
-            <a:r>
-              <a:rPr lang="en-US" sz="1530" dirty="0">
-                <a:solidFill>
-                  <a:srgbClr val="5A6D7A"/>
-                </a:solidFill>
-                <a:highlight>
-                  <a:srgbClr val="E1F0F7"/>
-                </a:highlight>
-                <a:latin typeface="Courier New" pitchFamily="34" charset="0"/>
-                <a:ea typeface="Courier New" pitchFamily="34" charset="-122"/>
-                <a:cs typeface="Courier New" pitchFamily="34" charset="-120"/>
-              </a:rPr>
-              <a:t>otelcol-contrib</a:t>
-            </a:r>
-            <a:pPr algn="l" indent="0" marL="0">
-              <a:lnSpc>
-                <a:spcPts val="2610"/>
-              </a:lnSpc>
-              <a:buNone/>
-            </a:pPr>
-            <a:r>
-              <a:rPr lang="en-US" sz="1740" dirty="0">
-                <a:solidFill>
-                  <a:srgbClr val="5A6D7A"/>
-                </a:solidFill>
-                <a:latin typeface="Arial" pitchFamily="34" charset="0"/>
-                <a:ea typeface="Arial" pitchFamily="34" charset="-122"/>
-                <a:cs typeface="Arial" pitchFamily="34" charset="-120"/>
-              </a:rPr>
-              <a:t> and the configuration file </a:t>
-            </a:r>
-            <a:pPr algn="l" indent="0" marL="0">
-              <a:lnSpc>
-                <a:spcPts val="2610"/>
-              </a:lnSpc>
-              <a:buNone/>
-            </a:pPr>
-            <a:r>
-              <a:rPr lang="en-US" sz="1530" dirty="0">
-                <a:solidFill>
-                  <a:srgbClr val="5A6D7A"/>
-                </a:solidFill>
-                <a:highlight>
-                  <a:srgbClr val="E1F0F7"/>
-                </a:highlight>
-                <a:latin typeface="Courier New" pitchFamily="34" charset="0"/>
-                <a:ea typeface="Courier New" pitchFamily="34" charset="-122"/>
-                <a:cs typeface="Courier New" pitchFamily="34" charset="-120"/>
-              </a:rPr>
-              <a:t>/etc/otelcol-contrib/config.yaml</a:t>
-            </a:r>
-            <a:pPr algn="l" indent="0" marL="0">
-              <a:lnSpc>
-                <a:spcPts val="2610"/>
-              </a:lnSpc>
-              <a:buNone/>
-            </a:pPr>
-            <a:r>
-              <a:rPr lang="en-US" sz="1740" dirty="0">
-                <a:solidFill>
-                  <a:srgbClr val="5A6D7A"/>
-                </a:solidFill>
-                <a:latin typeface="Arial" pitchFamily="34" charset="0"/>
-                <a:ea typeface="Arial" pitchFamily="34" charset="-122"/>
-                <a:cs typeface="Arial" pitchFamily="34" charset="-120"/>
-              </a:rPr>
-              <a:t>. The package starts the service, and the service listens on port 4318 for the records from Moodle.</a:t>
-            </a:r>
-            <a:endParaRPr lang="en-US" sz="1740" dirty="0"/>
-          </a:p>
-        </p:txBody>
-      </p:sp>
-      <p:sp>
-        <p:nvSpPr>
-          <p:cNvPr id="13" name="Text 11"/>
-          <p:cNvSpPr txBox="1"/>
-          <p:nvPr/>
-        </p:nvSpPr>
-        <p:spPr>
-          <a:xfrm>
-            <a:off x="647700" y="6464708"/>
-            <a:ext cx="948928" cy="142875"/>
-          </a:xfrm>
-          <a:prstGeom prst="rect">
-            <a:avLst/>
-          </a:prstGeom>
-          <a:noFill/>
-          <a:ln/>
-        </p:spPr>
-        <p:txBody>
-          <a:bodyPr wrap="none" lIns="0" tIns="0" rIns="0" bIns="0" rtlCol="0" anchor="t"/>
-          <a:lstStyle/>
-          <a:p>
-            <a:pPr algn="l" indent="0" marL="0">
-              <a:lnSpc>
-                <a:spcPts val="1050"/>
-              </a:lnSpc>
-              <a:buNone/>
-            </a:pPr>
-            <a:r>
-              <a:rPr lang="en-US" sz="870" dirty="0">
-                <a:solidFill>
-                  <a:srgbClr val="8496A2"/>
-                </a:solidFill>
-                <a:latin typeface="Courier New" pitchFamily="34" charset="0"/>
-                <a:ea typeface="Courier New" pitchFamily="34" charset="-122"/>
-                <a:cs typeface="Courier New" pitchFamily="34" charset="-120"/>
-              </a:rPr>
-              <a:t>Walk-through</a:t>
-            </a:r>
-            <a:endParaRPr lang="en-US" sz="870" dirty="0"/>
-          </a:p>
-        </p:txBody>
-      </p:sp>
-      <p:sp>
-        <p:nvSpPr>
-          <p:cNvPr id="14" name="Text 12"/>
-          <p:cNvSpPr txBox="1"/>
-          <p:nvPr/>
-        </p:nvSpPr>
-        <p:spPr>
-          <a:xfrm>
-            <a:off x="11024146" y="6464708"/>
-            <a:ext cx="577304" cy="142875"/>
-          </a:xfrm>
-          <a:prstGeom prst="rect">
-            <a:avLst/>
-          </a:prstGeom>
-          <a:noFill/>
-          <a:ln/>
-        </p:spPr>
-        <p:txBody>
-          <a:bodyPr wrap="none" lIns="0" tIns="0" rIns="0" bIns="0" rtlCol="0" anchor="t"/>
-          <a:lstStyle/>
-          <a:p>
-            <a:pPr algn="l" indent="0" marL="0">
-              <a:lnSpc>
-                <a:spcPts val="1050"/>
-              </a:lnSpc>
-              <a:buNone/>
-            </a:pPr>
-            <a:r>
-              <a:rPr lang="en-US" sz="870" dirty="0">
-                <a:solidFill>
-                  <a:srgbClr val="8496A2"/>
-                </a:solidFill>
-                <a:latin typeface="Courier New" pitchFamily="34" charset="0"/>
-                <a:ea typeface="Courier New" pitchFamily="34" charset="-122"/>
-                <a:cs typeface="Courier New" pitchFamily="34" charset="-120"/>
-              </a:rPr>
-              <a:t>20 / 39</a:t>
-            </a:r>
-            <a:endParaRPr lang="en-US" sz="870" dirty="0"/>
-          </a:p>
-        </p:txBody>
-      </p:sp>
-    </p:spTree>
-  </p:cSld>
-  <p:clrMapOvr>
-    <a:masterClrMapping/>
-  </p:clrMapOvr>
-</p:sld>
-</file>
-
-<file path=ppt/slides/slide21.xml><?xml version="1.0" encoding="utf-8"?>
-<p:sld xmlns:a="http://schemas.openxmlformats.org/drawingml/2006/main" xmlns:r="http://schemas.openxmlformats.org/officeDocument/2006/relationships" xmlns:p="http://schemas.openxmlformats.org/presentationml/2006/main">
-  <p:cSld name="Slide 21">
-    <p:bg>
-      <p:bgPr>
-        <a:solidFill>
-          <a:srgbClr val="FFFFFF"/>
-        </a:solidFill>
-      </p:bgPr>
-    </p:bg>
-    <p:spTree>
-      <p:nvGrpSpPr>
-        <p:cNvPr id="1" name=""/>
-        <p:cNvGrpSpPr/>
-        <p:nvPr/>
-      </p:nvGrpSpPr>
-      <p:grpSpPr>
-        <a:xfrm>
-          <a:off x="0" y="0"/>
-          <a:ext cx="0" cy="0"/>
-          <a:chOff x="0" y="0"/>
-          <a:chExt cx="0" cy="0"/>
-        </a:xfrm>
-      </p:grpSpPr>
-      <p:sp>
-        <p:nvSpPr>
-          <p:cNvPr id="2" name="Shape 0"/>
-          <p:cNvSpPr/>
-          <p:nvPr/>
-        </p:nvSpPr>
-        <p:spPr>
-          <a:xfrm>
-            <a:off x="647700" y="6343650"/>
-            <a:ext cx="10896600" cy="0"/>
-          </a:xfrm>
-          <a:prstGeom prst="line">
-            <a:avLst/>
-          </a:prstGeom>
-          <a:noFill/>
-          <a:ln w="8890">
-            <a:solidFill>
-              <a:srgbClr val="CBD7DF"/>
-            </a:solidFill>
-            <a:prstDash val="solid"/>
-          </a:ln>
-        </p:spPr>
-      </p:sp>
       <p:graphicFrame>
         <p:nvGraphicFramePr>
-          <p:cNvPr id="22" name="Table 0"/>
+          <p:cNvPr id="21" name="Table 0"/>
           <p:cNvGraphicFramePr>
             <a:graphicFrameLocks noGrp="1"/>
           </p:cNvGraphicFramePr>
@@ -14525,7 +13664,7 @@
                 <a:ea typeface="Courier New" pitchFamily="34" charset="-122"/>
                 <a:cs typeface="Courier New" pitchFamily="34" charset="-120"/>
               </a:rPr>
-              <a:t>STEP 7 OF 9</a:t>
+              <a:t>STEP 6 OF 9</a:t>
             </a:r>
             <a:endParaRPr lang="en-US" sz="900" dirty="0"/>
           </a:p>
@@ -14693,9 +13832,870 @@
                 <a:ea typeface="Courier New" pitchFamily="34" charset="-122"/>
                 <a:cs typeface="Courier New" pitchFamily="34" charset="-120"/>
               </a:rPr>
+              <a:t>20 / 39</a:t>
+            </a:r>
+            <a:endParaRPr lang="en-US" sz="900" dirty="0"/>
+          </a:p>
+        </p:txBody>
+      </p:sp>
+    </p:spTree>
+  </p:cSld>
+  <p:clrMapOvr>
+    <a:masterClrMapping/>
+  </p:clrMapOvr>
+</p:sld>
+</file>
+
+<file path=ppt/slides/slide21.xml><?xml version="1.0" encoding="utf-8"?>
+<p:sld xmlns:a="http://schemas.openxmlformats.org/drawingml/2006/main" xmlns:r="http://schemas.openxmlformats.org/officeDocument/2006/relationships" xmlns:p="http://schemas.openxmlformats.org/presentationml/2006/main">
+  <p:cSld name="Slide 21">
+    <p:bg>
+      <p:bgPr>
+        <a:solidFill>
+          <a:srgbClr val="FFFFFF"/>
+        </a:solidFill>
+      </p:bgPr>
+    </p:bg>
+    <p:spTree>
+      <p:nvGrpSpPr>
+        <p:cNvPr id="1" name=""/>
+        <p:cNvGrpSpPr/>
+        <p:nvPr/>
+      </p:nvGrpSpPr>
+      <p:grpSpPr>
+        <a:xfrm>
+          <a:off x="0" y="0"/>
+          <a:ext cx="0" cy="0"/>
+          <a:chOff x="0" y="0"/>
+          <a:chExt cx="0" cy="0"/>
+        </a:xfrm>
+      </p:grpSpPr>
+      <p:sp>
+        <p:nvSpPr>
+          <p:cNvPr id="2" name="Shape 0"/>
+          <p:cNvSpPr/>
+          <p:nvPr/>
+        </p:nvSpPr>
+        <p:spPr>
+          <a:xfrm>
+            <a:off x="1223585" y="3215437"/>
+            <a:ext cx="4702050" cy="1301955"/>
+          </a:xfrm>
+          <a:prstGeom prst="roundRect">
+            <a:avLst>
+              <a:gd name="adj" fmla="val 9187"/>
+            </a:avLst>
+          </a:prstGeom>
+          <a:solidFill>
+            <a:srgbClr val="0F2027"/>
+          </a:solidFill>
+          <a:ln/>
+        </p:spPr>
+      </p:sp>
+      <p:sp>
+        <p:nvSpPr>
+          <p:cNvPr id="3" name="Shape 1"/>
+          <p:cNvSpPr/>
+          <p:nvPr/>
+        </p:nvSpPr>
+        <p:spPr>
+          <a:xfrm>
+            <a:off x="6266364" y="3215437"/>
+            <a:ext cx="4702050" cy="1301955"/>
+          </a:xfrm>
+          <a:prstGeom prst="roundRect">
+            <a:avLst>
+              <a:gd name="adj" fmla="val 9187"/>
+            </a:avLst>
+          </a:prstGeom>
+          <a:solidFill>
+            <a:srgbClr val="0F2027"/>
+          </a:solidFill>
+          <a:ln/>
+        </p:spPr>
+      </p:sp>
+      <p:sp>
+        <p:nvSpPr>
+          <p:cNvPr id="4" name="Shape 2"/>
+          <p:cNvSpPr/>
+          <p:nvPr/>
+        </p:nvSpPr>
+        <p:spPr>
+          <a:xfrm>
+            <a:off x="647700" y="6343650"/>
+            <a:ext cx="10896600" cy="0"/>
+          </a:xfrm>
+          <a:prstGeom prst="line">
+            <a:avLst/>
+          </a:prstGeom>
+          <a:noFill/>
+          <a:ln w="8890">
+            <a:solidFill>
+              <a:srgbClr val="CBD7DF"/>
+            </a:solidFill>
+            <a:prstDash val="solid"/>
+          </a:ln>
+        </p:spPr>
+      </p:sp>
+      <p:sp>
+        <p:nvSpPr>
+          <p:cNvPr id="5" name="Text 3"/>
+          <p:cNvSpPr txBox="1"/>
+          <p:nvPr/>
+        </p:nvSpPr>
+        <p:spPr>
+          <a:xfrm>
+            <a:off x="1223585" y="514028"/>
+            <a:ext cx="9801978" cy="166105"/>
+          </a:xfrm>
+          <a:prstGeom prst="rect">
+            <a:avLst/>
+          </a:prstGeom>
+          <a:noFill/>
+          <a:ln/>
+        </p:spPr>
+        <p:txBody>
+          <a:bodyPr wrap="none" lIns="0" tIns="0" rIns="0" bIns="0" rtlCol="0" anchor="t"/>
+          <a:lstStyle/>
+          <a:p>
+            <a:pPr algn="l" indent="0" marL="0">
+              <a:lnSpc>
+                <a:spcPts val="1310"/>
+              </a:lnSpc>
+              <a:buNone/>
+            </a:pPr>
+            <a:r>
+              <a:rPr lang="en-US" sz="870" spc="140" kern="0" dirty="0">
+                <a:solidFill>
+                  <a:srgbClr val="0B6E99"/>
+                </a:solidFill>
+                <a:latin typeface="Courier New" pitchFamily="34" charset="0"/>
+                <a:ea typeface="Courier New" pitchFamily="34" charset="-122"/>
+                <a:cs typeface="Courier New" pitchFamily="34" charset="-120"/>
+              </a:rPr>
+              <a:t>STEP 7 OF 9</a:t>
+            </a:r>
+            <a:endParaRPr lang="en-US" sz="870" dirty="0"/>
+          </a:p>
+        </p:txBody>
+      </p:sp>
+      <p:sp>
+        <p:nvSpPr>
+          <p:cNvPr id="6" name="Text 4"/>
+          <p:cNvSpPr txBox="1"/>
+          <p:nvPr/>
+        </p:nvSpPr>
+        <p:spPr>
+          <a:xfrm>
+            <a:off x="1223585" y="818760"/>
+            <a:ext cx="9801978" cy="386381"/>
+          </a:xfrm>
+          <a:prstGeom prst="rect">
+            <a:avLst/>
+          </a:prstGeom>
+          <a:noFill/>
+          <a:ln/>
+        </p:spPr>
+        <p:txBody>
+          <a:bodyPr wrap="none" lIns="0" tIns="0" rIns="0" bIns="0" rtlCol="0" anchor="t"/>
+          <a:lstStyle/>
+          <a:p>
+            <a:pPr algn="l" indent="0" marL="0">
+              <a:lnSpc>
+                <a:spcPts val="3040"/>
+              </a:lnSpc>
+              <a:buNone/>
+            </a:pPr>
+            <a:r>
+              <a:rPr lang="en-US" sz="2820" b="1" spc="-60" kern="0" dirty="0">
+                <a:solidFill>
+                  <a:srgbClr val="101A22"/>
+                </a:solidFill>
+                <a:latin typeface="Arial" pitchFamily="34" charset="0"/>
+                <a:ea typeface="Arial" pitchFamily="34" charset="-122"/>
+                <a:cs typeface="Arial" pitchFamily="34" charset="-120"/>
+              </a:rPr>
+              <a:t>Install the OpenTelemetry Collector</a:t>
+            </a:r>
+            <a:endParaRPr lang="en-US" sz="2820" dirty="0"/>
+          </a:p>
+        </p:txBody>
+      </p:sp>
+      <p:sp>
+        <p:nvSpPr>
+          <p:cNvPr id="7" name="Text 5"/>
+          <p:cNvSpPr txBox="1"/>
+          <p:nvPr/>
+        </p:nvSpPr>
+        <p:spPr>
+          <a:xfrm>
+            <a:off x="1223585" y="1387869"/>
+            <a:ext cx="9801978" cy="1328840"/>
+          </a:xfrm>
+          <a:prstGeom prst="rect">
+            <a:avLst/>
+          </a:prstGeom>
+          <a:noFill/>
+          <a:ln/>
+        </p:spPr>
+        <p:txBody>
+          <a:bodyPr wrap="square" lIns="0" tIns="0" rIns="0" bIns="0" rtlCol="0" anchor="t"/>
+          <a:lstStyle/>
+          <a:p>
+            <a:pPr algn="l" indent="0" marL="0">
+              <a:lnSpc>
+                <a:spcPts val="2610"/>
+              </a:lnSpc>
+              <a:buNone/>
+            </a:pPr>
+            <a:r>
+              <a:rPr lang="en-US" sz="1740" dirty="0">
+                <a:solidFill>
+                  <a:srgbClr val="5A6D7A"/>
+                </a:solidFill>
+                <a:latin typeface="Arial" pitchFamily="34" charset="0"/>
+                <a:ea typeface="Arial" pitchFamily="34" charset="-122"/>
+                <a:cs typeface="Arial" pitchFamily="34" charset="-120"/>
+              </a:rPr>
+              <a:t>The OpenTelemetry Collector runs as a service. It receives the records from Moodle and sends them to OpenSearch. These steps install it on the Moodle server, and it can also run on its own host. It is not in the standard Ubuntu and Red Hat repositories, so you download the .deb or .rpm package from GitHub. The releases page on GitHub shows the newest version.</a:t>
+            </a:r>
+            <a:endParaRPr lang="en-US" sz="1740" dirty="0"/>
+          </a:p>
+        </p:txBody>
+      </p:sp>
+      <p:sp>
+        <p:nvSpPr>
+          <p:cNvPr id="8" name="Text 6"/>
+          <p:cNvSpPr txBox="1"/>
+          <p:nvPr/>
+        </p:nvSpPr>
+        <p:spPr>
+          <a:xfrm>
+            <a:off x="1223585" y="2973521"/>
+            <a:ext cx="4759200" cy="163495"/>
+          </a:xfrm>
+          <a:prstGeom prst="rect">
+            <a:avLst/>
+          </a:prstGeom>
+          <a:noFill/>
+          <a:ln/>
+        </p:spPr>
+        <p:txBody>
+          <a:bodyPr wrap="none" lIns="0" tIns="0" rIns="0" bIns="0" rtlCol="0" anchor="t"/>
+          <a:lstStyle/>
+          <a:p>
+            <a:pPr algn="l" indent="0" marL="0">
+              <a:lnSpc>
+                <a:spcPts val="1290"/>
+              </a:lnSpc>
+              <a:buNone/>
+            </a:pPr>
+            <a:r>
+              <a:rPr lang="en-US" sz="1070" b="1" dirty="0">
+                <a:solidFill>
+                  <a:srgbClr val="0B6E99"/>
+                </a:solidFill>
+                <a:latin typeface="Courier New" pitchFamily="34" charset="0"/>
+                <a:ea typeface="Courier New" pitchFamily="34" charset="-122"/>
+                <a:cs typeface="Courier New" pitchFamily="34" charset="-120"/>
+              </a:rPr>
+              <a:t>Ubuntu 24.04 LTS</a:t>
+            </a:r>
+            <a:endParaRPr lang="en-US" sz="1070" dirty="0"/>
+          </a:p>
+        </p:txBody>
+      </p:sp>
+      <p:sp>
+        <p:nvSpPr>
+          <p:cNvPr id="9" name="Text 7"/>
+          <p:cNvSpPr txBox="1"/>
+          <p:nvPr/>
+        </p:nvSpPr>
+        <p:spPr>
+          <a:xfrm>
+            <a:off x="1376862" y="3329543"/>
+            <a:ext cx="4452648" cy="1029464"/>
+          </a:xfrm>
+          <a:prstGeom prst="rect">
+            <a:avLst/>
+          </a:prstGeom>
+          <a:noFill/>
+          <a:ln/>
+        </p:spPr>
+        <p:txBody>
+          <a:bodyPr wrap="square" lIns="0" tIns="0" rIns="0" bIns="0" rtlCol="0" anchor="t"/>
+          <a:lstStyle/>
+          <a:p>
+            <a:pPr algn="l" indent="0" marL="0">
+              <a:lnSpc>
+                <a:spcPts val="1350"/>
+              </a:lnSpc>
+              <a:buNone/>
+            </a:pPr>
+            <a:r>
+              <a:rPr lang="en-US" sz="870" dirty="0">
+                <a:solidFill>
+                  <a:srgbClr val="E4EDF2"/>
+                </a:solidFill>
+                <a:latin typeface="Courier New" pitchFamily="34" charset="0"/>
+                <a:ea typeface="Courier New" pitchFamily="34" charset="-122"/>
+                <a:cs typeface="Courier New" pitchFamily="34" charset="-120"/>
+              </a:rPr>
+              <a:t>V=0.161.0   </a:t>
+            </a:r>
+            <a:pPr algn="l" indent="0" marL="0">
+              <a:lnSpc>
+                <a:spcPts val="1350"/>
+              </a:lnSpc>
+              <a:buNone/>
+            </a:pPr>
+            <a:r>
+              <a:rPr lang="en-US" sz="870" dirty="0">
+                <a:solidFill>
+                  <a:srgbClr val="86A5B4"/>
+                </a:solidFill>
+                <a:latin typeface="Courier New" pitchFamily="34" charset="0"/>
+                <a:ea typeface="Courier New" pitchFamily="34" charset="-122"/>
+                <a:cs typeface="Courier New" pitchFamily="34" charset="-120"/>
+              </a:rPr>
+              <a:t># the version of the OpenTelemetry Collector</a:t>
+            </a:r>
+            <a:pPr algn="l" indent="0" marL="0">
+              <a:lnSpc>
+                <a:spcPts val="1350"/>
+              </a:lnSpc>
+              <a:buNone/>
+            </a:pPr>
+            <a:r>
+              <a:rPr lang="en-US" sz="870" dirty="0">
+                <a:solidFill>
+                  <a:srgbClr val="E4EDF2"/>
+                </a:solidFill>
+                <a:latin typeface="Courier New" pitchFamily="34" charset="0"/>
+                <a:ea typeface="Courier New" pitchFamily="34" charset="-122"/>
+                <a:cs typeface="Courier New" pitchFamily="34" charset="-120"/>
+              </a:rPr>
+              <a:t> </a:t>
+            </a:r>
+            <a:endParaRPr lang="en-US" sz="870" dirty="0"/>
+          </a:p>
+          <a:p>
+            <a:pPr algn="l" indent="0" marL="0">
+              <a:lnSpc>
+                <a:spcPts val="1350"/>
+              </a:lnSpc>
+              <a:buNone/>
+            </a:pPr>
+            <a:r>
+              <a:rPr lang="en-US" sz="870" dirty="0">
+                <a:solidFill>
+                  <a:srgbClr val="E4EDF2"/>
+                </a:solidFill>
+                <a:latin typeface="Courier New" pitchFamily="34" charset="0"/>
+                <a:ea typeface="Courier New" pitchFamily="34" charset="-122"/>
+                <a:cs typeface="Courier New" pitchFamily="34" charset="-120"/>
+              </a:rPr>
+              <a:t>wget https://github.com/open-telemetry/\</a:t>
+            </a:r>
+            <a:endParaRPr lang="en-US" sz="870" dirty="0"/>
+          </a:p>
+          <a:p>
+            <a:pPr algn="l" indent="0" marL="0">
+              <a:lnSpc>
+                <a:spcPts val="1350"/>
+              </a:lnSpc>
+              <a:buNone/>
+            </a:pPr>
+            <a:r>
+              <a:rPr lang="en-US" sz="870" dirty="0">
+                <a:solidFill>
+                  <a:srgbClr val="E4EDF2"/>
+                </a:solidFill>
+                <a:latin typeface="Courier New" pitchFamily="34" charset="0"/>
+                <a:ea typeface="Courier New" pitchFamily="34" charset="-122"/>
+                <a:cs typeface="Courier New" pitchFamily="34" charset="-120"/>
+              </a:rPr>
+              <a:t>opentelemetry-collector-releases/releases/\</a:t>
+            </a:r>
+            <a:endParaRPr lang="en-US" sz="870" dirty="0"/>
+          </a:p>
+          <a:p>
+            <a:pPr algn="l" indent="0" marL="0">
+              <a:lnSpc>
+                <a:spcPts val="1350"/>
+              </a:lnSpc>
+              <a:buNone/>
+            </a:pPr>
+            <a:r>
+              <a:rPr lang="en-US" sz="870" dirty="0">
+                <a:solidFill>
+                  <a:srgbClr val="E4EDF2"/>
+                </a:solidFill>
+                <a:latin typeface="Courier New" pitchFamily="34" charset="0"/>
+                <a:ea typeface="Courier New" pitchFamily="34" charset="-122"/>
+                <a:cs typeface="Courier New" pitchFamily="34" charset="-120"/>
+              </a:rPr>
+              <a:t>download/v$V/otelcol-contrib_${V}_linux_amd64.deb</a:t>
+            </a:r>
+            <a:endParaRPr lang="en-US" sz="870" dirty="0"/>
+          </a:p>
+          <a:p>
+            <a:pPr algn="l" indent="0" marL="0">
+              <a:lnSpc>
+                <a:spcPts val="1350"/>
+              </a:lnSpc>
+              <a:buNone/>
+            </a:pPr>
+            <a:r>
+              <a:rPr lang="en-US" sz="870" dirty="0">
+                <a:solidFill>
+                  <a:srgbClr val="E4EDF2"/>
+                </a:solidFill>
+                <a:latin typeface="Courier New" pitchFamily="34" charset="0"/>
+                <a:ea typeface="Courier New" pitchFamily="34" charset="-122"/>
+                <a:cs typeface="Courier New" pitchFamily="34" charset="-120"/>
+              </a:rPr>
+              <a:t> </a:t>
+            </a:r>
+            <a:endParaRPr lang="en-US" sz="870" dirty="0"/>
+          </a:p>
+          <a:p>
+            <a:pPr algn="l" indent="0" marL="0">
+              <a:lnSpc>
+                <a:spcPts val="1350"/>
+              </a:lnSpc>
+              <a:buNone/>
+            </a:pPr>
+            <a:r>
+              <a:rPr lang="en-US" sz="870" dirty="0">
+                <a:solidFill>
+                  <a:srgbClr val="E4EDF2"/>
+                </a:solidFill>
+                <a:latin typeface="Courier New" pitchFamily="34" charset="0"/>
+                <a:ea typeface="Courier New" pitchFamily="34" charset="-122"/>
+                <a:cs typeface="Courier New" pitchFamily="34" charset="-120"/>
+              </a:rPr>
+              <a:t>dpkg -i otelcol-contrib_${V}_linux_amd64.deb</a:t>
+            </a:r>
+            <a:endParaRPr lang="en-US" sz="870" dirty="0"/>
+          </a:p>
+        </p:txBody>
+      </p:sp>
+      <p:sp>
+        <p:nvSpPr>
+          <p:cNvPr id="10" name="Text 8"/>
+          <p:cNvSpPr txBox="1"/>
+          <p:nvPr/>
+        </p:nvSpPr>
+        <p:spPr>
+          <a:xfrm>
+            <a:off x="6266364" y="2973521"/>
+            <a:ext cx="4759200" cy="163495"/>
+          </a:xfrm>
+          <a:prstGeom prst="rect">
+            <a:avLst/>
+          </a:prstGeom>
+          <a:noFill/>
+          <a:ln/>
+        </p:spPr>
+        <p:txBody>
+          <a:bodyPr wrap="none" lIns="0" tIns="0" rIns="0" bIns="0" rtlCol="0" anchor="t"/>
+          <a:lstStyle/>
+          <a:p>
+            <a:pPr algn="l" indent="0" marL="0">
+              <a:lnSpc>
+                <a:spcPts val="1290"/>
+              </a:lnSpc>
+              <a:buNone/>
+            </a:pPr>
+            <a:r>
+              <a:rPr lang="en-US" sz="1070" b="1" dirty="0">
+                <a:solidFill>
+                  <a:srgbClr val="0B6E99"/>
+                </a:solidFill>
+                <a:latin typeface="Courier New" pitchFamily="34" charset="0"/>
+                <a:ea typeface="Courier New" pitchFamily="34" charset="-122"/>
+                <a:cs typeface="Courier New" pitchFamily="34" charset="-120"/>
+              </a:rPr>
+              <a:t>RHEL 9 · Rocky 9</a:t>
+            </a:r>
+            <a:endParaRPr lang="en-US" sz="1070" dirty="0"/>
+          </a:p>
+        </p:txBody>
+      </p:sp>
+      <p:sp>
+        <p:nvSpPr>
+          <p:cNvPr id="11" name="Text 9"/>
+          <p:cNvSpPr txBox="1"/>
+          <p:nvPr/>
+        </p:nvSpPr>
+        <p:spPr>
+          <a:xfrm>
+            <a:off x="6419640" y="3329543"/>
+            <a:ext cx="4452648" cy="1029464"/>
+          </a:xfrm>
+          <a:prstGeom prst="rect">
+            <a:avLst/>
+          </a:prstGeom>
+          <a:noFill/>
+          <a:ln/>
+        </p:spPr>
+        <p:txBody>
+          <a:bodyPr wrap="square" lIns="0" tIns="0" rIns="0" bIns="0" rtlCol="0" anchor="t"/>
+          <a:lstStyle/>
+          <a:p>
+            <a:pPr algn="l" indent="0" marL="0">
+              <a:lnSpc>
+                <a:spcPts val="1350"/>
+              </a:lnSpc>
+              <a:buNone/>
+            </a:pPr>
+            <a:r>
+              <a:rPr lang="en-US" sz="870" dirty="0">
+                <a:solidFill>
+                  <a:srgbClr val="E4EDF2"/>
+                </a:solidFill>
+                <a:latin typeface="Courier New" pitchFamily="34" charset="0"/>
+                <a:ea typeface="Courier New" pitchFamily="34" charset="-122"/>
+                <a:cs typeface="Courier New" pitchFamily="34" charset="-120"/>
+              </a:rPr>
+              <a:t>V=0.161.0   </a:t>
+            </a:r>
+            <a:pPr algn="l" indent="0" marL="0">
+              <a:lnSpc>
+                <a:spcPts val="1350"/>
+              </a:lnSpc>
+              <a:buNone/>
+            </a:pPr>
+            <a:r>
+              <a:rPr lang="en-US" sz="870" dirty="0">
+                <a:solidFill>
+                  <a:srgbClr val="86A5B4"/>
+                </a:solidFill>
+                <a:latin typeface="Courier New" pitchFamily="34" charset="0"/>
+                <a:ea typeface="Courier New" pitchFamily="34" charset="-122"/>
+                <a:cs typeface="Courier New" pitchFamily="34" charset="-120"/>
+              </a:rPr>
+              <a:t># the version of the OpenTelemetry Collector</a:t>
+            </a:r>
+            <a:pPr algn="l" indent="0" marL="0">
+              <a:lnSpc>
+                <a:spcPts val="1350"/>
+              </a:lnSpc>
+              <a:buNone/>
+            </a:pPr>
+            <a:r>
+              <a:rPr lang="en-US" sz="870" dirty="0">
+                <a:solidFill>
+                  <a:srgbClr val="E4EDF2"/>
+                </a:solidFill>
+                <a:latin typeface="Courier New" pitchFamily="34" charset="0"/>
+                <a:ea typeface="Courier New" pitchFamily="34" charset="-122"/>
+                <a:cs typeface="Courier New" pitchFamily="34" charset="-120"/>
+              </a:rPr>
+              <a:t> </a:t>
+            </a:r>
+            <a:endParaRPr lang="en-US" sz="870" dirty="0"/>
+          </a:p>
+          <a:p>
+            <a:pPr algn="l" indent="0" marL="0">
+              <a:lnSpc>
+                <a:spcPts val="1350"/>
+              </a:lnSpc>
+              <a:buNone/>
+            </a:pPr>
+            <a:r>
+              <a:rPr lang="en-US" sz="870" dirty="0">
+                <a:solidFill>
+                  <a:srgbClr val="E4EDF2"/>
+                </a:solidFill>
+                <a:latin typeface="Courier New" pitchFamily="34" charset="0"/>
+                <a:ea typeface="Courier New" pitchFamily="34" charset="-122"/>
+                <a:cs typeface="Courier New" pitchFamily="34" charset="-120"/>
+              </a:rPr>
+              <a:t>wget https://github.com/open-telemetry/\</a:t>
+            </a:r>
+            <a:endParaRPr lang="en-US" sz="870" dirty="0"/>
+          </a:p>
+          <a:p>
+            <a:pPr algn="l" indent="0" marL="0">
+              <a:lnSpc>
+                <a:spcPts val="1350"/>
+              </a:lnSpc>
+              <a:buNone/>
+            </a:pPr>
+            <a:r>
+              <a:rPr lang="en-US" sz="870" dirty="0">
+                <a:solidFill>
+                  <a:srgbClr val="E4EDF2"/>
+                </a:solidFill>
+                <a:latin typeface="Courier New" pitchFamily="34" charset="0"/>
+                <a:ea typeface="Courier New" pitchFamily="34" charset="-122"/>
+                <a:cs typeface="Courier New" pitchFamily="34" charset="-120"/>
+              </a:rPr>
+              <a:t>opentelemetry-collector-releases/releases/\</a:t>
+            </a:r>
+            <a:endParaRPr lang="en-US" sz="870" dirty="0"/>
+          </a:p>
+          <a:p>
+            <a:pPr algn="l" indent="0" marL="0">
+              <a:lnSpc>
+                <a:spcPts val="1350"/>
+              </a:lnSpc>
+              <a:buNone/>
+            </a:pPr>
+            <a:r>
+              <a:rPr lang="en-US" sz="870" dirty="0">
+                <a:solidFill>
+                  <a:srgbClr val="E4EDF2"/>
+                </a:solidFill>
+                <a:latin typeface="Courier New" pitchFamily="34" charset="0"/>
+                <a:ea typeface="Courier New" pitchFamily="34" charset="-122"/>
+                <a:cs typeface="Courier New" pitchFamily="34" charset="-120"/>
+              </a:rPr>
+              <a:t>download/v$V/otelcol-contrib_${V}_linux_amd64.rpm</a:t>
+            </a:r>
+            <a:endParaRPr lang="en-US" sz="870" dirty="0"/>
+          </a:p>
+          <a:p>
+            <a:pPr algn="l" indent="0" marL="0">
+              <a:lnSpc>
+                <a:spcPts val="1350"/>
+              </a:lnSpc>
+              <a:buNone/>
+            </a:pPr>
+            <a:r>
+              <a:rPr lang="en-US" sz="870" dirty="0">
+                <a:solidFill>
+                  <a:srgbClr val="E4EDF2"/>
+                </a:solidFill>
+                <a:latin typeface="Courier New" pitchFamily="34" charset="0"/>
+                <a:ea typeface="Courier New" pitchFamily="34" charset="-122"/>
+                <a:cs typeface="Courier New" pitchFamily="34" charset="-120"/>
+              </a:rPr>
+              <a:t> </a:t>
+            </a:r>
+            <a:endParaRPr lang="en-US" sz="870" dirty="0"/>
+          </a:p>
+          <a:p>
+            <a:pPr algn="l" indent="0" marL="0">
+              <a:lnSpc>
+                <a:spcPts val="1350"/>
+              </a:lnSpc>
+              <a:buNone/>
+            </a:pPr>
+            <a:r>
+              <a:rPr lang="en-US" sz="870" dirty="0">
+                <a:solidFill>
+                  <a:srgbClr val="E4EDF2"/>
+                </a:solidFill>
+                <a:latin typeface="Courier New" pitchFamily="34" charset="0"/>
+                <a:ea typeface="Courier New" pitchFamily="34" charset="-122"/>
+                <a:cs typeface="Courier New" pitchFamily="34" charset="-120"/>
+              </a:rPr>
+              <a:t>dnf install ./otelcol-contrib_${V}_linux_amd64.rpm</a:t>
+            </a:r>
+            <a:endParaRPr lang="en-US" sz="870" dirty="0"/>
+          </a:p>
+        </p:txBody>
+      </p:sp>
+      <p:sp>
+        <p:nvSpPr>
+          <p:cNvPr id="12" name="Text 10"/>
+          <p:cNvSpPr txBox="1"/>
+          <p:nvPr/>
+        </p:nvSpPr>
+        <p:spPr>
+          <a:xfrm>
+            <a:off x="1223585" y="4768266"/>
+            <a:ext cx="9801978" cy="1001954"/>
+          </a:xfrm>
+          <a:prstGeom prst="rect">
+            <a:avLst/>
+          </a:prstGeom>
+          <a:noFill/>
+          <a:ln/>
+        </p:spPr>
+        <p:txBody>
+          <a:bodyPr wrap="square" lIns="0" tIns="0" rIns="0" bIns="0" rtlCol="0" anchor="t"/>
+          <a:lstStyle/>
+          <a:p>
+            <a:pPr algn="l" indent="0" marL="0">
+              <a:lnSpc>
+                <a:spcPts val="2610"/>
+              </a:lnSpc>
+              <a:buNone/>
+            </a:pPr>
+            <a:r>
+              <a:rPr lang="en-US" sz="1740" dirty="0">
+                <a:solidFill>
+                  <a:srgbClr val="5A6D7A"/>
+                </a:solidFill>
+                <a:latin typeface="Arial" pitchFamily="34" charset="0"/>
+                <a:ea typeface="Arial" pitchFamily="34" charset="-122"/>
+                <a:cs typeface="Arial" pitchFamily="34" charset="-120"/>
+              </a:rPr>
+              <a:t>The package installs a systemd service with the name </a:t>
+            </a:r>
+            <a:pPr algn="l" indent="0" marL="0">
+              <a:lnSpc>
+                <a:spcPts val="2610"/>
+              </a:lnSpc>
+              <a:buNone/>
+            </a:pPr>
+            <a:r>
+              <a:rPr lang="en-US" sz="1530" dirty="0">
+                <a:solidFill>
+                  <a:srgbClr val="5A6D7A"/>
+                </a:solidFill>
+                <a:highlight>
+                  <a:srgbClr val="E1F0F7"/>
+                </a:highlight>
+                <a:latin typeface="Courier New" pitchFamily="34" charset="0"/>
+                <a:ea typeface="Courier New" pitchFamily="34" charset="-122"/>
+                <a:cs typeface="Courier New" pitchFamily="34" charset="-120"/>
+              </a:rPr>
+              <a:t>otelcol-contrib</a:t>
+            </a:r>
+            <a:pPr algn="l" indent="0" marL="0">
+              <a:lnSpc>
+                <a:spcPts val="2610"/>
+              </a:lnSpc>
+              <a:buNone/>
+            </a:pPr>
+            <a:r>
+              <a:rPr lang="en-US" sz="1740" dirty="0">
+                <a:solidFill>
+                  <a:srgbClr val="5A6D7A"/>
+                </a:solidFill>
+                <a:latin typeface="Arial" pitchFamily="34" charset="0"/>
+                <a:ea typeface="Arial" pitchFamily="34" charset="-122"/>
+                <a:cs typeface="Arial" pitchFamily="34" charset="-120"/>
+              </a:rPr>
+              <a:t> and the configuration file </a:t>
+            </a:r>
+            <a:pPr algn="l" indent="0" marL="0">
+              <a:lnSpc>
+                <a:spcPts val="2610"/>
+              </a:lnSpc>
+              <a:buNone/>
+            </a:pPr>
+            <a:r>
+              <a:rPr lang="en-US" sz="1530" dirty="0">
+                <a:solidFill>
+                  <a:srgbClr val="5A6D7A"/>
+                </a:solidFill>
+                <a:highlight>
+                  <a:srgbClr val="E1F0F7"/>
+                </a:highlight>
+                <a:latin typeface="Courier New" pitchFamily="34" charset="0"/>
+                <a:ea typeface="Courier New" pitchFamily="34" charset="-122"/>
+                <a:cs typeface="Courier New" pitchFamily="34" charset="-120"/>
+              </a:rPr>
+              <a:t>/etc/otelcol-contrib/config.yaml</a:t>
+            </a:r>
+            <a:pPr algn="l" indent="0" marL="0">
+              <a:lnSpc>
+                <a:spcPts val="2610"/>
+              </a:lnSpc>
+              <a:buNone/>
+            </a:pPr>
+            <a:r>
+              <a:rPr lang="en-US" sz="1740" dirty="0">
+                <a:solidFill>
+                  <a:srgbClr val="5A6D7A"/>
+                </a:solidFill>
+                <a:latin typeface="Arial" pitchFamily="34" charset="0"/>
+                <a:ea typeface="Arial" pitchFamily="34" charset="-122"/>
+                <a:cs typeface="Arial" pitchFamily="34" charset="-120"/>
+              </a:rPr>
+              <a:t>. The package starts the service, and the service listens on port 4318 for the records from Moodle.</a:t>
+            </a:r>
+            <a:endParaRPr lang="en-US" sz="1740" dirty="0"/>
+          </a:p>
+        </p:txBody>
+      </p:sp>
+      <p:sp>
+        <p:nvSpPr>
+          <p:cNvPr id="13" name="Text 11"/>
+          <p:cNvSpPr txBox="1"/>
+          <p:nvPr/>
+        </p:nvSpPr>
+        <p:spPr>
+          <a:xfrm>
+            <a:off x="647700" y="6464708"/>
+            <a:ext cx="948928" cy="142875"/>
+          </a:xfrm>
+          <a:prstGeom prst="rect">
+            <a:avLst/>
+          </a:prstGeom>
+          <a:noFill/>
+          <a:ln/>
+        </p:spPr>
+        <p:txBody>
+          <a:bodyPr wrap="none" lIns="0" tIns="0" rIns="0" bIns="0" rtlCol="0" anchor="t"/>
+          <a:lstStyle/>
+          <a:p>
+            <a:pPr algn="l" indent="0" marL="0">
+              <a:lnSpc>
+                <a:spcPts val="1050"/>
+              </a:lnSpc>
+              <a:buNone/>
+            </a:pPr>
+            <a:r>
+              <a:rPr lang="en-US" sz="870" dirty="0">
+                <a:solidFill>
+                  <a:srgbClr val="8496A2"/>
+                </a:solidFill>
+                <a:latin typeface="Courier New" pitchFamily="34" charset="0"/>
+                <a:ea typeface="Courier New" pitchFamily="34" charset="-122"/>
+                <a:cs typeface="Courier New" pitchFamily="34" charset="-120"/>
+              </a:rPr>
+              <a:t>Walk-through</a:t>
+            </a:r>
+            <a:endParaRPr lang="en-US" sz="870" dirty="0"/>
+          </a:p>
+        </p:txBody>
+      </p:sp>
+      <p:sp>
+        <p:nvSpPr>
+          <p:cNvPr id="14" name="Text 12"/>
+          <p:cNvSpPr txBox="1"/>
+          <p:nvPr/>
+        </p:nvSpPr>
+        <p:spPr>
+          <a:xfrm>
+            <a:off x="11024146" y="6464708"/>
+            <a:ext cx="577304" cy="142875"/>
+          </a:xfrm>
+          <a:prstGeom prst="rect">
+            <a:avLst/>
+          </a:prstGeom>
+          <a:noFill/>
+          <a:ln/>
+        </p:spPr>
+        <p:txBody>
+          <a:bodyPr wrap="none" lIns="0" tIns="0" rIns="0" bIns="0" rtlCol="0" anchor="t"/>
+          <a:lstStyle/>
+          <a:p>
+            <a:pPr algn="l" indent="0" marL="0">
+              <a:lnSpc>
+                <a:spcPts val="1050"/>
+              </a:lnSpc>
+              <a:buNone/>
+            </a:pPr>
+            <a:r>
+              <a:rPr lang="en-US" sz="870" dirty="0">
+                <a:solidFill>
+                  <a:srgbClr val="8496A2"/>
+                </a:solidFill>
+                <a:latin typeface="Courier New" pitchFamily="34" charset="0"/>
+                <a:ea typeface="Courier New" pitchFamily="34" charset="-122"/>
+                <a:cs typeface="Courier New" pitchFamily="34" charset="-120"/>
+              </a:rPr>
               <a:t>21 / 39</a:t>
             </a:r>
-            <a:endParaRPr lang="en-US" sz="900" dirty="0"/>
+            <a:endParaRPr lang="en-US" sz="870" dirty="0"/>
           </a:p>
         </p:txBody>
       </p:sp>
@@ -20076,7 +20076,7 @@
                 <a:ea typeface="Arial" pitchFamily="34" charset="-122"/>
                 <a:cs typeface="Arial" pitchFamily="34" charset="-120"/>
               </a:rPr>
-              <a:t>A search shows the hour when failed logins spiked</a:t>
+              <a:t>Count the failed logins per hour to find a spike</a:t>
             </a:r>
             <a:endParaRPr lang="en-US" sz="3060" dirty="0"/>
           </a:p>
@@ -20571,7 +20571,7 @@
       </p:sp>
       <p:pic>
         <p:nvPicPr>
-          <p:cNvPr id="3" name="Image 0" descr="OpenSearch Dashboards showing a dashboard named Moodle events with six panels over seven days: events per hour with a daytime pattern, logins per hour, failed logins per hour with one burst, totals of 3,143 events and 101 users seen, events per course, and a bar chart of event types.">    </p:cNvPr>
+          <p:cNvPr id="3" name="Image 0" descr="OpenSearch Dashboards showing the dashboard Moodle events for the last 30 minutes: events per minute, logins per minute with a success line and a failure line that jumps to 10 in one minute, totals of 111 events and 2 users seen, a table of usernames with failed logins (admin 15, student 1, teacher 1), event types, and the first rows of the latest events list.">    </p:cNvPr>
           <p:cNvPicPr>
             <a:picLocks noChangeAspect="1"/>
           </p:cNvPicPr>
@@ -20713,7 +20713,7 @@
                 <a:ea typeface="Arial" pitchFamily="34" charset="-122"/>
                 <a:cs typeface="Arial" pitchFamily="34" charset="-120"/>
               </a:rPr>
-              <a:t>You build each chart once, and it updates when new events arrive. The picture shows six example charts with seven days of data from the demo site.</a:t>
+              <a:t>You build each chart once, and it updates when new events arrive. The picture shows the demo dashboard after 30 minutes of use, with logins, course views and a burst of failed logins.</a:t>
             </a:r>
             <a:endParaRPr lang="en-US" sz="1720" dirty="0"/>
           </a:p>
@@ -21163,7 +21163,7 @@
                 <a:ea typeface="Courier New" pitchFamily="34" charset="-122"/>
                 <a:cs typeface="Courier New" pitchFamily="34" charset="-120"/>
               </a:rPr>
-              <a:t>THE PROBLEM</a:t>
+              <a:t>THE LOG TABLE</a:t>
             </a:r>
             <a:endParaRPr lang="en-US" sz="980" dirty="0"/>
           </a:p>
@@ -21584,7 +21584,7 @@
                 <a:ea typeface="Arial" pitchFamily="34" charset="-122"/>
                 <a:cs typeface="Arial" pitchFamily="34" charset="-120"/>
               </a:rPr>
-              <a:t>, read that table directly.</a:t>
+              <a:t>, use this table.</a:t>
             </a:r>
             <a:endParaRPr lang="en-US" sz="1730" dirty="0"/>
           </a:p>
@@ -21641,7 +21641,7 @@
         <p:spPr>
           <a:xfrm>
             <a:off x="647700" y="6464379"/>
-            <a:ext cx="874663" cy="148590"/>
+            <a:ext cx="1023193" cy="148590"/>
           </a:xfrm>
           <a:prstGeom prst="rect">
             <a:avLst/>
@@ -21668,7 +21668,7 @@
                 <a:ea typeface="Courier New" pitchFamily="34" charset="-122"/>
                 <a:cs typeface="Courier New" pitchFamily="34" charset="-120"/>
               </a:rPr>
-              <a:t>The problem</a:t>
+              <a:t>The log table</a:t>
             </a:r>
             <a:endParaRPr lang="en-US" sz="980" dirty="0"/>
           </a:p>
@@ -22855,7 +22855,7 @@
                 <a:ea typeface="Arial" pitchFamily="34" charset="-122"/>
                 <a:cs typeface="Arial" pitchFamily="34" charset="-120"/>
               </a:rPr>
-              <a:t>An index in OpenSearch is stored on disk as one or more pieces called shards. By default one data server accepts at most 1000 shards, and every new index counts against that limit.</a:t>
+              <a:t>An index in OpenSearch is stored on disk as one or more pieces called shards. By default one data server accepts at most 1000 shards, and every new index brings the server closer to that limit.</a:t>
             </a:r>
             <a:endParaRPr lang="en-US" sz="1560" dirty="0"/>
           </a:p>
@@ -27476,7 +27476,7 @@
                           <a:ea typeface="Arial" pitchFamily="34" charset="-122"/>
                           <a:cs typeface="Arial" pitchFamily="34" charset="-120"/>
                         </a:rPr>
-                        <a:t>Loads the dashboard "Moodle events" with six charts into OpenSearch Dashboards.</a:t>
+                        <a:t>Loads the dashboard "Moodle events" with five charts and one list into OpenSearch Dashboards.</a:t>
                       </a:r>
                       <a:endParaRPr lang="en-US" sz="1200" dirty="0"/>
                     </a:p>
@@ -28542,7 +28542,7 @@
       </p:sp>
       <p:pic>
         <p:nvPicPr>
-          <p:cNvPr id="3" name="Image 0" descr="OpenSearch Dashboards Discover on the otel-v1-logs-* index pattern, last seven days: a histogram of events per three hours with a daytime pattern, then a table of 3,143 results with the columns time, body, event name, user id, course id and crud; the first rows are a course module viewed and a logout.">    </p:cNvPr>
+          <p:cNvPr id="3" name="Image 0" descr="OpenSearch Dashboards Discover on the otel-v1-logs-* index pattern, last 30 minutes: a histogram of events per 30 seconds, then a table of 102 results with the columns time, body, event name, user id, course id and crud; the first rows are course views, a dashboard view and a login by the user with id 2.">    </p:cNvPr>
           <p:cNvPicPr>
             <a:picLocks noChangeAspect="1"/>
           </p:cNvPicPr>
@@ -28556,8 +28556,8 @@
         </p:blipFill>
         <p:spPr>
           <a:xfrm>
-            <a:off x="959343" y="1475055"/>
-            <a:ext cx="10291274" cy="4127230"/>
+            <a:off x="1368510" y="1400046"/>
+            <a:ext cx="9471510" cy="4218685"/>
           </a:xfrm>
           <a:prstGeom prst="rect">
             <a:avLst/>
@@ -28572,8 +28572,8 @@
         </p:nvSpPr>
         <p:spPr>
           <a:xfrm>
-            <a:off x="959343" y="512966"/>
-            <a:ext cx="10330465" cy="175150"/>
+            <a:off x="1368510" y="514591"/>
+            <a:ext cx="9512130" cy="161220"/>
           </a:xfrm>
           <a:prstGeom prst="rect">
             <a:avLst/>
@@ -28587,12 +28587,12 @@
           <a:p>
             <a:pPr algn="l" indent="0" marL="0">
               <a:lnSpc>
-                <a:spcPts val="1380"/>
-              </a:lnSpc>
-              <a:buNone/>
-            </a:pPr>
-            <a:r>
-              <a:rPr lang="en-US" sz="920" spc="150" kern="0" dirty="0">
+                <a:spcPts val="1270"/>
+              </a:lnSpc>
+              <a:buNone/>
+            </a:pPr>
+            <a:r>
+              <a:rPr lang="en-US" sz="850" spc="140" kern="0" dirty="0">
                 <a:solidFill>
                   <a:srgbClr val="0B6E99"/>
                 </a:solidFill>
@@ -28602,7 +28602,7 @@
               </a:rPr>
               <a:t>DEMO · IN PICTURES</a:t>
             </a:r>
-            <a:endParaRPr lang="en-US" sz="920" dirty="0"/>
+            <a:endParaRPr lang="en-US" sz="850" dirty="0"/>
           </a:p>
         </p:txBody>
       </p:sp>
@@ -28614,8 +28614,8 @@
         </p:nvSpPr>
         <p:spPr>
           <a:xfrm>
-            <a:off x="959343" y="834236"/>
-            <a:ext cx="10330465" cy="407427"/>
+            <a:off x="1368510" y="810272"/>
+            <a:ext cx="9512130" cy="375023"/>
           </a:xfrm>
           <a:prstGeom prst="rect">
             <a:avLst/>
@@ -28629,12 +28629,12 @@
           <a:p>
             <a:pPr algn="l" indent="0" marL="0">
               <a:lnSpc>
-                <a:spcPts val="3210"/>
-              </a:lnSpc>
-              <a:buNone/>
-            </a:pPr>
-            <a:r>
-              <a:rPr lang="en-US" sz="2970" b="1" spc="-60" kern="0" dirty="0">
+                <a:spcPts val="2950"/>
+              </a:lnSpc>
+              <a:buNone/>
+            </a:pPr>
+            <a:r>
+              <a:rPr lang="en-US" sz="2730" b="1" spc="-50" kern="0" dirty="0">
                 <a:solidFill>
                   <a:srgbClr val="101A22"/>
                 </a:solidFill>
@@ -28644,7 +28644,7 @@
               </a:rPr>
               <a:t>Discover shows one row for each Moodle event</a:t>
             </a:r>
-            <a:endParaRPr lang="en-US" sz="2970" dirty="0"/>
+            <a:endParaRPr lang="en-US" sz="2730" dirty="0"/>
           </a:p>
         </p:txBody>
       </p:sp>
@@ -28656,8 +28656,8 @@
         </p:nvSpPr>
         <p:spPr>
           <a:xfrm>
-            <a:off x="959343" y="5671207"/>
-            <a:ext cx="10330465" cy="140120"/>
+            <a:off x="1368510" y="5682164"/>
+            <a:ext cx="9512130" cy="128976"/>
           </a:xfrm>
           <a:prstGeom prst="rect">
             <a:avLst/>
@@ -28671,12 +28671,12 @@
           <a:p>
             <a:pPr algn="l" indent="0" marL="0">
               <a:lnSpc>
-                <a:spcPts val="1100"/>
-              </a:lnSpc>
-              <a:buNone/>
-            </a:pPr>
-            <a:r>
-              <a:rPr lang="en-US" sz="920" dirty="0">
+                <a:spcPts val="1020"/>
+              </a:lnSpc>
+              <a:buNone/>
+            </a:pPr>
+            <a:r>
+              <a:rPr lang="en-US" sz="850" dirty="0">
                 <a:solidFill>
                   <a:srgbClr val="5A6D7A"/>
                 </a:solidFill>
@@ -28686,7 +28686,7 @@
               </a:rPr>
               <a:t>The table shows the time, the body and four attributes of each event.</a:t>
             </a:r>
-            <a:endParaRPr lang="en-US" sz="920" dirty="0"/>
+            <a:endParaRPr lang="en-US" sz="850" dirty="0"/>
           </a:p>
         </p:txBody>
       </p:sp>
@@ -28698,7 +28698,7 @@
         </p:nvSpPr>
         <p:spPr>
           <a:xfrm>
-            <a:off x="647700" y="6464556"/>
+            <a:off x="647700" y="6464788"/>
             <a:ext cx="354509" cy="142875"/>
           </a:xfrm>
           <a:prstGeom prst="rect">
@@ -28713,12 +28713,12 @@
           <a:p>
             <a:pPr algn="l" indent="0" marL="0">
               <a:lnSpc>
-                <a:spcPts val="1100"/>
-              </a:lnSpc>
-              <a:buNone/>
-            </a:pPr>
-            <a:r>
-              <a:rPr lang="en-US" sz="920" dirty="0">
+                <a:spcPts val="1020"/>
+              </a:lnSpc>
+              <a:buNone/>
+            </a:pPr>
+            <a:r>
+              <a:rPr lang="en-US" sz="850" dirty="0">
                 <a:solidFill>
                   <a:srgbClr val="8496A2"/>
                 </a:solidFill>
@@ -28728,7 +28728,7 @@
               </a:rPr>
               <a:t>Demo</a:t>
             </a:r>
-            <a:endParaRPr lang="en-US" sz="920" dirty="0"/>
+            <a:endParaRPr lang="en-US" sz="850" dirty="0"/>
           </a:p>
         </p:txBody>
       </p:sp>
@@ -28740,7 +28740,7 @@
         </p:nvSpPr>
         <p:spPr>
           <a:xfrm>
-            <a:off x="11024146" y="6464556"/>
+            <a:off x="11024146" y="6464788"/>
             <a:ext cx="577304" cy="142875"/>
           </a:xfrm>
           <a:prstGeom prst="rect">
@@ -28755,12 +28755,12 @@
           <a:p>
             <a:pPr algn="l" indent="0" marL="0">
               <a:lnSpc>
-                <a:spcPts val="1100"/>
-              </a:lnSpc>
-              <a:buNone/>
-            </a:pPr>
-            <a:r>
-              <a:rPr lang="en-US" sz="920" dirty="0">
+                <a:spcPts val="1020"/>
+              </a:lnSpc>
+              <a:buNone/>
+            </a:pPr>
+            <a:r>
+              <a:rPr lang="en-US" sz="850" dirty="0">
                 <a:solidFill>
                   <a:srgbClr val="8496A2"/>
                 </a:solidFill>
@@ -28770,7 +28770,7 @@
               </a:rPr>
               <a:t>38 / 39</a:t>
             </a:r>
-            <a:endParaRPr lang="en-US" sz="920" dirty="0"/>
+            <a:endParaRPr lang="en-US" sz="850" dirty="0"/>
           </a:p>
         </p:txBody>
       </p:sp>
@@ -29812,7 +29812,7 @@
                 <a:ea typeface="Courier New" pitchFamily="34" charset="-122"/>
                 <a:cs typeface="Courier New" pitchFamily="34" charset="-120"/>
               </a:rPr>
-              <a:t>THE PROBLEM</a:t>
+              <a:t>THE LOG TABLE</a:t>
             </a:r>
             <a:endParaRPr lang="en-US" sz="980" dirty="0"/>
           </a:p>
@@ -30215,7 +30215,7 @@
         <p:spPr>
           <a:xfrm>
             <a:off x="647700" y="6464379"/>
-            <a:ext cx="874663" cy="148590"/>
+            <a:ext cx="1023193" cy="148590"/>
           </a:xfrm>
           <a:prstGeom prst="rect">
             <a:avLst/>
@@ -30242,7 +30242,7 @@
                 <a:ea typeface="Courier New" pitchFamily="34" charset="-122"/>
                 <a:cs typeface="Courier New" pitchFamily="34" charset="-120"/>
               </a:rPr>
-              <a:t>The problem</a:t>
+              <a:t>The log table</a:t>
             </a:r>
             <a:endParaRPr lang="en-US" sz="980" dirty="0"/>
           </a:p>
@@ -30705,7 +30705,7 @@
                 <a:ea typeface="Arial" pitchFamily="34" charset="-122"/>
                 <a:cs typeface="Arial" pitchFamily="34" charset="-120"/>
               </a:rPr>
-              <a:t>every web request · every CLI run · every scheduled task · every adhoc task · every web service call</a:t>
+              <a:t>Each web request, CLI run, scheduled task, adhoc task and web service call gets its own timing.</a:t>
             </a:r>
             <a:endParaRPr lang="en-US" sz="1280" dirty="0"/>
           </a:p>
@@ -30719,6 +30719,48 @@
         </p:nvSpPr>
         <p:spPr>
           <a:xfrm>
+            <a:off x="647700" y="3283238"/>
+            <a:ext cx="10953750" cy="314325"/>
+          </a:xfrm>
+          <a:prstGeom prst="rect">
+            <a:avLst/>
+          </a:prstGeom>
+          <a:noFill/>
+          <a:ln/>
+        </p:spPr>
+        <p:txBody>
+          <a:bodyPr wrap="none" lIns="0" tIns="0" rIns="0" bIns="0" rtlCol="0" anchor="t"/>
+          <a:lstStyle/>
+          <a:p>
+            <a:pPr algn="l" indent="0" marL="0">
+              <a:lnSpc>
+                <a:spcPts val="2480"/>
+              </a:lnSpc>
+              <a:buNone/>
+            </a:pPr>
+            <a:r>
+              <a:rPr lang="en-US" sz="1650" dirty="0">
+                <a:solidFill>
+                  <a:srgbClr val="5A6D7A"/>
+                </a:solidFill>
+                <a:latin typeface="Arial" pitchFamily="34" charset="0"/>
+                <a:ea typeface="Arial" pitchFamily="34" charset="-122"/>
+                <a:cs typeface="Arial" pitchFamily="34" charset="-120"/>
+              </a:rPr>
+              <a:t>Moodle added official OpenTelemetry support in version 5.2. Moodle 5.1 and older versions do not have it.</a:t>
+            </a:r>
+            <a:endParaRPr lang="en-US" sz="1650" dirty="0"/>
+          </a:p>
+        </p:txBody>
+      </p:sp>
+      <p:sp>
+        <p:nvSpPr>
+          <p:cNvPr id="12" name="Text 10"/>
+          <p:cNvSpPr txBox="1"/>
+          <p:nvPr/>
+        </p:nvSpPr>
+        <p:spPr>
+          <a:xfrm>
             <a:off x="647700" y="6464379"/>
             <a:ext cx="1320403" cy="148590"/>
           </a:xfrm>
@@ -30755,7 +30797,7 @@
       </p:sp>
       <p:sp>
         <p:nvSpPr>
-          <p:cNvPr id="12" name="Text 10"/>
+          <p:cNvPr id="13" name="Text 11"/>
           <p:cNvSpPr txBox="1"/>
           <p:nvPr/>
         </p:nvSpPr>
@@ -30835,12 +30877,12 @@
         </p:nvSpPr>
         <p:spPr>
           <a:xfrm>
-            <a:off x="691286" y="5209227"/>
-            <a:ext cx="2634739" cy="448818"/>
+            <a:off x="993122" y="5242494"/>
+            <a:ext cx="2487597" cy="423753"/>
           </a:xfrm>
           <a:prstGeom prst="roundRect">
             <a:avLst>
-              <a:gd name="adj" fmla="val 68627"/>
+              <a:gd name="adj" fmla="val 72717"/>
             </a:avLst>
           </a:prstGeom>
           <a:solidFill>
@@ -30892,18 +30934,18 @@
           </p:nvPr>
         </p:nvGraphicFramePr>
         <p:xfrm>
-          <a:off x="691286" y="2969862"/>
-          <a:ext cx="10809429" cy="914400"/>
+          <a:off x="993122" y="3128190"/>
+          <a:ext cx="10205756" cy="914400"/>
         </p:xfrm>
         <a:graphic>
           <a:graphicData uri="http://schemas.openxmlformats.org/drawingml/2006/table">
             <a:tbl>
               <a:tblPr/>
               <a:tblGrid>
-                <a:gridCol w="2481639"/>
-                <a:gridCol w="8327789"/>
+                <a:gridCol w="2343047"/>
+                <a:gridCol w="7862709"/>
               </a:tblGrid>
-              <a:tr h="429920">
+              <a:tr h="405911">
                 <a:tc>
                   <a:txBody>
                     <a:bodyPr/>
@@ -30911,12 +30953,12 @@
                     <a:p>
                       <a:pPr algn="l" indent="0" marL="0">
                         <a:lnSpc>
-                          <a:spcPts val="1520"/>
+                          <a:spcPts val="1430"/>
                         </a:lnSpc>
                         <a:buNone/>
                       </a:pPr>
                       <a:r>
-                        <a:rPr lang="en-US" sz="1260" dirty="0">
+                        <a:rPr lang="en-US" sz="1190" dirty="0">
                           <a:solidFill>
                             <a:srgbClr val="0B6E99"/>
                           </a:solidFill>
@@ -30929,7 +30971,7 @@
                       <a:endParaRPr lang="en-US" sz="1200" dirty="0"/>
                     </a:p>
                   </a:txBody>
-                  <a:tcPr marL="132283" marR="132283" marT="113386" marB="113386" anchor="t">
+                  <a:tcPr marL="124949" marR="124949" marT="107099" marB="107099" anchor="t">
                     <a:lnL w="0" cap="flat" cmpd="sng" algn="ctr">
                       <a:noFill/>
                     </a:lnL>
@@ -30957,12 +30999,12 @@
                     <a:p>
                       <a:pPr algn="l" indent="0" marL="0">
                         <a:lnSpc>
-                          <a:spcPts val="1610"/>
+                          <a:spcPts val="1520"/>
                         </a:lnSpc>
                         <a:buNone/>
                       </a:pPr>
                       <a:r>
-                        <a:rPr lang="en-US" sz="1340" dirty="0">
+                        <a:rPr lang="en-US" sz="1260" dirty="0">
                           <a:solidFill>
                             <a:srgbClr val="101A22"/>
                           </a:solidFill>
@@ -30975,7 +31017,7 @@
                       <a:endParaRPr lang="en-US" sz="1200" dirty="0"/>
                     </a:p>
                   </a:txBody>
-                  <a:tcPr marL="132283" marR="132283" marT="113386" marB="113386" anchor="t">
+                  <a:tcPr marL="124949" marR="124949" marT="107099" marB="107099" anchor="t">
                     <a:lnL w="0" cap="flat" cmpd="sng" algn="ctr">
                       <a:noFill/>
                     </a:lnL>
@@ -30997,7 +31039,7 @@
                   </a:tcPr>
                 </a:tc>
               </a:tr>
-              <a:tr h="434645">
+              <a:tr h="410371">
                 <a:tc>
                   <a:txBody>
                     <a:bodyPr/>
@@ -31005,12 +31047,12 @@
                     <a:p>
                       <a:pPr algn="l" indent="0" marL="0">
                         <a:lnSpc>
-                          <a:spcPts val="1520"/>
+                          <a:spcPts val="1430"/>
                         </a:lnSpc>
                         <a:buNone/>
                       </a:pPr>
                       <a:r>
-                        <a:rPr lang="en-US" sz="1260" dirty="0">
+                        <a:rPr lang="en-US" sz="1190" dirty="0">
                           <a:solidFill>
                             <a:srgbClr val="0B6E99"/>
                           </a:solidFill>
@@ -31023,7 +31065,7 @@
                       <a:endParaRPr lang="en-US" sz="1200" dirty="0"/>
                     </a:p>
                   </a:txBody>
-                  <a:tcPr marL="132283" marR="132283" marT="113386" marB="113386" anchor="t">
+                  <a:tcPr marL="124949" marR="124949" marT="107099" marB="107099" anchor="t">
                     <a:lnL w="0" cap="flat" cmpd="sng" algn="ctr">
                       <a:noFill/>
                     </a:lnL>
@@ -31051,12 +31093,12 @@
                     <a:p>
                       <a:pPr algn="l" indent="0" marL="0">
                         <a:lnSpc>
-                          <a:spcPts val="1610"/>
+                          <a:spcPts val="1520"/>
                         </a:lnSpc>
                         <a:buNone/>
                       </a:pPr>
                       <a:r>
-                        <a:rPr lang="en-US" sz="1340" dirty="0">
+                        <a:rPr lang="en-US" sz="1260" dirty="0">
                           <a:solidFill>
                             <a:srgbClr val="101A22"/>
                           </a:solidFill>
@@ -31069,7 +31111,7 @@
                       <a:endParaRPr lang="en-US" sz="1200" dirty="0"/>
                     </a:p>
                   </a:txBody>
-                  <a:tcPr marL="132283" marR="132283" marT="113386" marB="113386" anchor="t">
+                  <a:tcPr marL="124949" marR="124949" marT="107099" marB="107099" anchor="t">
                     <a:lnL w="0" cap="flat" cmpd="sng" algn="ctr">
                       <a:noFill/>
                     </a:lnL>
@@ -31091,7 +31133,7 @@
                   </a:tcPr>
                 </a:tc>
               </a:tr>
-              <a:tr h="434645">
+              <a:tr h="410371">
                 <a:tc>
                   <a:txBody>
                     <a:bodyPr/>
@@ -31099,12 +31141,12 @@
                     <a:p>
                       <a:pPr algn="l" indent="0" marL="0">
                         <a:lnSpc>
-                          <a:spcPts val="1520"/>
+                          <a:spcPts val="1430"/>
                         </a:lnSpc>
                         <a:buNone/>
                       </a:pPr>
                       <a:r>
-                        <a:rPr lang="en-US" sz="1260" dirty="0">
+                        <a:rPr lang="en-US" sz="1190" dirty="0">
                           <a:solidFill>
                             <a:srgbClr val="0B6E99"/>
                           </a:solidFill>
@@ -31117,7 +31159,7 @@
                       <a:endParaRPr lang="en-US" sz="1200" dirty="0"/>
                     </a:p>
                   </a:txBody>
-                  <a:tcPr marL="132283" marR="132283" marT="113386" marB="113386" anchor="t">
+                  <a:tcPr marL="124949" marR="124949" marT="107099" marB="107099" anchor="t">
                     <a:lnL w="0" cap="flat" cmpd="sng" algn="ctr">
                       <a:noFill/>
                     </a:lnL>
@@ -31145,12 +31187,12 @@
                     <a:p>
                       <a:pPr algn="l" indent="0" marL="0">
                         <a:lnSpc>
-                          <a:spcPts val="1610"/>
+                          <a:spcPts val="1520"/>
                         </a:lnSpc>
                         <a:buNone/>
                       </a:pPr>
                       <a:r>
-                        <a:rPr lang="en-US" sz="1340" dirty="0">
+                        <a:rPr lang="en-US" sz="1260" dirty="0">
                           <a:solidFill>
                             <a:srgbClr val="101A22"/>
                           </a:solidFill>
@@ -31163,7 +31205,7 @@
                       <a:endParaRPr lang="en-US" sz="1200" dirty="0"/>
                     </a:p>
                   </a:txBody>
-                  <a:tcPr marL="132283" marR="132283" marT="113386" marB="113386" anchor="t">
+                  <a:tcPr marL="124949" marR="124949" marT="107099" marB="107099" anchor="t">
                     <a:lnL w="0" cap="flat" cmpd="sng" algn="ctr">
                       <a:noFill/>
                     </a:lnL>
@@ -31185,7 +31227,7 @@
                   </a:tcPr>
                 </a:tc>
               </a:tr>
-              <a:tr h="434645">
+              <a:tr h="410371">
                 <a:tc>
                   <a:txBody>
                     <a:bodyPr/>
@@ -31193,12 +31235,12 @@
                     <a:p>
                       <a:pPr algn="l" indent="0" marL="0">
                         <a:lnSpc>
-                          <a:spcPts val="1520"/>
+                          <a:spcPts val="1430"/>
                         </a:lnSpc>
                         <a:buNone/>
                       </a:pPr>
                       <a:r>
-                        <a:rPr lang="en-US" sz="1260" dirty="0">
+                        <a:rPr lang="en-US" sz="1190" dirty="0">
                           <a:solidFill>
                             <a:srgbClr val="0B6E99"/>
                           </a:solidFill>
@@ -31211,7 +31253,7 @@
                       <a:endParaRPr lang="en-US" sz="1200" dirty="0"/>
                     </a:p>
                   </a:txBody>
-                  <a:tcPr marL="132283" marR="132283" marT="113386" marB="113386" anchor="t">
+                  <a:tcPr marL="124949" marR="124949" marT="107099" marB="107099" anchor="t">
                     <a:lnL w="0" cap="flat" cmpd="sng" algn="ctr">
                       <a:noFill/>
                     </a:lnL>
@@ -31239,12 +31281,12 @@
                     <a:p>
                       <a:pPr algn="l" indent="0" marL="0">
                         <a:lnSpc>
-                          <a:spcPts val="1610"/>
+                          <a:spcPts val="1520"/>
                         </a:lnSpc>
                         <a:buNone/>
                       </a:pPr>
                       <a:r>
-                        <a:rPr lang="en-US" sz="1340" dirty="0">
+                        <a:rPr lang="en-US" sz="1260" dirty="0">
                           <a:solidFill>
                             <a:srgbClr val="101A22"/>
                           </a:solidFill>
@@ -31257,7 +31299,7 @@
                       <a:endParaRPr lang="en-US" sz="1200" dirty="0"/>
                     </a:p>
                   </a:txBody>
-                  <a:tcPr marL="132283" marR="132283" marT="113386" marB="113386" anchor="t">
+                  <a:tcPr marL="124949" marR="124949" marT="107099" marB="107099" anchor="t">
                     <a:lnL w="0" cap="flat" cmpd="sng" algn="ctr">
                       <a:noFill/>
                     </a:lnL>
@@ -31291,8 +31333,8 @@
         </p:nvSpPr>
         <p:spPr>
           <a:xfrm>
-            <a:off x="691286" y="511904"/>
-            <a:ext cx="10866579" cy="184252"/>
+            <a:off x="993122" y="513096"/>
+            <a:ext cx="10262906" cy="174036"/>
           </a:xfrm>
           <a:prstGeom prst="rect">
             <a:avLst/>
@@ -31306,12 +31348,12 @@
           <a:p>
             <a:pPr algn="l" indent="0" marL="0">
               <a:lnSpc>
-                <a:spcPts val="1450"/>
-              </a:lnSpc>
-              <a:buNone/>
-            </a:pPr>
-            <a:r>
-              <a:rPr lang="en-US" sz="970" spc="150" kern="0" dirty="0">
+                <a:spcPts val="1370"/>
+              </a:lnSpc>
+              <a:buNone/>
+            </a:pPr>
+            <a:r>
+              <a:rPr lang="en-US" sz="910" spc="150" kern="0" dirty="0">
                 <a:solidFill>
                   <a:srgbClr val="0B6E99"/>
                 </a:solidFill>
@@ -31321,7 +31363,7 @@
               </a:rPr>
               <a:t>THE SOFTWARE</a:t>
             </a:r>
-            <a:endParaRPr lang="en-US" sz="970" dirty="0"/>
+            <a:endParaRPr lang="en-US" sz="910" dirty="0"/>
           </a:p>
         </p:txBody>
       </p:sp>
@@ -31333,8 +31375,8 @@
         </p:nvSpPr>
         <p:spPr>
           <a:xfrm>
-            <a:off x="691286" y="849935"/>
-            <a:ext cx="10866579" cy="428598"/>
+            <a:off x="993122" y="832257"/>
+            <a:ext cx="10262906" cy="404835"/>
           </a:xfrm>
           <a:prstGeom prst="rect">
             <a:avLst/>
@@ -31348,12 +31390,12 @@
           <a:p>
             <a:pPr algn="l" indent="0" marL="0">
               <a:lnSpc>
-                <a:spcPts val="3370"/>
-              </a:lnSpc>
-              <a:buNone/>
-            </a:pPr>
-            <a:r>
-              <a:rPr lang="en-US" sz="3120" b="1" spc="-60" kern="0" dirty="0">
+                <a:spcPts val="3190"/>
+              </a:lnSpc>
+              <a:buNone/>
+            </a:pPr>
+            <a:r>
+              <a:rPr lang="en-US" sz="2950" b="1" spc="-60" kern="0" dirty="0">
                 <a:solidFill>
                   <a:srgbClr val="101A22"/>
                 </a:solidFill>
@@ -31363,7 +31405,7 @@
               </a:rPr>
               <a:t>OpenTelemetry sends the Moodle data to OpenSearch</a:t>
             </a:r>
-            <a:endParaRPr lang="en-US" sz="3120" dirty="0"/>
+            <a:endParaRPr lang="en-US" sz="2950" dirty="0"/>
           </a:p>
         </p:txBody>
       </p:sp>
@@ -31375,8 +31417,8 @@
         </p:nvSpPr>
         <p:spPr>
           <a:xfrm>
-            <a:off x="691286" y="1481203"/>
-            <a:ext cx="10866579" cy="737006"/>
+            <a:off x="993122" y="1428254"/>
+            <a:ext cx="10262906" cy="695847"/>
           </a:xfrm>
           <a:prstGeom prst="rect">
             <a:avLst/>
@@ -31390,12 +31432,12 @@
           <a:p>
             <a:pPr algn="l" indent="0" marL="0">
               <a:lnSpc>
-                <a:spcPts val="2900"/>
-              </a:lnSpc>
-              <a:buNone/>
-            </a:pPr>
-            <a:r>
-              <a:rPr lang="en-US" sz="1930" dirty="0">
+                <a:spcPts val="2740"/>
+              </a:lnSpc>
+              <a:buNone/>
+            </a:pPr>
+            <a:r>
+              <a:rPr lang="en-US" sz="1830" dirty="0">
                 <a:solidFill>
                   <a:srgbClr val="5A6D7A"/>
                 </a:solidFill>
@@ -31403,9 +31445,9 @@
                 <a:ea typeface="Arial" pitchFamily="34" charset="-122"/>
                 <a:cs typeface="Arial" pitchFamily="34" charset="-120"/>
               </a:rPr>
-              <a:t>OpenTelemetry is a log shipper. It is distributed as open source. It takes the data that Moodle produces, the events and the timings, and sends it to OpenSearch.</a:t>
-            </a:r>
-            <a:endParaRPr lang="en-US" sz="1930" dirty="0"/>
+              <a:t>OpenTelemetry is a log shipper. It is open source under the Apache 2.0 license. It takes the data that Moodle produces, the events and the timings, and sends it to OpenSearch.</a:t>
+            </a:r>
+            <a:endParaRPr lang="en-US" sz="1830" dirty="0"/>
           </a:p>
         </p:txBody>
       </p:sp>
@@ -31417,8 +31459,8 @@
         </p:nvSpPr>
         <p:spPr>
           <a:xfrm>
-            <a:off x="691286" y="2470492"/>
-            <a:ext cx="10866579" cy="311811"/>
+            <a:off x="993122" y="2362298"/>
+            <a:ext cx="10262906" cy="588794"/>
           </a:xfrm>
           <a:prstGeom prst="rect">
             <a:avLst/>
@@ -31427,17 +31469,17 @@
           <a:ln/>
         </p:spPr>
         <p:txBody>
-          <a:bodyPr wrap="none" lIns="0" tIns="0" rIns="0" bIns="0" rtlCol="0" anchor="t"/>
-          <a:lstStyle/>
-          <a:p>
-            <a:pPr algn="l" indent="0" marL="0">
-              <a:lnSpc>
-                <a:spcPts val="2460"/>
-              </a:lnSpc>
-              <a:buNone/>
-            </a:pPr>
-            <a:r>
-              <a:rPr lang="en-US" sz="1640" b="1" dirty="0">
+          <a:bodyPr wrap="square" lIns="0" tIns="0" rIns="0" bIns="0" rtlCol="0" anchor="t"/>
+          <a:lstStyle/>
+          <a:p>
+            <a:pPr algn="l" indent="0" marL="0">
+              <a:lnSpc>
+                <a:spcPts val="2320"/>
+              </a:lnSpc>
+              <a:buNone/>
+            </a:pPr>
+            <a:r>
+              <a:rPr lang="en-US" sz="1550" b="1" dirty="0">
                 <a:solidFill>
                   <a:srgbClr val="101A22"/>
                 </a:solidFill>
@@ -31449,12 +31491,12 @@
             </a:r>
             <a:pPr algn="l" indent="0" marL="0">
               <a:lnSpc>
-                <a:spcPts val="2460"/>
-              </a:lnSpc>
-              <a:buNone/>
-            </a:pPr>
-            <a:r>
-              <a:rPr lang="en-US" sz="1640" dirty="0">
+                <a:spcPts val="2320"/>
+              </a:lnSpc>
+              <a:buNone/>
+            </a:pPr>
+            <a:r>
+              <a:rPr lang="en-US" sz="1550" dirty="0">
                 <a:solidFill>
                   <a:srgbClr val="101A22"/>
                 </a:solidFill>
@@ -31462,9 +31504,9 @@
                 <a:ea typeface="Arial" pitchFamily="34" charset="-122"/>
                 <a:cs typeface="Arial" pitchFamily="34" charset="-120"/>
               </a:rPr>
-              <a:t> It is a family of pieces. These four appear in this talk:</a:t>
-            </a:r>
-            <a:endParaRPr lang="en-US" sz="1640" dirty="0"/>
+              <a:t> The OpenTelemetry project publishes separate programs and libraries. This talk uses these four:</a:t>
+            </a:r>
+            <a:endParaRPr lang="en-US" sz="1550" dirty="0"/>
           </a:p>
         </p:txBody>
       </p:sp>
@@ -31476,8 +31518,8 @@
         </p:nvSpPr>
         <p:spPr>
           <a:xfrm>
-            <a:off x="691286" y="4766551"/>
-            <a:ext cx="10866579" cy="311810"/>
+            <a:off x="993122" y="4824525"/>
+            <a:ext cx="10262906" cy="294523"/>
           </a:xfrm>
           <a:prstGeom prst="rect">
             <a:avLst/>
@@ -31491,12 +31533,12 @@
           <a:p>
             <a:pPr algn="l" indent="0" marL="0">
               <a:lnSpc>
-                <a:spcPts val="2460"/>
-              </a:lnSpc>
-              <a:buNone/>
-            </a:pPr>
-            <a:r>
-              <a:rPr lang="en-US" sz="1640" dirty="0">
+                <a:spcPts val="2320"/>
+              </a:lnSpc>
+              <a:buNone/>
+            </a:pPr>
+            <a:r>
+              <a:rPr lang="en-US" sz="1550" dirty="0">
                 <a:solidFill>
                   <a:srgbClr val="5A6D7A"/>
                 </a:solidFill>
@@ -31506,7 +31548,7 @@
               </a:rPr>
               <a:t>None of them stores data or displays it. That is OpenSearch's job.</a:t>
             </a:r>
-            <a:endParaRPr lang="en-US" sz="1640" dirty="0"/>
+            <a:endParaRPr lang="en-US" sz="1550" dirty="0"/>
           </a:p>
         </p:txBody>
       </p:sp>
@@ -31518,8 +31560,8 @@
         </p:nvSpPr>
         <p:spPr>
           <a:xfrm>
-            <a:off x="851916" y="5285054"/>
-            <a:ext cx="2370630" cy="240944"/>
+            <a:off x="1144846" y="5314116"/>
+            <a:ext cx="2241300" cy="227586"/>
           </a:xfrm>
           <a:prstGeom prst="rect">
             <a:avLst/>
@@ -31533,12 +31575,12 @@
           <a:p>
             <a:pPr algn="l" indent="0" marL="0">
               <a:lnSpc>
-                <a:spcPts val="1900"/>
-              </a:lnSpc>
-              <a:buNone/>
-            </a:pPr>
-            <a:r>
-              <a:rPr lang="en-US" sz="1260" dirty="0">
+                <a:spcPts val="1790"/>
+              </a:lnSpc>
+              <a:buNone/>
+            </a:pPr>
+            <a:r>
+              <a:rPr lang="en-US" sz="1190" dirty="0">
                 <a:solidFill>
                   <a:srgbClr val="0B6E99"/>
                 </a:solidFill>
@@ -31548,7 +31590,7 @@
               </a:rPr>
               <a:t>https://opentelemetry.io</a:t>
             </a:r>
-            <a:endParaRPr lang="en-US" sz="1260" dirty="0"/>
+            <a:endParaRPr lang="en-US" sz="1190" dirty="0"/>
           </a:p>
         </p:txBody>
       </p:sp>
@@ -31560,8 +31602,8 @@
         </p:nvSpPr>
         <p:spPr>
           <a:xfrm>
-            <a:off x="647700" y="6464404"/>
-            <a:ext cx="1320403" cy="147401"/>
+            <a:off x="647700" y="6464574"/>
+            <a:ext cx="1320403" cy="142875"/>
           </a:xfrm>
           <a:prstGeom prst="rect">
             <a:avLst/>
@@ -31575,12 +31617,12 @@
           <a:p>
             <a:pPr algn="l" indent="0" marL="0">
               <a:lnSpc>
-                <a:spcPts val="1160"/>
-              </a:lnSpc>
-              <a:buNone/>
-            </a:pPr>
-            <a:r>
-              <a:rPr lang="en-US" sz="970" dirty="0">
+                <a:spcPts val="1100"/>
+              </a:lnSpc>
+              <a:buNone/>
+            </a:pPr>
+            <a:r>
+              <a:rPr lang="en-US" sz="910" dirty="0">
                 <a:solidFill>
                   <a:srgbClr val="8496A2"/>
                 </a:solidFill>
@@ -31590,7 +31632,7 @@
               </a:rPr>
               <a:t>Setting the scene</a:t>
             </a:r>
-            <a:endParaRPr lang="en-US" sz="970" dirty="0"/>
+            <a:endParaRPr lang="en-US" sz="910" dirty="0"/>
           </a:p>
         </p:txBody>
       </p:sp>
@@ -31602,8 +31644,8 @@
         </p:nvSpPr>
         <p:spPr>
           <a:xfrm>
-            <a:off x="11098411" y="6464404"/>
-            <a:ext cx="503039" cy="147401"/>
+            <a:off x="11098411" y="6464574"/>
+            <a:ext cx="503039" cy="142875"/>
           </a:xfrm>
           <a:prstGeom prst="rect">
             <a:avLst/>
@@ -31617,12 +31659,12 @@
           <a:p>
             <a:pPr algn="l" indent="0" marL="0">
               <a:lnSpc>
-                <a:spcPts val="1160"/>
-              </a:lnSpc>
-              <a:buNone/>
-            </a:pPr>
-            <a:r>
-              <a:rPr lang="en-US" sz="970" dirty="0">
+                <a:spcPts val="1100"/>
+              </a:lnSpc>
+              <a:buNone/>
+            </a:pPr>
+            <a:r>
+              <a:rPr lang="en-US" sz="910" dirty="0">
                 <a:solidFill>
                   <a:srgbClr val="8496A2"/>
                 </a:solidFill>
@@ -31632,7 +31674,7 @@
               </a:rPr>
               <a:t>6 / 39</a:t>
             </a:r>
-            <a:endParaRPr lang="en-US" sz="970" dirty="0"/>
+            <a:endParaRPr lang="en-US" sz="910" dirty="0"/>
           </a:p>
         </p:txBody>
       </p:sp>

</xml_diff>

<commit_message>
Slides: speaker notes rewritten as spoken text, one sentence per line
</commit_message>
<xml_diff>
--- a/Moodle-Otel-Opensearch/presentation/moodle-otel-deck.pptx
+++ b/Moodle-Otel-Opensearch/presentation/moodle-otel-deck.pptx
@@ -540,9 +540,39 @@
           <a:p>
             <a:r>
               <a:rPr lang="en-US" dirty="0"/>
-              <a:t>~30 s. Title only. The agenda is the next slide.</a:t>
-            </a:r>
-            <a:endParaRPr lang="en-US" dirty="0"/>
+              <a:t>~30 s.
+</a:t>
+            </a:r>
+          </a:p>
+          <a:p>
+            <a:endParaRPr lang="en-US"/>
+          </a:p>
+          <a:p>
+            <a:r>
+              <a:rPr lang="en-US" dirty="0"/>
+              <a:t>• Welcome.
+</a:t>
+            </a:r>
+          </a:p>
+          <a:p>
+            <a:r>
+              <a:rPr lang="en-US" dirty="0"/>
+              <a:t>• This talk shows how to send Moodle's logs and timing data to OpenSearch with OpenTelemetry.
+</a:t>
+            </a:r>
+          </a:p>
+          <a:p>
+            <a:r>
+              <a:rPr lang="en-US" dirty="0"/>
+              <a:t>• You need Moodle 5.2 for this.
+</a:t>
+            </a:r>
+          </a:p>
+          <a:p>
+            <a:r>
+              <a:rPr lang="en-US" dirty="0"/>
+              <a:t>• The slides and all demo files are on GitHub, at the address on the slide.</a:t>
+            </a:r>
           </a:p>
         </p:txBody>
       </p:sp>
@@ -628,9 +658,116 @@
           <a:p>
             <a:r>
               <a:rPr lang="en-US" dirty="0"/>
-              <a:t>~1 min 30 s. Three statements, in this order. One: components 1 to 4 are not merely on the same server — they are inside the same PHP process, the one that runs Moodle's code. There is no deployment decision to make and nothing to install elsewhere. Two: the collector runs on the Moodle web server too, as a separate service. That is what the walk-through installs: one collector per Moodle server, talking over localhost, so the data never crosses the network on its way to the collector, and port 4318 stays closed. No extra server is needed. The other way is one shared collector on its own host for every web server you run — fewer things to configure and one place to filter personal data — the pattern we run; it needs the endpoint variable pointed at that host and port 4318 open there. Three: OpenSearch is always separate, and it is the one component most of them already have. If asked which to pick: the shared host for a small estate, one per server once traffic is large enough that you want the buffering close to the source. Two glosses to give in passing: OTLP on the arrow is simply the message format, properly defined in part two; and the reason for a relay at all is buffering — PHP hands the data off in a millisecond and gets back to serving the page, and if OpenSearch is slow or down the collector absorbs it instead of the request failing.</a:t>
-            </a:r>
-            <a:endParaRPr lang="en-US" dirty="0"/>
+              <a:t>~1 min 30 s.
+</a:t>
+            </a:r>
+          </a:p>
+          <a:p>
+            <a:endParaRPr lang="en-US"/>
+          </a:p>
+          <a:p>
+            <a:r>
+              <a:rPr lang="en-US" dirty="0"/>
+              <a:t>• Components 1 to 4 run inside the PHP process that runs Moodle.
+</a:t>
+            </a:r>
+          </a:p>
+          <a:p>
+            <a:r>
+              <a:rPr lang="en-US" dirty="0"/>
+              <a:t>• You install nothing on another server for them.
+</a:t>
+            </a:r>
+          </a:p>
+          <a:p>
+            <a:r>
+              <a:rPr lang="en-US" dirty="0"/>
+              <a:t>• The collector runs on the Moodle web server as its own service.
+</a:t>
+            </a:r>
+          </a:p>
+          <a:p>
+            <a:r>
+              <a:rPr lang="en-US" dirty="0"/>
+              <a:t>• PHP sends to it on localhost, port 4318.
+</a:t>
+            </a:r>
+          </a:p>
+          <a:p>
+            <a:r>
+              <a:rPr lang="en-US" dirty="0"/>
+              <a:t>• So that port stays closed to the network.
+</a:t>
+            </a:r>
+          </a:p>
+          <a:p>
+            <a:r>
+              <a:rPr lang="en-US" dirty="0"/>
+              <a:t>• You can also run one shared collector on its own server for all your web servers.
+</a:t>
+            </a:r>
+          </a:p>
+          <a:p>
+            <a:r>
+              <a:rPr lang="en-US" dirty="0"/>
+              <a:t>• Then you point the endpoint variable at that server and open port 4318 there.
+</a:t>
+            </a:r>
+          </a:p>
+          <a:p>
+            <a:r>
+              <a:rPr lang="en-US" dirty="0"/>
+              <a:t>• That gives you one place to filter personal data.
+</a:t>
+            </a:r>
+          </a:p>
+          <a:p>
+            <a:r>
+              <a:rPr lang="en-US" dirty="0"/>
+              <a:t>• We run it that way.
+</a:t>
+            </a:r>
+          </a:p>
+          <a:p>
+            <a:r>
+              <a:rPr lang="en-US" dirty="0"/>
+              <a:t>• OpenSearch always runs on its own server or cluster.
+</a:t>
+            </a:r>
+          </a:p>
+          <a:p>
+            <a:r>
+              <a:rPr lang="en-US" dirty="0"/>
+              <a:t>• Many of you already have one.
+</a:t>
+            </a:r>
+          </a:p>
+          <a:p>
+            <a:r>
+              <a:rPr lang="en-US" dirty="0"/>
+              <a:t>• The collector also works as a buffer.
+</a:t>
+            </a:r>
+          </a:p>
+          <a:p>
+            <a:r>
+              <a:rPr lang="en-US" dirty="0"/>
+              <a:t>• PHP hands over the data in about a millisecond and goes back to the page.
+</a:t>
+            </a:r>
+          </a:p>
+          <a:p>
+            <a:r>
+              <a:rPr lang="en-US" dirty="0"/>
+              <a:t>• When OpenSearch is slow or down, the collector holds the data.
+</a:t>
+            </a:r>
+          </a:p>
+          <a:p>
+            <a:r>
+              <a:rPr lang="en-US" dirty="0"/>
+              <a:t>? If asked which to pick: a shared collector for a small site, and one per server for high traffic.</a:t>
+            </a:r>
           </a:p>
         </p:txBody>
       </p:sp>
@@ -716,9 +853,32 @@
           <a:p>
             <a:r>
               <a:rPr lang="en-US" dirty="0"/>
-              <a:t>Section runs ~6 min. Say the transition plainly: so far you have seen what the six components are and where they run; nothing is installed yet. Before the commands, four terms, because they appear in the commands, in the collector config and in every search — in Discover's field browser, in the collector's config, in every OpenTelemetry and OpenSearch document they will read afterwards. Four terms, built in order, each needing the one before it. Nobody should leave having nodded at a term they do not own. Do not rush it. Trace and span are deliberately NOT here — they arrive in the look ahead at the end, once the log story is complete.</a:t>
-            </a:r>
-            <a:endParaRPr lang="en-US" dirty="0"/>
+              <a:t>Section runs ~6 min.
+</a:t>
+            </a:r>
+          </a:p>
+          <a:p>
+            <a:endParaRPr lang="en-US"/>
+          </a:p>
+          <a:p>
+            <a:r>
+              <a:rPr lang="en-US" dirty="0"/>
+              <a:t>• Nothing is installed yet.
+</a:t>
+            </a:r>
+          </a:p>
+          <a:p>
+            <a:r>
+              <a:rPr lang="en-US" dirty="0"/>
+              <a:t>• Before the commands, you need a few terms.
+</a:t>
+            </a:r>
+          </a:p>
+          <a:p>
+            <a:r>
+              <a:rPr lang="en-US" dirty="0"/>
+              <a:t>• They appear in the commands, in the collector file and in every search.</a:t>
+            </a:r>
           </a:p>
         </p:txBody>
       </p:sp>
@@ -804,9 +964,46 @@
           <a:p>
             <a:r>
               <a:rPr lang="en-US" dirty="0"/>
-              <a:t>~1 min. Anchor it to what they know: this is the same event Moodle already writes to its own log table — the same stream, pointed somewhere better. Nothing is invented, nothing is parsed out of a text file. One event in Moodle, one document in the store.</a:t>
-            </a:r>
-            <a:endParaRPr lang="en-US" dirty="0"/>
+              <a:t>~1 min.
+</a:t>
+            </a:r>
+          </a:p>
+          <a:p>
+            <a:endParaRPr lang="en-US"/>
+          </a:p>
+          <a:p>
+            <a:r>
+              <a:rPr lang="en-US" dirty="0"/>
+              <a:t>• A log record is one Moodle event stored as one document.
+</a:t>
+            </a:r>
+          </a:p>
+          <a:p>
+            <a:r>
+              <a:rPr lang="en-US" dirty="0"/>
+              <a:t>• It is the same event that Moodle writes to its log table.
+</a:t>
+            </a:r>
+          </a:p>
+          <a:p>
+            <a:r>
+              <a:rPr lang="en-US" dirty="0"/>
+              <a:t>• Only the destination is new.
+</a:t>
+            </a:r>
+          </a:p>
+          <a:p>
+            <a:r>
+              <a:rPr lang="en-US" dirty="0"/>
+              <a:t>• The record has a body, a time and a service name.
+</a:t>
+            </a:r>
+          </a:p>
+          <a:p>
+            <a:r>
+              <a:rPr lang="en-US" dirty="0"/>
+              <a:t>• Nothing is parsed out of a text file.</a:t>
+            </a:r>
           </a:p>
         </p:txBody>
       </p:sp>
@@ -892,9 +1089,95 @@
           <a:p>
             <a:r>
               <a:rPr lang="en-US" dirty="0"/>
-              <a:t>~2 min. Read the first three attribute lines out loud and point at the words of the body sentence they come from: Moodle builds that sentence from userid, objecttable and contextinstanceid. Then the other four, and dwell on crud. Every Moodle event classifies itself as create, read, update or delete, so the value is c, r, u or d. Answer the where question before it is asked: attributes are written in PHP on the Moodle server at the moment the event fires, they ride inside the record over OTLP, and the OpenTelemetry Collector is the one place to add, drop or hash them in transit. That is how personal data gets controlled. Point at the attributes. prefix on the four lines: a search on an attribute needs the full name with the prefix, and the field browser in Discover shows the full name. These field names are real, from the demo index.</a:t>
-            </a:r>
-            <a:endParaRPr lang="en-US" dirty="0"/>
+              <a:t>~2 min.
+</a:t>
+            </a:r>
+          </a:p>
+          <a:p>
+            <a:endParaRPr lang="en-US"/>
+          </a:p>
+          <a:p>
+            <a:r>
+              <a:rPr lang="en-US" dirty="0"/>
+              <a:t>• Every record also has attributes, which are key and value pairs.
+</a:t>
+            </a:r>
+          </a:p>
+          <a:p>
+            <a:r>
+              <a:rPr lang="en-US" dirty="0"/>
+              <a:t>• This record has seventeen.
+</a:t>
+            </a:r>
+          </a:p>
+          <a:p>
+            <a:r>
+              <a:rPr lang="en-US" dirty="0"/>
+              <a:t>• Here you see seven.
+</a:t>
+            </a:r>
+          </a:p>
+          <a:p>
+            <a:r>
+              <a:rPr lang="en-US" dirty="0"/>
+              <a:t>• Moodle builds the body sentence from the first three: userid, objecttable and contextinstanceid.
+</a:t>
+            </a:r>
+          </a:p>
+          <a:p>
+            <a:r>
+              <a:rPr lang="en-US" dirty="0"/>
+              <a:t>• The crud attribute says if the event was a create, read, update or delete.
+</a:t>
+            </a:r>
+          </a:p>
+          <a:p>
+            <a:r>
+              <a:rPr lang="en-US" dirty="0"/>
+              <a:t>• So its value is c, r, u or d.
+</a:t>
+            </a:r>
+          </a:p>
+          <a:p>
+            <a:r>
+              <a:rPr lang="en-US" dirty="0"/>
+              <a:t>• PHP writes the attributes when the event fires.
+</a:t>
+            </a:r>
+          </a:p>
+          <a:p>
+            <a:r>
+              <a:rPr lang="en-US" dirty="0"/>
+              <a:t>• They travel inside the record to the collector.
+</a:t>
+            </a:r>
+          </a:p>
+          <a:p>
+            <a:r>
+              <a:rPr lang="en-US" dirty="0"/>
+              <a:t>• The collector is where you add, remove or hash attributes.
+</a:t>
+            </a:r>
+          </a:p>
+          <a:p>
+            <a:r>
+              <a:rPr lang="en-US" dirty="0"/>
+              <a:t>• That is how you control personal data.
+</a:t>
+            </a:r>
+          </a:p>
+          <a:p>
+            <a:r>
+              <a:rPr lang="en-US" dirty="0"/>
+              <a:t>• In OpenSearch every attribute has the prefix attributes.
+</a:t>
+            </a:r>
+          </a:p>
+          <a:p>
+            <a:r>
+              <a:rPr lang="en-US" dirty="0"/>
+              <a:t>• A search needs that full name.</a:t>
+            </a:r>
           </a:p>
         </p:txBody>
       </p:sp>
@@ -980,9 +1263,32 @@
           <a:p>
             <a:r>
               <a:rPr lang="en-US" dirty="0"/>
-              <a:t>Section runs ~13 min, nine steps. Nothing is typed live. Each slide is one step with the real command. Remind them that the slides are at https://github.com/netsapiensis/MoodleMootNordic2026.</a:t>
-            </a:r>
-            <a:endParaRPr lang="en-US" dirty="0"/>
+              <a:t>Section runs ~13 min, nine steps.
+</a:t>
+            </a:r>
+          </a:p>
+          <a:p>
+            <a:endParaRPr lang="en-US"/>
+          </a:p>
+          <a:p>
+            <a:r>
+              <a:rPr lang="en-US" dirty="0"/>
+              <a:t>• The installation has nine steps.
+</a:t>
+            </a:r>
+          </a:p>
+          <a:p>
+            <a:r>
+              <a:rPr lang="en-US" dirty="0"/>
+              <a:t>• Each slide is one step with the real commands, for Ubuntu and for Red Hat.
+</a:t>
+            </a:r>
+          </a:p>
+          <a:p>
+            <a:r>
+              <a:rPr lang="en-US" dirty="0"/>
+              <a:t>• All commands are on GitHub.</a:t>
+            </a:r>
           </a:p>
         </p:txBody>
       </p:sp>
@@ -1068,9 +1374,67 @@
           <a:p>
             <a:r>
               <a:rPr lang="en-US" dirty="0"/>
-              <a:t>~1 min. Checked on both distributions, not read in a blog. PHP itself is not installed here: anyone running Moodle 5.2 already has PHP 8.3 and PHP-FPM, so only the packages this extension needs are added. php-pear is what provides the pecl command on both — without it the next slide fails at "command not found". The header package (php8.3-dev, php-devel) and the compiler packages are needed because the extension is built from source. On RHEL and Rocky, php-devel comes from the enabled module stream, so it matches the PHP that Moodle runs on.</a:t>
-            </a:r>
-            <a:endParaRPr lang="en-US" dirty="0"/>
+              <a:t>~1 min.
+</a:t>
+            </a:r>
+          </a:p>
+          <a:p>
+            <a:endParaRPr lang="en-US"/>
+          </a:p>
+          <a:p>
+            <a:r>
+              <a:rPr lang="en-US" dirty="0"/>
+              <a:t>• Step 1 installs what you need to build the PHP extension.
+</a:t>
+            </a:r>
+          </a:p>
+          <a:p>
+            <a:r>
+              <a:rPr lang="en-US" dirty="0"/>
+              <a:t>• You already have PHP 8.3 and PHP-FPM if you run Moodle 5.2.
+</a:t>
+            </a:r>
+          </a:p>
+          <a:p>
+            <a:r>
+              <a:rPr lang="en-US" dirty="0"/>
+              <a:t>• You add the PHP header files, php-pear and a C compiler.
+</a:t>
+            </a:r>
+          </a:p>
+          <a:p>
+            <a:r>
+              <a:rPr lang="en-US" dirty="0"/>
+              <a:t>• php-pear gives you the pecl command.
+</a:t>
+            </a:r>
+          </a:p>
+          <a:p>
+            <a:r>
+              <a:rPr lang="en-US" dirty="0"/>
+              <a:t>• Without it, step 2 fails with "command not found".
+</a:t>
+            </a:r>
+          </a:p>
+          <a:p>
+            <a:r>
+              <a:rPr lang="en-US" dirty="0"/>
+              <a:t>• The extension is built from source, so it needs the compiler.
+</a:t>
+            </a:r>
+          </a:p>
+          <a:p>
+            <a:r>
+              <a:rPr lang="en-US" dirty="0"/>
+              <a:t>• On Red Hat, php-devel comes from the same module stream as your PHP.
+</a:t>
+            </a:r>
+          </a:p>
+          <a:p>
+            <a:r>
+              <a:rPr lang="en-US" dirty="0"/>
+              <a:t>• So it always matches the PHP that Moodle uses.</a:t>
+            </a:r>
           </a:p>
         </p:txBody>
       </p:sp>
@@ -1156,9 +1520,95 @@
           <a:p>
             <a:r>
               <a:rPr lang="en-US" dirty="0"/>
-              <a:t>~1 min 30 s. Two differences worth naming out loud. Debian and Ubuntu split configuration into mods-available plus a phpenmod symlink per SAPI; Red Hat just drops a numbered file into /etc/php.d and is done. The number 40 controls load order and matters only if an extension depends on another — 40 is a safe middle. pecl install compiles, so it takes a minute and needs the compiler from the previous slide. If they have never used PECL or PHP Composer, say that is normal — they are PHP developers' tools, not sysadmin ones — and that extension is not package: the extension is C, from PECL, listed in php.ini; the packages on the next slide are PHP, from PHP Composer, listed in composer.json. Different tools, different files, both needed. And the restart is not optional: the CLI picks the extension up immediately, FPM does not.</a:t>
-            </a:r>
-            <a:endParaRPr lang="en-US" dirty="0"/>
+              <a:t>~1 min 30 s.
+</a:t>
+            </a:r>
+          </a:p>
+          <a:p>
+            <a:endParaRPr lang="en-US"/>
+          </a:p>
+          <a:p>
+            <a:r>
+              <a:rPr lang="en-US" dirty="0"/>
+              <a:t>• Step 2 builds and enables the extension.
+</a:t>
+            </a:r>
+          </a:p>
+          <a:p>
+            <a:r>
+              <a:rPr lang="en-US" dirty="0"/>
+              <a:t>• pecl install downloads the source and compiles it.
+</a:t>
+            </a:r>
+          </a:p>
+          <a:p>
+            <a:r>
+              <a:rPr lang="en-US" dirty="0"/>
+              <a:t>• That takes about a minute.
+</a:t>
+            </a:r>
+          </a:p>
+          <a:p>
+            <a:r>
+              <a:rPr lang="en-US" dirty="0"/>
+              <a:t>• Then a small ini file tells PHP to load it.
+</a:t>
+            </a:r>
+          </a:p>
+          <a:p>
+            <a:r>
+              <a:rPr lang="en-US" dirty="0"/>
+              <a:t>• Ubuntu puts the file in mods-available and enables it with phpenmod.
+</a:t>
+            </a:r>
+          </a:p>
+          <a:p>
+            <a:r>
+              <a:rPr lang="en-US" dirty="0"/>
+              <a:t>• Red Hat only needs the file in /etc/php.d.
+</a:t>
+            </a:r>
+          </a:p>
+          <a:p>
+            <a:r>
+              <a:rPr lang="en-US" dirty="0"/>
+              <a:t>• The number 40 in the name sets the load order.
+</a:t>
+            </a:r>
+          </a:p>
+          <a:p>
+            <a:r>
+              <a:rPr lang="en-US" dirty="0"/>
+              <a:t>• Restart PHP-FPM, because it does not load the extension until you do.
+</a:t>
+            </a:r>
+          </a:p>
+          <a:p>
+            <a:r>
+              <a:rPr lang="en-US" dirty="0"/>
+              <a:t>• The check at the bottom must show "opentelemetry hooks =&gt; enabled".
+</a:t>
+            </a:r>
+          </a:p>
+          <a:p>
+            <a:r>
+              <a:rPr lang="en-US" dirty="0"/>
+              <a:t>• The extension is C code from PECL.
+</a:t>
+            </a:r>
+          </a:p>
+          <a:p>
+            <a:r>
+              <a:rPr lang="en-US" dirty="0"/>
+              <a:t>• The packages in the next step are PHP code from Composer.
+</a:t>
+            </a:r>
+          </a:p>
+          <a:p>
+            <a:r>
+              <a:rPr lang="en-US" dirty="0"/>
+              <a:t>• You need both.</a:t>
+            </a:r>
           </a:p>
         </p:txBody>
       </p:sp>
@@ -1244,9 +1694,116 @@
           <a:p>
             <a:r>
               <a:rPr lang="en-US" dirty="0"/>
-              <a:t>~1 min 30 s. Say whose dependency this is before anyone asks: Moodle does not need Composer — the OpenTelemetry PHP libraries do, because Composer is the only way they are shipped. You run it once, against the Moodle directory, so the libraries land where Moodle 5.2 will load them. Then walk the two packages against the chain: moodle-package-otel is component 3, written by Moodle HQ — it knows Moodle from the inside, which methods to time and which events to forward. exporter-otlp is component 4, from the OpenTelemetry project — it packs spans and log records into OTLP messages and sends them to the collector, and Composer pulls the OpenTelemetry SDK in as its dependency. Neither does anything yet: the switch is the environment variables, two steps ahead. Checked: Ubuntu 24.04 packages Composer 2.7.1; Rocky and RHEL 9 do not package it at all, so the official installer is the normal route there. Reassure the room that this writes only into vendor/ and never touches Moodle core — for many this is their first time running Composer against a production Moodle. Run it as the user that owns the Moodle tree, not as root, or the web server cannot read what it wrote. The 5.2 line is verified in both source trees: 5.1 has it at public/lib/setuplib.php:82 inside the Whoops handler, which returns early for CLI, for AJAX, and whenever debugdisplay is off. Anyone on 5.0 or 5.1 now knows why the answer is "upgrade first" — one line, not a rewrite. If anyone asks why 5.2 is the minimum: one line in public/lib/classes/component.php loads vendor/autoload.php on every request; Moodle 5.1 has it only inside its error handler.</a:t>
-            </a:r>
-            <a:endParaRPr lang="en-US" dirty="0"/>
+              <a:t>~1 min 30 s.
+</a:t>
+            </a:r>
+          </a:p>
+          <a:p>
+            <a:endParaRPr lang="en-US"/>
+          </a:p>
+          <a:p>
+            <a:r>
+              <a:rPr lang="en-US" dirty="0"/>
+              <a:t>• Step 3 installs Composer and two packages.
+</a:t>
+            </a:r>
+          </a:p>
+          <a:p>
+            <a:r>
+              <a:rPr lang="en-US" dirty="0"/>
+              <a:t>• Moodle itself does not need Composer.
+</a:t>
+            </a:r>
+          </a:p>
+          <a:p>
+            <a:r>
+              <a:rPr lang="en-US" dirty="0"/>
+              <a:t>• The OpenTelemetry PHP libraries are only published through Composer.
+</a:t>
+            </a:r>
+          </a:p>
+          <a:p>
+            <a:r>
+              <a:rPr lang="en-US" dirty="0"/>
+              <a:t>• Ubuntu has a Composer package.
+</a:t>
+            </a:r>
+          </a:p>
+          <a:p>
+            <a:r>
+              <a:rPr lang="en-US" dirty="0"/>
+              <a:t>• Red Hat and Rocky do not, so you use the official installer.
+</a:t>
+            </a:r>
+          </a:p>
+          <a:p>
+            <a:r>
+              <a:rPr lang="en-US" dirty="0"/>
+              <a:t>• You run the two commands once, in the Moodle folder.
+</a:t>
+            </a:r>
+          </a:p>
+          <a:p>
+            <a:r>
+              <a:rPr lang="en-US" dirty="0"/>
+              <a:t>• moodle-package-otel comes from Moodle HQ.
+</a:t>
+            </a:r>
+          </a:p>
+          <a:p>
+            <a:r>
+              <a:rPr lang="en-US" dirty="0"/>
+              <a:t>• It knows which Moodle events to send and what to time.
+</a:t>
+            </a:r>
+          </a:p>
+          <a:p>
+            <a:r>
+              <a:rPr lang="en-US" dirty="0"/>
+              <a:t>• exporter-otlp comes from OpenTelemetry.
+</a:t>
+            </a:r>
+          </a:p>
+          <a:p>
+            <a:r>
+              <a:rPr lang="en-US" dirty="0"/>
+              <a:t>• It sends the records to the collector.
+</a:t>
+            </a:r>
+          </a:p>
+          <a:p>
+            <a:r>
+              <a:rPr lang="en-US" dirty="0"/>
+              <a:t>• Composer writes only into vendor/ and does not touch Moodle core.
+</a:t>
+            </a:r>
+          </a:p>
+          <a:p>
+            <a:r>
+              <a:rPr lang="en-US" dirty="0"/>
+              <a:t>• Run it as the user that owns the Moodle files, not as root.
+</a:t>
+            </a:r>
+          </a:p>
+          <a:p>
+            <a:r>
+              <a:rPr lang="en-US" dirty="0"/>
+              <a:t>• Nothing is sent yet.
+</a:t>
+            </a:r>
+          </a:p>
+          <a:p>
+            <a:r>
+              <a:rPr lang="en-US" dirty="0"/>
+              <a:t>• The variables in the next step switch it on.
+</a:t>
+            </a:r>
+          </a:p>
+          <a:p>
+            <a:r>
+              <a:rPr lang="en-US" dirty="0"/>
+              <a:t>? If asked why Moodle 5.1 does not work: 5.2 loads vendor/autoload.php on every request. 5.1 loads it only inside its error handler.</a:t>
+            </a:r>
           </a:p>
         </p:txBody>
       </p:sp>
@@ -1332,9 +1889,88 @@
           <a:p>
             <a:r>
               <a:rPr lang="en-US" dirty="0"/>
-              <a:t>~1 min 30 s. Every one is a standard OpenTelemetry PHP variable, not a Moodle invention, so the reference for them is https://opentelemetry.io rather than moodledev. AUTOLOAD_ENABLED is the on switch and the silent failure: without it nothing runs and nothing complains. Say where they go before anyone asks: the environment of the PHP process, which means three files, one per way PHP starts, on the next slide. Say also what they are NOT — not config.php, not a database setting, not an admin page — because someone will otherwise spend an afternoon hunting the Moodle admin tree. The protocol line: http/protobuf means HTTP on port 4318. gRPC on port 4317 also works, but it needs one more PHP Composer package.</a:t>
-            </a:r>
-            <a:endParaRPr lang="en-US" dirty="0"/>
+              <a:t>~1 min 30 s.
+</a:t>
+            </a:r>
+          </a:p>
+          <a:p>
+            <a:endParaRPr lang="en-US"/>
+          </a:p>
+          <a:p>
+            <a:r>
+              <a:rPr lang="en-US" dirty="0"/>
+              <a:t>• Step 4 is six environment variables.
+</a:t>
+            </a:r>
+          </a:p>
+          <a:p>
+            <a:r>
+              <a:rPr lang="en-US" dirty="0"/>
+              <a:t>• They are standard OpenTelemetry variables, documented on opentelemetry.io.
+</a:t>
+            </a:r>
+          </a:p>
+          <a:p>
+            <a:r>
+              <a:rPr lang="en-US" dirty="0"/>
+              <a:t>• The first one switches everything on.
+</a:t>
+            </a:r>
+          </a:p>
+          <a:p>
+            <a:r>
+              <a:rPr lang="en-US" dirty="0"/>
+              <a:t>• If you forget it, nothing is sent and you get no error.
+</a:t>
+            </a:r>
+          </a:p>
+          <a:p>
+            <a:r>
+              <a:rPr lang="en-US" dirty="0"/>
+              <a:t>• The endpoint is the collector's address.
+</a:t>
+            </a:r>
+          </a:p>
+          <a:p>
+            <a:r>
+              <a:rPr lang="en-US" dirty="0"/>
+              <a:t>• The protocol is HTTP on port 4318.
+</a:t>
+            </a:r>
+          </a:p>
+          <a:p>
+            <a:r>
+              <a:rPr lang="en-US" dirty="0"/>
+              <a:t>• The next two send the timings and the events.
+</a:t>
+            </a:r>
+          </a:p>
+          <a:p>
+            <a:r>
+              <a:rPr lang="en-US" dirty="0"/>
+              <a:t>• The last one turns metrics off, because Moodle produces none.
+</a:t>
+            </a:r>
+          </a:p>
+          <a:p>
+            <a:r>
+              <a:rPr lang="en-US" dirty="0"/>
+              <a:t>• These variables are not a Moodle setting.
+</a:t>
+            </a:r>
+          </a:p>
+          <a:p>
+            <a:r>
+              <a:rPr lang="en-US" dirty="0"/>
+              <a:t>• They do not go in config.php and you will not find them in the admin pages.
+</a:t>
+            </a:r>
+          </a:p>
+          <a:p>
+            <a:r>
+              <a:rPr lang="en-US" dirty="0"/>
+              <a:t>• gRPC on port 4317 also works, but it needs one more Composer package.</a:t>
+            </a:r>
           </a:p>
         </p:txBody>
       </p:sp>
@@ -1420,9 +2056,74 @@
           <a:p>
             <a:r>
               <a:rPr lang="en-US" dirty="0"/>
-              <a:t>~2 min. The slide people will photograph. Three points. One: PHP-FPM does not inherit your shell — the pool file is the only thing it reads, and the syntax is env[NAME] = value, not export. Two: cron is the same Moodle cron entry that already exists; crontab files accept plain NAME=value lines above the schedule, so you edit the file you already have. If they run Moodle cron from a systemd timer instead, the equivalent is Environment= or EnvironmentFile= in the unit. Three: a hand-run CLI command gets nothing unless the variables are in that shell, which is what the profile.d file fixes — or prefix the one command. Symptom of missing one: web traces but no cron traces, or the reverse, and never an error message.</a:t>
-            </a:r>
-            <a:endParaRPr lang="en-US" dirty="0"/>
+              <a:t>~2 min.
+</a:t>
+            </a:r>
+          </a:p>
+          <a:p>
+            <a:endParaRPr lang="en-US"/>
+          </a:p>
+          <a:p>
+            <a:r>
+              <a:rPr lang="en-US" dirty="0"/>
+              <a:t>• Step 5 puts the variables where PHP reads them.
+</a:t>
+            </a:r>
+          </a:p>
+          <a:p>
+            <a:r>
+              <a:rPr lang="en-US" dirty="0"/>
+              <a:t>• PHP runs Moodle in two places, PHP-FPM for web requests and cron for scheduled tasks.
+</a:t>
+            </a:r>
+          </a:p>
+          <a:p>
+            <a:r>
+              <a:rPr lang="en-US" dirty="0"/>
+              <a:t>• Each has its own environment.
+</a:t>
+            </a:r>
+          </a:p>
+          <a:p>
+            <a:r>
+              <a:rPr lang="en-US" dirty="0"/>
+              <a:t>• PHP-FPM reads only its pool file, not your shell.
+</a:t>
+            </a:r>
+          </a:p>
+          <a:p>
+            <a:r>
+              <a:rPr lang="en-US" dirty="0"/>
+              <a:t>• The pool file uses env[NAME] = value.
+</a:t>
+            </a:r>
+          </a:p>
+          <a:p>
+            <a:r>
+              <a:rPr lang="en-US" dirty="0"/>
+              <a:t>• For cron, you add plain NAME=value lines above the schedule in your existing cron file.
+</a:t>
+            </a:r>
+          </a:p>
+          <a:p>
+            <a:r>
+              <a:rPr lang="en-US" dirty="0"/>
+              <a:t>• If your cron runs from a systemd timer, use Environment= in the unit.
+</a:t>
+            </a:r>
+          </a:p>
+          <a:p>
+            <a:r>
+              <a:rPr lang="en-US" dirty="0"/>
+              <a:t>• If one file is missing, you get web data but no cron data, or the other way round.
+</a:t>
+            </a:r>
+          </a:p>
+          <a:p>
+            <a:r>
+              <a:rPr lang="en-US" dirty="0"/>
+              <a:t>• You get no error message.</a:t>
+            </a:r>
           </a:p>
         </p:txBody>
       </p:sp>
@@ -1508,9 +2209,67 @@
           <a:p>
             <a:r>
               <a:rPr lang="en-US" dirty="0"/>
-              <a:t>~1 min. Read the eight points so the room knows the shape of the hour: about four minutes on Moodle, OpenTelemetry and OpenSearch, four on how they fit together, six on the four terms, thirteen on installation, then what you get, the two cautions, a two-slide look at timing data, and the live system. The slides and the demo files are at https://github.com/netsapiensis/MoodleMootNordic2026. Tell them the address so nobody writes commands down.</a:t>
-            </a:r>
-            <a:endParaRPr lang="en-US" dirty="0"/>
+              <a:t>~1 min.
+</a:t>
+            </a:r>
+          </a:p>
+          <a:p>
+            <a:endParaRPr lang="en-US"/>
+          </a:p>
+          <a:p>
+            <a:r>
+              <a:rPr lang="en-US" dirty="0"/>
+              <a:t>• This is the plan for the next 50 minutes.
+</a:t>
+            </a:r>
+          </a:p>
+          <a:p>
+            <a:r>
+              <a:rPr lang="en-US" dirty="0"/>
+              <a:t>• First, the Moodle log table and why it is not enough.
+</a:t>
+            </a:r>
+          </a:p>
+          <a:p>
+            <a:r>
+              <a:rPr lang="en-US" dirty="0"/>
+              <a:t>• Then what Moodle, OpenTelemetry and OpenSearch each do.
+</a:t>
+            </a:r>
+          </a:p>
+          <a:p>
+            <a:r>
+              <a:rPr lang="en-US" dirty="0"/>
+              <a:t>• Then how the three fit together, and the terms you need.
+</a:t>
+            </a:r>
+          </a:p>
+          <a:p>
+            <a:r>
+              <a:rPr lang="en-US" dirty="0"/>
+              <a:t>• Installation is the longest part, about 13 minutes.
+</a:t>
+            </a:r>
+          </a:p>
+          <a:p>
+            <a:r>
+              <a:rPr lang="en-US" dirty="0"/>
+              <a:t>• After that you see the results and two things to plan for.
+</a:t>
+            </a:r>
+          </a:p>
+          <a:p>
+            <a:r>
+              <a:rPr lang="en-US" dirty="0"/>
+              <a:t>• At the end there is a short look at timing data and a live system.
+</a:t>
+            </a:r>
+          </a:p>
+          <a:p>
+            <a:r>
+              <a:rPr lang="en-US" dirty="0"/>
+              <a:t>• All commands are on GitHub.</a:t>
+            </a:r>
           </a:p>
         </p:txBody>
       </p:sp>
@@ -1596,9 +2355,81 @@
           <a:p>
             <a:r>
               <a:rPr lang="en-US" dirty="0"/>
-              <a:t>~1 min 30 s. This is the slide the OpenSearch administrator in the room has been waiting for, and the one the Moodle administrator will hand to a colleague. Say the split out loud: the collector is yours, the four rows here are done by whoever runs OpenSearch. Row one: the action group names are OpenSearch's own — write means create and update documents in existing indices, create_index means create indices and mappings, and the cluster-level cluster_manage_index_templates is what manage_index_template needs, and the cluster-level indices:data/write/bulk lets the collector send its records in bulk. Without it OpenSearch answers 403 to every batch; a fresh demo stack showed this on 2026-09-23. Row two: the exporter README says manage_index_template "creates composable index templates on startup" and is only valid with otel-v1 mode; the version numbers are from the collector changelog. Row three: the demo stack's README has this exact step, and creating the pattern through the API instead of the screen gives a pattern without a field list that Discover rejects. Row four: the ISM documentation says the policy is attached "when an index that matches the ISM template pattern is created" — so create the policy before the first monthly index, or attach it by hand. Moved off the slide: the security plugin is part of every OpenSearch install and is on unless someone switched it off; the collector logs in with a basicauth extension, an https endpoint and a tls setting, shown in step 8; mode: otel-v1 arrived in collector 0.154.0 and manage_index_template in 0.157.0, and older builds such as 0.144.0 have neither key.</a:t>
-            </a:r>
-            <a:endParaRPr lang="en-US" dirty="0"/>
+              <a:t>~1 min 30 s.
+</a:t>
+            </a:r>
+          </a:p>
+          <a:p>
+            <a:endParaRPr lang="en-US"/>
+          </a:p>
+          <a:p>
+            <a:r>
+              <a:rPr lang="en-US" dirty="0"/>
+              <a:t>• Step 6 is done by whoever runs your OpenSearch.
+</a:t>
+            </a:r>
+          </a:p>
+          <a:p>
+            <a:r>
+              <a:rPr lang="en-US" dirty="0"/>
+              <a:t>• First, a user for the collector.
+</a:t>
+            </a:r>
+          </a:p>
+          <a:p>
+            <a:r>
+              <a:rPr lang="en-US" dirty="0"/>
+              <a:t>• It needs write and create_index on the two index patterns, and two cluster permissions.
+</a:t>
+            </a:r>
+          </a:p>
+          <a:p>
+            <a:r>
+              <a:rPr lang="en-US" dirty="0"/>
+              <a:t>• Without the bulk permission, OpenSearch rejects every batch with 403.
+</a:t>
+            </a:r>
+          </a:p>
+          <a:p>
+            <a:r>
+              <a:rPr lang="en-US" dirty="0"/>
+              <a:t>• Second, the index template.
+</a:t>
+            </a:r>
+          </a:p>
+          <a:p>
+            <a:r>
+              <a:rPr lang="en-US" dirty="0"/>
+              <a:t>• The collector creates it at start, from version 0.157.0.
+</a:t>
+            </a:r>
+          </a:p>
+          <a:p>
+            <a:r>
+              <a:rPr lang="en-US" dirty="0"/>
+              <a:t>• Third, an index pattern, so that Discover can show the data.
+</a:t>
+            </a:r>
+          </a:p>
+          <a:p>
+            <a:r>
+              <a:rPr lang="en-US" dirty="0"/>
+              <a:t>• Create it in the Dashboards screen, because a pattern made through the API has no field list.
+</a:t>
+            </a:r>
+          </a:p>
+          <a:p>
+            <a:r>
+              <a:rPr lang="en-US" dirty="0"/>
+              <a:t>• Fourth, a retention policy.
+</a:t>
+            </a:r>
+          </a:p>
+          <a:p>
+            <a:r>
+              <a:rPr lang="en-US" dirty="0"/>
+              <a:t>• It only covers indices created after it, so create it on day one.</a:t>
+            </a:r>
           </a:p>
         </p:txBody>
       </p:sp>
@@ -1684,9 +2515,74 @@
           <a:p>
             <a:r>
               <a:rPr lang="en-US" dirty="0"/>
-              <a:t>~1 min. Say why the version is pinned in a variable: the collector releases every few weeks and the config keys change between versions — you will see a concrete example on the next slide. Take contrib, not the core build: the OpenSearch exporter only exists in contrib. After installing, the service is enabled but the shipped config does nothing useful until the next slide replaces it. Checked in the 0.159.0 package files: the postinstall script enables and starts the service at once, with the ready-made config file. That file listens on 0.0.0.0 on ports 4318 and 4317 (OTLP), 14250, 14268, 6831 and 6832 (Jaeger) and 9411 (Zipkin), and its debug exporter writes every record in full to the system log. Step 8 replaces the whole content of the file, and that closes the extra ports. Say this aloud; it is not on the slide. Also say that the Collector is the only new service. The PHP extension and the PHP packages run inside PHP, so after a change to them you restart PHP-FPM, and after a change to the Collector configuration you run systemctl restart otelcol-contrib.</a:t>
-            </a:r>
-            <a:endParaRPr lang="en-US" dirty="0"/>
+              <a:t>~1 min.
+</a:t>
+            </a:r>
+          </a:p>
+          <a:p>
+            <a:endParaRPr lang="en-US"/>
+          </a:p>
+          <a:p>
+            <a:r>
+              <a:rPr lang="en-US" dirty="0"/>
+              <a:t>• Step 7 installs the collector.
+</a:t>
+            </a:r>
+          </a:p>
+          <a:p>
+            <a:r>
+              <a:rPr lang="en-US" dirty="0"/>
+              <a:t>• It is not in the Ubuntu or Red Hat repositories, so you download the package from GitHub.
+</a:t>
+            </a:r>
+          </a:p>
+          <a:p>
+            <a:r>
+              <a:rPr lang="en-US" dirty="0"/>
+              <a:t>• The version is in a variable, because the collector releases every few weeks and its settings change.
+</a:t>
+            </a:r>
+          </a:p>
+          <a:p>
+            <a:r>
+              <a:rPr lang="en-US" dirty="0"/>
+              <a:t>• Take the contrib build.
+</a:t>
+            </a:r>
+          </a:p>
+          <a:p>
+            <a:r>
+              <a:rPr lang="en-US" dirty="0"/>
+              <a:t>• Only contrib has the OpenSearch exporter.
+</a:t>
+            </a:r>
+          </a:p>
+          <a:p>
+            <a:r>
+              <a:rPr lang="en-US" dirty="0"/>
+              <a:t>• The package starts the service at once with a default configuration.
+</a:t>
+            </a:r>
+          </a:p>
+          <a:p>
+            <a:r>
+              <a:rPr lang="en-US" dirty="0"/>
+              <a:t>• That default file listens on many ports on all interfaces, and it writes every record to the system log.
+</a:t>
+            </a:r>
+          </a:p>
+          <a:p>
+            <a:r>
+              <a:rPr lang="en-US" dirty="0"/>
+              <a:t>• Step 8 replaces the whole file, which closes those ports.
+</a:t>
+            </a:r>
+          </a:p>
+          <a:p>
+            <a:r>
+              <a:rPr lang="en-US" dirty="0"/>
+              <a:t>• The collector is the only new service on the server.</a:t>
+            </a:r>
           </a:p>
         </p:txBody>
       </p:sp>
@@ -1772,9 +2668,60 @@
           <a:p>
             <a:r>
               <a:rPr lang="en-US" dirty="0"/>
-              <a:t>~45 s. The file is one file, shown on two slides so the text stays readable. This half takes the records in. The sender is the PHP package exporter-otlp inside PHP. receivers opens port 4318, the OTLP port that the variable OTEL_EXPORTER_OTLP_ENDPOINT from step 4 points at; localhost because the OpenTelemetry Collector runs on the Moodle web server, so the port stays closed to the network. A shared collector on its own host needs 0.0.0.0 here and a firewall rule. processors: batch groups records for five seconds before they are sent, so one busy Moodle does not open a connection per event. The demo file has one more processor, transform/cli-status, that fixes the cron timings. The README of the demo explains it. It is not on the slide on purpose.</a:t>
-            </a:r>
-            <a:endParaRPr lang="en-US" dirty="0"/>
+              <a:t>~45 s.
+</a:t>
+            </a:r>
+          </a:p>
+          <a:p>
+            <a:endParaRPr lang="en-US"/>
+          </a:p>
+          <a:p>
+            <a:r>
+              <a:rPr lang="en-US" dirty="0"/>
+              <a:t>• Step 8 is one configuration file, shown on two slides.
+</a:t>
+            </a:r>
+          </a:p>
+          <a:p>
+            <a:r>
+              <a:rPr lang="en-US" dirty="0"/>
+              <a:t>• This first part takes the records in.
+</a:t>
+            </a:r>
+          </a:p>
+          <a:p>
+            <a:r>
+              <a:rPr lang="en-US" dirty="0"/>
+              <a:t>• The receiver listens on localhost port 4318.
+</a:t>
+            </a:r>
+          </a:p>
+          <a:p>
+            <a:r>
+              <a:rPr lang="en-US" dirty="0"/>
+              <a:t>• That is the address from the endpoint variable.
+</a:t>
+            </a:r>
+          </a:p>
+          <a:p>
+            <a:r>
+              <a:rPr lang="en-US" dirty="0"/>
+              <a:t>• The batch processor collects records for five seconds and sends them as one group.
+</a:t>
+            </a:r>
+          </a:p>
+          <a:p>
+            <a:r>
+              <a:rPr lang="en-US" dirty="0"/>
+              <a:t>• So a busy Moodle does not open one connection per event.
+</a:t>
+            </a:r>
+          </a:p>
+          <a:p>
+            <a:r>
+              <a:rPr lang="en-US" dirty="0"/>
+              <a:t>• A shared collector on its own server listens on 0.0.0.0 instead and needs a firewall rule.</a:t>
+            </a:r>
           </a:p>
         </p:txBody>
       </p:sp>
@@ -1860,9 +2807,102 @@
           <a:p>
             <a:r>
               <a:rPr lang="en-US" dirty="0"/>
-              <a:t>~1 min 30 s. Say the host name out loud: opensearch1 is our name for the OpenSearch server in this and every following example, including the curl on the next slide — they substitute theirs. extensions holds the user name and the password of the OpenSearch user from step 6; the exporter points at this block by name and does not carry the credentials itself. insecure_skip_verify: true switches off every check of the OpenSearch certificate; with a real certificate, remove the line or set ca_file. One exporter, two pipelines: logs stores the events, traces stores the timing data that step 4 switched on with OTEL_TRACES_EXPORTER=otlp. Without the traces pipeline the collector answers 404 on /v1/traces, and PHP logs a warning on every request. traces_index stays otel-v1-apm-span: the Trace analytics page in OpenSearch Dashboards reads spans from that name only. Keys that carry the weight: logs_index must start with otel-v1-logs: the index template that the exporter installs applies only to the pattern otel-v1-logs*, tested on the demo stack. With any other name OpenSearch guesses the field types. The part after that is yours to name, and one events index per site is a sane default; Discover finds it by pattern. mapping.mode: otel-v1 writes one field layout for both kinds of data. The _time_format keys decide how many indices you create, and therefore how many shards — monthly, not daily. Flag honestly that this exporter is marked alpha upstream for both logs and traces (its README). manage_index_template was explained on the Configure OpenSearch slide, two back.</a:t>
-            </a:r>
-            <a:endParaRPr lang="en-US" dirty="0"/>
+              <a:t>~1 min 30 s.
+</a:t>
+            </a:r>
+          </a:p>
+          <a:p>
+            <a:endParaRPr lang="en-US"/>
+          </a:p>
+          <a:p>
+            <a:r>
+              <a:rPr lang="en-US" dirty="0"/>
+              <a:t>• The second part sends the records to OpenSearch.
+</a:t>
+            </a:r>
+          </a:p>
+          <a:p>
+            <a:r>
+              <a:rPr lang="en-US" dirty="0"/>
+              <a:t>• opensearch1 is the name of our OpenSearch server, so use your own.
+</a:t>
+            </a:r>
+          </a:p>
+          <a:p>
+            <a:r>
+              <a:rPr lang="en-US" dirty="0"/>
+              <a:t>• The extensions block holds the login of the collector user from step 6.
+</a:t>
+            </a:r>
+          </a:p>
+          <a:p>
+            <a:r>
+              <a:rPr lang="en-US" dirty="0"/>
+              <a:t>• insecure_skip_verify turns off the certificate check.
+</a:t>
+            </a:r>
+          </a:p>
+          <a:p>
+            <a:r>
+              <a:rPr lang="en-US" dirty="0"/>
+              <a:t>• With a real certificate, remove that line.
+</a:t>
+            </a:r>
+          </a:p>
+          <a:p>
+            <a:r>
+              <a:rPr lang="en-US" dirty="0"/>
+              <a:t>• The logs index name must start with otel-v1-logs.
+</a:t>
+            </a:r>
+          </a:p>
+          <a:p>
+            <a:r>
+              <a:rPr lang="en-US" dirty="0"/>
+              <a:t>• Otherwise the index template does not apply, and OpenSearch guesses the field types.
+</a:t>
+            </a:r>
+          </a:p>
+          <a:p>
+            <a:r>
+              <a:rPr lang="en-US" dirty="0"/>
+              <a:t>• The traces index keeps its default name, because the trace pages read only that name.
+</a:t>
+            </a:r>
+          </a:p>
+          <a:p>
+            <a:r>
+              <a:rPr lang="en-US" dirty="0"/>
+              <a:t>• The time format gives one new index per month.
+</a:t>
+            </a:r>
+          </a:p>
+          <a:p>
+            <a:r>
+              <a:rPr lang="en-US" dirty="0"/>
+              <a:t>• At the bottom, two pipelines use the same exporter, one for events and one for timings.
+</a:t>
+            </a:r>
+          </a:p>
+          <a:p>
+            <a:r>
+              <a:rPr lang="en-US" dirty="0"/>
+              <a:t>• Without the traces pipeline, PHP logs a warning on every request.
+</a:t>
+            </a:r>
+          </a:p>
+          <a:p>
+            <a:r>
+              <a:rPr lang="en-US" dirty="0"/>
+              <a:t>• This exporter is still marked alpha by its authors.
+</a:t>
+            </a:r>
+          </a:p>
+          <a:p>
+            <a:r>
+              <a:rPr lang="en-US" dirty="0"/>
+              <a:t>• Restart the collector after every change to this file.</a:t>
+            </a:r>
           </a:p>
         </p:txBody>
       </p:sp>
@@ -1948,9 +2988,53 @@
           <a:p>
             <a:r>
               <a:rPr lang="en-US" dirty="0"/>
-              <a:t>~1 min. Give the debugging order explicitly — it is the single most useful thing they take away if they try this next week. Walk backwards from OpenSearch to PHP. The first check that looks right shows that the records stop just after that place. The variables check reads the PHP-FPM pool file; on RHEL and Rocky the path is /etc/php-fpm.d/www.conf. The slide counts only the logs index; the traces pipeline also creates otel-v1-apm-span-2026.09, which you can count the same way.</a:t>
-            </a:r>
-            <a:endParaRPr lang="en-US" dirty="0"/>
+              <a:t>~1 min.
+</a:t>
+            </a:r>
+          </a:p>
+          <a:p>
+            <a:endParaRPr lang="en-US"/>
+          </a:p>
+          <a:p>
+            <a:r>
+              <a:rPr lang="en-US" dirty="0"/>
+              <a:t>• Step 9 checks the result.
+</a:t>
+            </a:r>
+          </a:p>
+          <a:p>
+            <a:r>
+              <a:rPr lang="en-US" dirty="0"/>
+              <a:t>• This curl counts the records in the events index.
+</a:t>
+            </a:r>
+          </a:p>
+          <a:p>
+            <a:r>
+              <a:rPr lang="en-US" dirty="0"/>
+              <a:t>• If the count is above 0, everything works.
+</a:t>
+            </a:r>
+          </a:p>
+          <a:p>
+            <a:r>
+              <a:rPr lang="en-US" dirty="0"/>
+              <a:t>• If it is 0, check these four places in this order, from OpenSearch back to PHP.
+</a:t>
+            </a:r>
+          </a:p>
+          <a:p>
+            <a:r>
+              <a:rPr lang="en-US" dirty="0"/>
+              <a:t>• The first place that looks right tells you the records stop just after it.
+</a:t>
+            </a:r>
+          </a:p>
+          <a:p>
+            <a:r>
+              <a:rPr lang="en-US" dirty="0"/>
+              <a:t>• On Red Hat, the pool file is /etc/php-fpm.d/www.conf.</a:t>
+            </a:r>
           </a:p>
         </p:txBody>
       </p:sp>
@@ -2036,9 +3120,25 @@
           <a:p>
             <a:r>
               <a:rPr lang="en-US" dirty="0"/>
-              <a:t>Section runs ~3 min 30 s. After thirteen minutes of installation, this section shows what the audience gets. This section is the reason the talk exists.</a:t>
-            </a:r>
-            <a:endParaRPr lang="en-US" dirty="0"/>
+              <a:t>Section runs ~3 min 30 s.
+</a:t>
+            </a:r>
+          </a:p>
+          <a:p>
+            <a:endParaRPr lang="en-US"/>
+          </a:p>
+          <a:p>
+            <a:r>
+              <a:rPr lang="en-US" dirty="0"/>
+              <a:t>• That was the installation.
+</a:t>
+            </a:r>
+          </a:p>
+          <a:p>
+            <a:r>
+              <a:rPr lang="en-US" dirty="0"/>
+              <a:t>• Now you see what you get from it.</a:t>
+            </a:r>
           </a:p>
         </p:txBody>
       </p:sp>
@@ -2124,9 +3224,60 @@
           <a:p>
             <a:r>
               <a:rPr lang="en-US" dirty="0"/>
-              <a:t>~45 s. Every line verified against the demo index, not the documentation: user_loggedin and user_login_failed with the username in the record, course_module_viewed with courseid and userid, the crud attribute on every event, capability_assigned and role_assigned, email_failed with the delivery error. The audit-trail line is the one that lands with managers — who got which permission, when.</a:t>
-            </a:r>
-            <a:endParaRPr lang="en-US" dirty="0"/>
+              <a:t>~45 s.
+</a:t>
+            </a:r>
+          </a:p>
+          <a:p>
+            <a:endParaRPr lang="en-US"/>
+          </a:p>
+          <a:p>
+            <a:r>
+              <a:rPr lang="en-US" dirty="0"/>
+              <a:t>• These are the kinds of events that you get.
+</a:t>
+            </a:r>
+          </a:p>
+          <a:p>
+            <a:r>
+              <a:rPr lang="en-US" dirty="0"/>
+              <a:t>• Every login, with the user name for a failed one.
+</a:t>
+            </a:r>
+          </a:p>
+          <a:p>
+            <a:r>
+              <a:rPr lang="en-US" dirty="0"/>
+              <a:t>• Every view of a course or activity, with who viewed it.
+</a:t>
+            </a:r>
+          </a:p>
+          <a:p>
+            <a:r>
+              <a:rPr lang="en-US" dirty="0"/>
+              <a:t>• Every create, update and delete.
+</a:t>
+            </a:r>
+          </a:p>
+          <a:p>
+            <a:r>
+              <a:rPr lang="en-US" dirty="0"/>
+              <a:t>• Every role and permission change, which gives you an audit trail.
+</a:t>
+            </a:r>
+          </a:p>
+          <a:p>
+            <a:r>
+              <a:rPr lang="en-US" dirty="0"/>
+              <a:t>• And some failures, like an email that could not be sent.
+</a:t>
+            </a:r>
+          </a:p>
+          <a:p>
+            <a:r>
+              <a:rPr lang="en-US" dirty="0"/>
+              <a:t>• All of these were checked on the demo index.</a:t>
+            </a:r>
           </a:p>
         </p:txBody>
       </p:sp>
@@ -2212,9 +3363,46 @@
           <a:p>
             <a:r>
               <a:rPr lang="en-US" dirty="0"/>
-              <a:t>~1 min. Say what the search does: it keeps only the failed logins and counts them for each hour. OpenSearch calls this a date histogram. The numbers are from the demo site, run on 2026-09-27. The burst of 45 at 02:00 is added on purpose by the script that makes the demo data. If asked about "right now": add a filter on the time field, for example the last 24 hours.</a:t>
-            </a:r>
-            <a:endParaRPr lang="en-US" dirty="0"/>
+              <a:t>~1 min.
+</a:t>
+            </a:r>
+          </a:p>
+          <a:p>
+            <a:endParaRPr lang="en-US"/>
+          </a:p>
+          <a:p>
+            <a:r>
+              <a:rPr lang="en-US" dirty="0"/>
+              <a:t>• This search keeps only the failed logins and counts them per hour.
+</a:t>
+            </a:r>
+          </a:p>
+          <a:p>
+            <a:r>
+              <a:rPr lang="en-US" dirty="0"/>
+              <a:t>• OpenSearch calls this a date histogram.
+</a:t>
+            </a:r>
+          </a:p>
+          <a:p>
+            <a:r>
+              <a:rPr lang="en-US" dirty="0"/>
+              <a:t>• The table is the real result from the demo site.
+</a:t>
+            </a:r>
+          </a:p>
+          <a:p>
+            <a:r>
+              <a:rPr lang="en-US" dirty="0"/>
+              <a:t>• You can see the spike of 45 failed logins at 02:00.
+</a:t>
+            </a:r>
+          </a:p>
+          <a:p>
+            <a:r>
+              <a:rPr lang="en-US" dirty="0"/>
+              <a:t>• For "right now", add a time filter, for example the last 24 hours.</a:t>
+            </a:r>
           </a:p>
         </p:txBody>
       </p:sp>
@@ -2300,9 +3488,60 @@
           <a:p>
             <a:r>
               <a:rPr lang="en-US" dirty="0"/>
-              <a:t>~1 min 30 s. A real screenshot from the Docker Compose stack. The dashboard shows the last 30 minutes and refreshes every 10 seconds. It has five charts and one list, and dashboards-init loads them at the first start. Point at three things. First, the failure line in "Logins per minute", where one minute has ten failed logins. This answers the opening question about failed logins. Second, the table of usernames with failed logins, which shows which username was attacked. Third, the list of latest events, where each click in Moodle shows as a new row. Say that every chart is built from the same records that the searches read.</a:t>
-            </a:r>
-            <a:endParaRPr lang="en-US" dirty="0"/>
+              <a:t>~1 min 30 s.
+</a:t>
+            </a:r>
+          </a:p>
+          <a:p>
+            <a:endParaRPr lang="en-US"/>
+          </a:p>
+          <a:p>
+            <a:r>
+              <a:rPr lang="en-US" dirty="0"/>
+              <a:t>• This is the demo dashboard in OpenSearch Dashboards.
+</a:t>
+            </a:r>
+          </a:p>
+          <a:p>
+            <a:r>
+              <a:rPr lang="en-US" dirty="0"/>
+              <a:t>• It shows the last 30 minutes and refreshes every 10 seconds.
+</a:t>
+            </a:r>
+          </a:p>
+          <a:p>
+            <a:r>
+              <a:rPr lang="en-US" dirty="0"/>
+              <a:t>• You build each chart once, and it updates by itself.
+</a:t>
+            </a:r>
+          </a:p>
+          <a:p>
+            <a:r>
+              <a:rPr lang="en-US" dirty="0"/>
+              <a:t>• Here, the line of failed logins shows one minute with ten failures.
+</a:t>
+            </a:r>
+          </a:p>
+          <a:p>
+            <a:r>
+              <a:rPr lang="en-US" dirty="0"/>
+              <a:t>• The table shows which user name was attacked.
+</a:t>
+            </a:r>
+          </a:p>
+          <a:p>
+            <a:r>
+              <a:rPr lang="en-US" dirty="0"/>
+              <a:t>• The list at the bottom shows each click in Moodle as a new row.
+</a:t>
+            </a:r>
+          </a:p>
+          <a:p>
+            <a:r>
+              <a:rPr lang="en-US" dirty="0"/>
+              <a:t>• Every chart uses the same records that the searches use.</a:t>
+            </a:r>
           </a:p>
         </p:txBody>
       </p:sp>
@@ -2388,9 +3627,32 @@
           <a:p>
             <a:r>
               <a:rPr lang="en-US" dirty="0"/>
-              <a:t>Section runs ~3 min 30 s. Credibility section. This audience trusts a talk more when the speaker names the downsides before they do.</a:t>
-            </a:r>
-            <a:endParaRPr lang="en-US" dirty="0"/>
+              <a:t>Section runs ~3 min 30 s.
+</a:t>
+            </a:r>
+          </a:p>
+          <a:p>
+            <a:endParaRPr lang="en-US"/>
+          </a:p>
+          <a:p>
+            <a:r>
+              <a:rPr lang="en-US" dirty="0"/>
+              <a:t>• There are two things you must plan for before you switch this on.
+</a:t>
+            </a:r>
+          </a:p>
+          <a:p>
+            <a:r>
+              <a:rPr lang="en-US" dirty="0"/>
+              <a:t>• The first is personal data.
+</a:t>
+            </a:r>
+          </a:p>
+          <a:p>
+            <a:r>
+              <a:rPr lang="en-US" dirty="0"/>
+              <a:t>• The second is the number of indices.</a:t>
+            </a:r>
           </a:p>
         </p:txBody>
       </p:sp>
@@ -2476,9 +3738,74 @@
           <a:p>
             <a:r>
               <a:rPr lang="en-US" dirty="0"/>
-              <a:t>~2 min. The two records are real, copied from the demo site you will see at the end — nothing needs to be invented, Moodle has logged like this for years. Ask the room who has ever read these records anywhere except Moodle's own reports. Then the part where the room nods: anyone who has hosted Moodle at scale has watched logstore_standard_log grow, and has either shortened the retention setting or paid for the table. Name the trade honestly: the history has value, but the database is the wrong place to keep it — it is the most expensive storage in the estate and every report query lands on the production server.</a:t>
-            </a:r>
-            <a:endParaRPr lang="en-US" dirty="0"/>
+              <a:t>~2 min.
+</a:t>
+            </a:r>
+          </a:p>
+          <a:p>
+            <a:endParaRPr lang="en-US"/>
+          </a:p>
+          <a:p>
+            <a:r>
+              <a:rPr lang="en-US" dirty="0"/>
+              <a:t>• These two records come from our demo site.
+</a:t>
+            </a:r>
+          </a:p>
+          <a:p>
+            <a:r>
+              <a:rPr lang="en-US" dirty="0"/>
+              <a:t>• Moodle has logged every event like this for years.
+</a:t>
+            </a:r>
+          </a:p>
+          <a:p>
+            <a:r>
+              <a:rPr lang="en-US" dirty="0"/>
+              <a:t>• Every event becomes one row in the table mdl_logstore_standard_log.
+</a:t>
+            </a:r>
+          </a:p>
+          <a:p>
+            <a:r>
+              <a:rPr lang="en-US" dirty="0"/>
+              <a:t>• That table is in the same database that serves your pages.
+</a:t>
+            </a:r>
+          </a:p>
+          <a:p>
+            <a:r>
+              <a:rPr lang="en-US" dirty="0"/>
+              <a:t>• On a big site it is one of the largest tables.
+</a:t>
+            </a:r>
+          </a:p>
+          <a:p>
+            <a:r>
+              <a:rPr lang="en-US" dirty="0"/>
+              <a:t>• By default Moodle never deletes these rows.
+</a:t>
+            </a:r>
+          </a:p>
+          <a:p>
+            <a:r>
+              <a:rPr lang="en-US" dirty="0"/>
+              <a:t>• So you either shorten the retention or pay for the storage.
+</a:t>
+            </a:r>
+          </a:p>
+          <a:p>
+            <a:r>
+              <a:rPr lang="en-US" dirty="0"/>
+              <a:t>• The history has value, but the database is the most expensive place to keep it.
+</a:t>
+            </a:r>
+          </a:p>
+          <a:p>
+            <a:r>
+              <a:rPr lang="en-US" dirty="0"/>
+              <a:t>• Every report on this table also runs on your production server.</a:t>
+            </a:r>
           </a:p>
         </p:txBody>
       </p:sp>
@@ -2564,9 +3891,74 @@
           <a:p>
             <a:r>
               <a:rPr lang="en-US" dirty="0"/>
-              <a:t>~2 min. For a Swedish education host this is an important point. It decides whether the whole thing gets approved. The email_failed example is real and verified on the demo stack: the event's other.message attribute held the full text of a sign-in notification, including the account email, the login IP and the user agent. Tell what happened, step by step. It is the single most convincing argument for filtering in the collector: one config, off the Moodle components, applied to every site at once. The pseudonymity point has two sides: good for privacy by default, and it means dashboards show ids unless you deliberately enrich them.</a:t>
-            </a:r>
-            <a:endParaRPr lang="en-US" dirty="0"/>
+              <a:t>~2 min.
+</a:t>
+            </a:r>
+          </a:p>
+          <a:p>
+            <a:endParaRPr lang="en-US"/>
+          </a:p>
+          <a:p>
+            <a:r>
+              <a:rPr lang="en-US" dirty="0"/>
+              <a:t>• By default an event names a user only by id.
+</a:t>
+            </a:r>
+          </a:p>
+          <a:p>
+            <a:r>
+              <a:rPr lang="en-US" dirty="0"/>
+              <a:t>• A failed login also records the user name that was typed.
+</a:t>
+            </a:r>
+          </a:p>
+          <a:p>
+            <a:r>
+              <a:rPr lang="en-US" dirty="0"/>
+              <a:t>• Every email that Moodle fails to send is stored with its full text.
+</a:t>
+            </a:r>
+          </a:p>
+          <a:p>
+            <a:r>
+              <a:rPr lang="en-US" dirty="0"/>
+              <a:t>• On our demo site that included a sign-in notice with the user's email, IP address and browser.
+</a:t>
+            </a:r>
+          </a:p>
+          <a:p>
+            <a:r>
+              <a:rPr lang="en-US" dirty="0"/>
+              <a:t>• As soon as one record identifies a person, GDPR applies to the index.
+</a:t>
+            </a:r>
+          </a:p>
+          <a:p>
+            <a:r>
+              <a:rPr lang="en-US" dirty="0"/>
+              <a:t>• Remove or hash these attributes in the collector, before they reach OpenSearch.
+</a:t>
+            </a:r>
+          </a:p>
+          <a:p>
+            <a:r>
+              <a:rPr lang="en-US" dirty="0"/>
+              <a:t>• The statement on the slide deletes the email text.
+</a:t>
+            </a:r>
+          </a:p>
+          <a:p>
+            <a:r>
+              <a:rPr lang="en-US" dirty="0"/>
+              <a:t>• One collector configuration then protects every site.
+</a:t>
+            </a:r>
+          </a:p>
+          <a:p>
+            <a:r>
+              <a:rPr lang="en-US" dirty="0"/>
+              <a:t>• Decide the retention period before you start sending.</a:t>
+            </a:r>
           </a:p>
         </p:txBody>
       </p:sp>
@@ -2652,9 +4044,102 @@
           <a:p>
             <a:r>
               <a:rPr lang="en-US" dirty="0"/>
-              <a:t>~1 min 30 s. The 1000 is the default of cluster.max_shards_per_node; it can be raised, but that only postpones the problem. The card is arithmetic, not a story: five daily indices reach 1000 shards after 100 days, because the limit counts the primary and the replica. The sizing sentence comes from the demo index, about 290 bytes per event record on disk, so one million events a day is about 9 GB a month. Weekly indices are not available: the exporter's index name format knows only yyyy, yy, MM, dd, HH, mm and ss. If asked, the OpenSearch-native way to get a fixed index size is an ISM rollover policy behind an alias.</a:t>
-            </a:r>
-            <a:endParaRPr lang="en-US" dirty="0"/>
+              <a:t>~1 min 30 s.
+</a:t>
+            </a:r>
+          </a:p>
+          <a:p>
+            <a:endParaRPr lang="en-US"/>
+          </a:p>
+          <a:p>
+            <a:r>
+              <a:rPr lang="en-US" dirty="0"/>
+              <a:t>• OpenSearch stores each index as shards.
+</a:t>
+            </a:r>
+          </a:p>
+          <a:p>
+            <a:r>
+              <a:rPr lang="en-US" dirty="0"/>
+              <a:t>• One data server accepts at most 1000 shards by default.
+</a:t>
+            </a:r>
+          </a:p>
+          <a:p>
+            <a:r>
+              <a:rPr lang="en-US" dirty="0"/>
+              <a:t>• Each index has two shards, one primary and one copy.
+</a:t>
+            </a:r>
+          </a:p>
+          <a:p>
+            <a:r>
+              <a:rPr lang="en-US" dirty="0"/>
+              <a:t>• Five daily indices add ten shards a day and reach the limit in 100 days.
+</a:t>
+            </a:r>
+          </a:p>
+          <a:p>
+            <a:r>
+              <a:rPr lang="en-US" dirty="0"/>
+              <a:t>• After that, OpenSearch rejects all new records, and nothing alerts you.
+</a:t>
+            </a:r>
+          </a:p>
+          <a:p>
+            <a:r>
+              <a:rPr lang="en-US" dirty="0"/>
+              <a:t>• You can raise the limit, but that only delays the problem.
+</a:t>
+            </a:r>
+          </a:p>
+          <a:p>
+            <a:r>
+              <a:rPr lang="en-US" dirty="0"/>
+              <a:t>• Very large shards are also slow.
+</a:t>
+            </a:r>
+          </a:p>
+          <a:p>
+            <a:r>
+              <a:rPr lang="en-US" dirty="0"/>
+              <a:t>• Use one index per month.
+</a:t>
+            </a:r>
+          </a:p>
+          <a:p>
+            <a:r>
+              <a:rPr lang="en-US" dirty="0"/>
+              <a:t>• On the demo site one event uses about 290 bytes.
+</a:t>
+            </a:r>
+          </a:p>
+          <a:p>
+            <a:r>
+              <a:rPr lang="en-US" dirty="0"/>
+              <a:t>• So a million events a day is about 9 GB a month.
+</a:t>
+            </a:r>
+          </a:p>
+          <a:p>
+            <a:r>
+              <a:rPr lang="en-US" dirty="0"/>
+              <a:t>• Create the retention policy on the first day.
+</a:t>
+            </a:r>
+          </a:p>
+          <a:p>
+            <a:r>
+              <a:rPr lang="en-US" dirty="0"/>
+              <a:t>? If asked about weekly indices: the exporter cannot name them.
+</a:t>
+            </a:r>
+          </a:p>
+          <a:p>
+            <a:r>
+              <a:rPr lang="en-US" dirty="0"/>
+              <a:t>• For a fixed size, use an ISM rollover policy.</a:t>
+            </a:r>
           </a:p>
         </p:txBody>
       </p:sp>
@@ -2740,9 +4225,32 @@
           <a:p>
             <a:r>
               <a:rPr lang="en-US" dirty="0"/>
-              <a:t>Section runs ~3 min 30 s. The cautions are over. Two slides on the timing data, then the demo. Say once, out loud: the timing data goes through the same OpenTelemetry Collector into the same OpenSearch. Nothing new is installed for it. The collector file from step 8 already has the pipeline named traces.</a:t>
-            </a:r>
-            <a:endParaRPr lang="en-US" dirty="0"/>
+              <a:t>Section runs ~3 min 30 s.
+</a:t>
+            </a:r>
+          </a:p>
+          <a:p>
+            <a:endParaRPr lang="en-US"/>
+          </a:p>
+          <a:p>
+            <a:r>
+              <a:rPr lang="en-US" dirty="0"/>
+              <a:t>• Moodle also sends timing data.
+</a:t>
+            </a:r>
+          </a:p>
+          <a:p>
+            <a:r>
+              <a:rPr lang="en-US" dirty="0"/>
+              <a:t>• It goes through the same collector into the same OpenSearch.
+</a:t>
+            </a:r>
+          </a:p>
+          <a:p>
+            <a:r>
+              <a:rPr lang="en-US" dirty="0"/>
+              <a:t>• You install nothing new for it.</a:t>
+            </a:r>
           </a:p>
         </p:txBody>
       </p:sp>
@@ -2828,9 +4336,102 @@
           <a:p>
             <a:r>
               <a:rPr lang="en-US" dirty="0"/>
-              <a:t>~2 min. Everything so far was events. Point at the traceId and say it has been on every document shown this hour. Two new words, define each one in a short sentence: a trace is one request's timing record start to finish, a span is one step inside it. Correct the common wrong guess out loud: a trace does not follow a user around; it ends when the request ends, and a cron run is a trace too. Then read the picture: a real login request from the demo site took 92.8 ms, and the login event inside it took 2.5 ms. The trace id is 37a0a4f13ade731c02fb88010eb876b4, and the event record "The user with id '2' has logged in." carries the same traceId. No span covers the 79 ms before the login event, so the trace does not name the slow step. The first span carries a note named moodle.shutdown_handler with Moodle's own summary of the request: dbtime 0.032 s, dbqueries 13/9, which is 13 reads and 9 writes. This is the fifth question from the opening, answered in part, by the same OpenTelemetry Collector that ships the events.</a:t>
-            </a:r>
-            <a:endParaRPr lang="en-US" dirty="0"/>
+              <a:t>~2 min.
+</a:t>
+            </a:r>
+          </a:p>
+          <a:p>
+            <a:endParaRPr lang="en-US"/>
+          </a:p>
+          <a:p>
+            <a:r>
+              <a:rPr lang="en-US" dirty="0"/>
+              <a:t>• Every event record has a traceId and a spanId.
+</a:t>
+            </a:r>
+          </a:p>
+          <a:p>
+            <a:r>
+              <a:rPr lang="en-US" dirty="0"/>
+              <a:t>• They link the event to the timing of the request that wrote it.
+</a:t>
+            </a:r>
+          </a:p>
+          <a:p>
+            <a:r>
+              <a:rPr lang="en-US" dirty="0"/>
+              <a:t>• A trace is the timing of one request, from start to end.
+</a:t>
+            </a:r>
+          </a:p>
+          <a:p>
+            <a:r>
+              <a:rPr lang="en-US" dirty="0"/>
+              <a:t>• A span is one step inside it, with a start time and a duration.
+</a:t>
+            </a:r>
+          </a:p>
+          <a:p>
+            <a:r>
+              <a:rPr lang="en-US" dirty="0"/>
+              <a:t>• A trace does not follow a user.
+</a:t>
+            </a:r>
+          </a:p>
+          <a:p>
+            <a:r>
+              <a:rPr lang="en-US" dirty="0"/>
+              <a:t>• It ends when the request ends.
+</a:t>
+            </a:r>
+          </a:p>
+          <a:p>
+            <a:r>
+              <a:rPr lang="en-US" dirty="0"/>
+              <a:t>• A cron run is also a trace.
+</a:t>
+            </a:r>
+          </a:p>
+          <a:p>
+            <a:r>
+              <a:rPr lang="en-US" dirty="0"/>
+              <a:t>• This picture is a real login on the demo site.
+</a:t>
+            </a:r>
+          </a:p>
+          <a:p>
+            <a:r>
+              <a:rPr lang="en-US" dirty="0"/>
+              <a:t>• The whole request took 92.8 ms.
+</a:t>
+            </a:r>
+          </a:p>
+          <a:p>
+            <a:r>
+              <a:rPr lang="en-US" dirty="0"/>
+              <a:t>• The login event inside it took 2.5 ms.
+</a:t>
+            </a:r>
+          </a:p>
+          <a:p>
+            <a:r>
+              <a:rPr lang="en-US" dirty="0"/>
+              <a:t>• Moodle adds a note to the first span.
+</a:t>
+            </a:r>
+          </a:p>
+          <a:p>
+            <a:r>
+              <a:rPr lang="en-US" dirty="0"/>
+              <a:t>• It shows 32 ms of database time, 13 reads and 9 writes.
+</a:t>
+            </a:r>
+          </a:p>
+          <a:p>
+            <a:r>
+              <a:rPr lang="en-US" dirty="0"/>
+              <a:t>• No span covers the rest of the time, so this trace does not show the slow step.</a:t>
+            </a:r>
           </a:p>
         </p:txBody>
       </p:sp>
@@ -2916,9 +4517,74 @@
           <a:p>
             <a:r>
               <a:rPr lang="en-US" dirty="0"/>
-              <a:t>~1 min 30 s. Say it once, plainly: nothing extra was installed for this. The events and the timing data use one collector and one store, the same collector file as the walk-through. Close with the promise: the timing data gets its own session. Only if asked: by default the Trace analytics page reads spans from indices named otel-v1-apm-span-*, so the OpenTelemetry Collector writes the spans under that name, with its traces_index setting. With another name the spans are stored, but the page stays empty until you change the setting observability:traceAnalyticsSpanIndices in OpenSearch Dashboards. Only if asked: two views on the Trace analytics page, Services and the service map, need a second index. Only Data Prepper builds it. Data Prepper is a separate OpenSearch program that sits between the OpenTelemetry Collector and OpenSearch. Only if asked: a sampling rate of 10 % is a starting convention, not a Moodle measurement, and OTEL_SERVICE_NAME does not reach the stored span, verified on a real one.</a:t>
-            </a:r>
-            <a:endParaRPr lang="en-US" dirty="0"/>
+              <a:t>~1 min 30 s.
+</a:t>
+            </a:r>
+          </a:p>
+          <a:p>
+            <a:endParaRPr lang="en-US"/>
+          </a:p>
+          <a:p>
+            <a:r>
+              <a:rPr lang="en-US" dirty="0"/>
+              <a:t>• The timing data answers questions like these.
+</a:t>
+            </a:r>
+          </a:p>
+          <a:p>
+            <a:r>
+              <a:rPr lang="en-US" dirty="0"/>
+              <a:t>• Which pages are slow.
+</a:t>
+            </a:r>
+          </a:p>
+          <a:p>
+            <a:r>
+              <a:rPr lang="en-US" dirty="0"/>
+              <a:t>• Which scheduled task ran for 40 minutes last night.
+</a:t>
+            </a:r>
+          </a:p>
+          <a:p>
+            <a:r>
+              <a:rPr lang="en-US" dirty="0"/>
+              <a:t>• How long each event took inside a request.
+</a:t>
+            </a:r>
+          </a:p>
+          <a:p>
+            <a:r>
+              <a:rPr lang="en-US" dirty="0"/>
+              <a:t>• A span has attributes like an event, so you search it the same way and can sort by duration.
+</a:t>
+            </a:r>
+          </a:p>
+          <a:p>
+            <a:r>
+              <a:rPr lang="en-US" dirty="0"/>
+              <a:t>• In Dashboards you find it under Observability.
+</a:t>
+            </a:r>
+          </a:p>
+          <a:p>
+            <a:r>
+              <a:rPr lang="en-US" dirty="0"/>
+              <a:t>• Timing data deserves its own talk.
+</a:t>
+            </a:r>
+          </a:p>
+          <a:p>
+            <a:r>
+              <a:rPr lang="en-US" dirty="0"/>
+              <a:t>? If asked why the Services page is empty: it needs a second index that only Data Prepper builds.
+</a:t>
+            </a:r>
+          </a:p>
+          <a:p>
+            <a:r>
+              <a:rPr lang="en-US" dirty="0"/>
+              <a:t>? If asked about sampling: 10 % is a common start, not a Moodle measurement.</a:t>
+            </a:r>
           </a:p>
         </p:txBody>
       </p:sp>
@@ -3004,9 +4670,67 @@
           <a:p>
             <a:r>
               <a:rPr lang="en-US" dirty="0"/>
-              <a:t>~6 min. Start the Docker Compose stack before the talk. The first start builds the Moodle image and takes 5 to 10 minutes. Generate a little traffic a few minutes before you present. Have the browser tab open and logged in already. Two slides show the demo environment. After them, switch to the browser. If the live system fails, show the picture of the records screen, which is the slide after the ten containers, and continue with the next step. Never debug in front of the room. Four moves, roughly a minute each. 1. The indices exist: _cat/indices/otel-* shows the events index, with the timing index beside it. 2. The event stream: Discover on otel-v1-logs-moodle-*. Read three bodies out loud. The histogram above them is the shape of the day. 3. One search each: *user_login_failed*, then attributes.event.data.courseid: 2, then the trail of one userid. 4. Thirty seconds of timing data: copy a traceId from an event, open Trace analytics, and show the timeline. Say that the timing data is the next talk. Then go back to the four questions from the opening and answer two of them out loud. Do not explore. A short demo is better than a long one. The Services page and the service map stay empty in this stack, because it has no Data Prepper. Do not open them.</a:t>
-            </a:r>
-            <a:endParaRPr lang="en-US" dirty="0"/>
+              <a:t>~6 min.
+</a:t>
+            </a:r>
+          </a:p>
+          <a:p>
+            <a:endParaRPr lang="en-US"/>
+          </a:p>
+          <a:p>
+            <a:r>
+              <a:rPr lang="en-US" dirty="0"/>
+              <a:t>• Now the live system.
+</a:t>
+            </a:r>
+          </a:p>
+          <a:p>
+            <a:r>
+              <a:rPr lang="en-US" dirty="0"/>
+              <a:t>• First, the indices: _cat/indices/otel-* shows the events index and the timing index.
+</a:t>
+            </a:r>
+          </a:p>
+          <a:p>
+            <a:r>
+              <a:rPr lang="en-US" dirty="0"/>
+              <a:t>• Second, Discover on otel-v1-logs-moodle-*.
+</a:t>
+            </a:r>
+          </a:p>
+          <a:p>
+            <a:r>
+              <a:rPr lang="en-US" dirty="0"/>
+              <a:t>• Each row is one Moodle event, and the chart on top shows the events over time.
+</a:t>
+            </a:r>
+          </a:p>
+          <a:p>
+            <a:r>
+              <a:rPr lang="en-US" dirty="0"/>
+              <a:t>• Third, three searches: *user_login_failed*, then attributes.event.data.courseid: 2, then everything one user did.
+</a:t>
+            </a:r>
+          </a:p>
+          <a:p>
+            <a:r>
+              <a:rPr lang="en-US" dirty="0"/>
+              <a:t>• Fourth, the timing: copy a traceId from an event and open it in Trace analytics.
+</a:t>
+            </a:r>
+          </a:p>
+          <a:p>
+            <a:r>
+              <a:rPr lang="en-US" dirty="0"/>
+              <a:t>• That shows the timeline of one request.
+</a:t>
+            </a:r>
+          </a:p>
+          <a:p>
+            <a:r>
+              <a:rPr lang="en-US" dirty="0"/>
+              <a:t>• With that we have answered two of the four questions from the start.</a:t>
+            </a:r>
           </a:p>
         </p:txBody>
       </p:sp>
@@ -3092,9 +4816,67 @@
           <a:p>
             <a:r>
               <a:rPr lang="en-US" dirty="0"/>
-              <a:t>~1 min. Say what it is for: the same six components, the same environment variables, and a collector file like the one in the walk-through, with one more processor and a debug exporter. So what they saw on the slides is what starts on their computer. Everything is https, with one self-signed certificate: the browser warns once for each of the three addresses. Two limits to state: there is no Data Prepper in it, so the Services page and the service map in Trace analytics stay empty — the trace list and the per-request timeline work; and on Linux, OpenSearch needs vm.max_map_count of at least 262144 (Docker Desktop on macOS and Windows sets it for you). The compose/README.md has the first steps in Dashboards: create the index pattern, then Discover.</a:t>
-            </a:r>
-            <a:endParaRPr lang="en-US" dirty="0"/>
+              <a:t>~1 min.
+</a:t>
+            </a:r>
+          </a:p>
+          <a:p>
+            <a:endParaRPr lang="en-US"/>
+          </a:p>
+          <a:p>
+            <a:r>
+              <a:rPr lang="en-US" dirty="0"/>
+              <a:t>• You can run all of this on your own computer.
+</a:t>
+            </a:r>
+          </a:p>
+          <a:p>
+            <a:r>
+              <a:rPr lang="en-US" dirty="0"/>
+              <a:t>• The demo folder on GitHub has a Docker Compose stack.
+</a:t>
+            </a:r>
+          </a:p>
+          <a:p>
+            <a:r>
+              <a:rPr lang="en-US" dirty="0"/>
+              <a:t>• It has the same six components, the same variables and a collector file like the one you saw.
+</a:t>
+            </a:r>
+          </a:p>
+          <a:p>
+            <a:r>
+              <a:rPr lang="en-US" dirty="0"/>
+              <a:t>• One command starts it.
+</a:t>
+            </a:r>
+          </a:p>
+          <a:p>
+            <a:r>
+              <a:rPr lang="en-US" dirty="0"/>
+              <a:t>• The first start builds the Moodle image and takes 5 to 10 minutes.
+</a:t>
+            </a:r>
+          </a:p>
+          <a:p>
+            <a:r>
+              <a:rPr lang="en-US" dirty="0"/>
+              <a:t>• Everything runs on https with a self-signed certificate, so your browser warns once for each address.
+</a:t>
+            </a:r>
+          </a:p>
+          <a:p>
+            <a:r>
+              <a:rPr lang="en-US" dirty="0"/>
+              <a:t>• On Linux, OpenSearch needs vm.max_map_count of at least 262144.
+</a:t>
+            </a:r>
+          </a:p>
+          <a:p>
+            <a:r>
+              <a:rPr lang="en-US" dirty="0"/>
+              <a:t>• The passwords are in the files, so change them before other machines can reach it.</a:t>
+            </a:r>
           </a:p>
         </p:txBody>
       </p:sp>
@@ -3180,9 +4962,67 @@
           <a:p>
             <a:r>
               <a:rPr lang="en-US" dirty="0"/>
-              <a:t>~1 min. The rows are the start order, which compose.yaml enforces with depends_on, so nobody starts anything by hand: the certificate first, because OpenSearch needs it to listen on https; OpenSearch, then the init job that creates the collector's user, because the collector cannot log in before the user exists; then the collector, because Moodle sends to it from its first request; then Moodle's database install, and only then the web server and the cron loop. MariaDB starts alongside, it only has to be healthy before moodle-init. The four one-shot helpers, certs, opensearch-init, dashboards-init and moodle-init, do their job on the first start and exit; later starts find their work done. Image names are shortened; the full names, with the Docker Hub organisations, are in compose.yaml.</a:t>
-            </a:r>
-            <a:endParaRPr lang="en-US" dirty="0"/>
+              <a:t>~1 min.
+</a:t>
+            </a:r>
+          </a:p>
+          <a:p>
+            <a:endParaRPr lang="en-US"/>
+          </a:p>
+          <a:p>
+            <a:r>
+              <a:rPr lang="en-US" dirty="0"/>
+              <a:t>• The stack starts ten containers in this order, and Docker Compose handles the order for you.
+</a:t>
+            </a:r>
+          </a:p>
+          <a:p>
+            <a:r>
+              <a:rPr lang="en-US" dirty="0"/>
+              <a:t>• The certificate comes first, because OpenSearch needs it for https.
+</a:t>
+            </a:r>
+          </a:p>
+          <a:p>
+            <a:r>
+              <a:rPr lang="en-US" dirty="0"/>
+              <a:t>• Then OpenSearch, and a job that creates the collector's user.
+</a:t>
+            </a:r>
+          </a:p>
+          <a:p>
+            <a:r>
+              <a:rPr lang="en-US" dirty="0"/>
+              <a:t>• Then the collector, because Moodle sends to it from the first request.
+</a:t>
+            </a:r>
+          </a:p>
+          <a:p>
+            <a:r>
+              <a:rPr lang="en-US" dirty="0"/>
+              <a:t>• Then the Moodle database install, and then Moodle and its cron.
+</a:t>
+            </a:r>
+          </a:p>
+          <a:p>
+            <a:r>
+              <a:rPr lang="en-US" dirty="0"/>
+              <a:t>• The four containers marked "once" do their job on the first start and stop.
+</a:t>
+            </a:r>
+          </a:p>
+          <a:p>
+            <a:r>
+              <a:rPr lang="en-US" dirty="0"/>
+              <a:t>• The Services page and the service map stay empty in this stack, because it has no Data Prepper.
+</a:t>
+            </a:r>
+          </a:p>
+          <a:p>
+            <a:r>
+              <a:rPr lang="en-US" dirty="0"/>
+              <a:t>• The trace list and the timeline of each request work.</a:t>
+            </a:r>
           </a:p>
         </p:txBody>
       </p:sp>
@@ -3268,9 +5108,39 @@
           <a:p>
             <a:r>
               <a:rPr lang="en-US" dirty="0"/>
-              <a:t>Use only if the live system fails. A real screenshot from the Docker Compose stack, taken beforehand: Discover on the events index, the same screen as demo move 2. Read one body out loud, then point at the columns: they are the attributes of the log record, chosen from the field list on the left. The histogram is the count of events per 30 seconds.</a:t>
-            </a:r>
-            <a:endParaRPr lang="en-US" dirty="0"/>
+              <a:t>~30 s.
+</a:t>
+            </a:r>
+          </a:p>
+          <a:p>
+            <a:endParaRPr lang="en-US"/>
+          </a:p>
+          <a:p>
+            <a:r>
+              <a:rPr lang="en-US" dirty="0"/>
+              <a:t>• This is Discover on the events index, from the demo stack.
+</a:t>
+            </a:r>
+          </a:p>
+          <a:p>
+            <a:r>
+              <a:rPr lang="en-US" dirty="0"/>
+              <a:t>• Each row is one Moodle event.
+</a:t>
+            </a:r>
+          </a:p>
+          <a:p>
+            <a:r>
+              <a:rPr lang="en-US" dirty="0"/>
+              <a:t>• The columns are attributes, picked from the field list on the left.
+</a:t>
+            </a:r>
+          </a:p>
+          <a:p>
+            <a:r>
+              <a:rPr lang="en-US" dirty="0"/>
+              <a:t>• The chart on top counts the events per 30 seconds.</a:t>
+            </a:r>
           </a:p>
         </p:txBody>
       </p:sp>
@@ -3356,9 +5226,74 @@
           <a:p>
             <a:r>
               <a:rPr lang="en-US" dirty="0"/>
-              <a:t>Leave this up for the 10 minutes of questions. Advice if asked where to begin: install the PHP extension on a test server first, because it is the only step that compiles code. Likely ones: overhead in production (sample, and measure on your own site); PHP 8.4 (the extension supports PHP 8+); can we send to Grafana instead (yes — same OTLP, components 1 to 4 unchanged, and the Collector gets a different exporter); what about metrics (not from this package, because it records no metrics; the OpenSearch exporter can send metrics in recent versions, but Moodle does not produce them).</a:t>
-            </a:r>
-            <a:endParaRPr lang="en-US" dirty="0"/>
+              <a:t>10 min.
+</a:t>
+            </a:r>
+          </a:p>
+          <a:p>
+            <a:endParaRPr lang="en-US"/>
+          </a:p>
+          <a:p>
+            <a:r>
+              <a:rPr lang="en-US" dirty="0"/>
+              <a:t>• Thank you.
+</a:t>
+            </a:r>
+          </a:p>
+          <a:p>
+            <a:r>
+              <a:rPr lang="en-US" dirty="0"/>
+              <a:t>• The links on the slide take you further.
+</a:t>
+            </a:r>
+          </a:p>
+          <a:p>
+            <a:r>
+              <a:rPr lang="en-US" dirty="0"/>
+              <a:t>? If asked where to begin: install the PHP extension on a test server first.
+</a:t>
+            </a:r>
+          </a:p>
+          <a:p>
+            <a:r>
+              <a:rPr lang="en-US" dirty="0"/>
+              <a:t>• It is the only step that compiles code.
+</a:t>
+            </a:r>
+          </a:p>
+          <a:p>
+            <a:r>
+              <a:rPr lang="en-US" dirty="0"/>
+              <a:t>? If asked about overhead: use sampling, and measure on your own site.
+</a:t>
+            </a:r>
+          </a:p>
+          <a:p>
+            <a:r>
+              <a:rPr lang="en-US" dirty="0"/>
+              <a:t>? If asked about PHP 8.4: the extension supports PHP 8 and newer.
+</a:t>
+            </a:r>
+          </a:p>
+          <a:p>
+            <a:r>
+              <a:rPr lang="en-US" dirty="0"/>
+              <a:t>? If asked about Grafana: yes, it also speaks OTLP.
+</a:t>
+            </a:r>
+          </a:p>
+          <a:p>
+            <a:r>
+              <a:rPr lang="en-US" dirty="0"/>
+              <a:t>• Only the collector exporter changes.
+</a:t>
+            </a:r>
+          </a:p>
+          <a:p>
+            <a:r>
+              <a:rPr lang="en-US" dirty="0"/>
+              <a:t>? If asked about metrics: this package records none, and Moodle produces none.</a:t>
+            </a:r>
           </a:p>
         </p:txBody>
       </p:sp>
@@ -3444,9 +5379,67 @@
           <a:p>
             <a:r>
               <a:rPr lang="en-US" dirty="0"/>
-              <a:t>~1 min. Do not promise magic — promise these questions. The live demo must answer at least two of them out loud, pointing back here. The last question is the hook for the look ahead at timing data: developers in the room get their payoff there, everyone else gets theirs from the other questions.</a:t>
-            </a:r>
-            <a:endParaRPr lang="en-US" dirty="0"/>
+              <a:t>~1 min.
+</a:t>
+            </a:r>
+          </a:p>
+          <a:p>
+            <a:endParaRPr lang="en-US"/>
+          </a:p>
+          <a:p>
+            <a:r>
+              <a:rPr lang="en-US" dirty="0"/>
+              <a:t>• These are questions that the core Moodle reports cannot answer.
+</a:t>
+            </a:r>
+          </a:p>
+          <a:p>
+            <a:r>
+              <a:rPr lang="en-US" dirty="0"/>
+              <a:t>• How many logins per hour, this week against last week.
+</a:t>
+            </a:r>
+          </a:p>
+          <a:p>
+            <a:r>
+              <a:rPr lang="en-US" dirty="0"/>
+              <a:t>• Which courses are used, and which nobody has opened.
+</a:t>
+            </a:r>
+          </a:p>
+          <a:p>
+            <a:r>
+              <a:rPr lang="en-US" dirty="0"/>
+              <a:t>• What one user did across all courses last month.
+</a:t>
+            </a:r>
+          </a:p>
+          <a:p>
+            <a:r>
+              <a:rPr lang="en-US" dirty="0"/>
+              <a:t>• Whether failed logins are rising right now.
+</a:t>
+            </a:r>
+          </a:p>
+          <a:p>
+            <a:r>
+              <a:rPr lang="en-US" dirty="0"/>
+              <a:t>• OpenSearch answers all four.
+</a:t>
+            </a:r>
+          </a:p>
+          <a:p>
+            <a:r>
+              <a:rPr lang="en-US" dirty="0"/>
+              <a:t>• I show two of them in the live demo.
+</a:t>
+            </a:r>
+          </a:p>
+          <a:p>
+            <a:r>
+              <a:rPr lang="en-US" dirty="0"/>
+              <a:t>• The last question on the slide, why a page was slow, comes at the end with the timing data.</a:t>
+            </a:r>
           </a:p>
         </p:txBody>
       </p:sp>
@@ -3532,9 +5525,67 @@
           <a:p>
             <a:r>
               <a:rPr lang="en-US" dirty="0"/>
-              <a:t>~1 min. Start here because it is the only one of the three names they already own. The left column is the logging side — the same event stream from the previous slide — and the right is the timing side. Say out loud that one configuration produces both; you do not choose. The event names are real ones recorded on the demo stack.</a:t>
-            </a:r>
-            <a:endParaRPr lang="en-US" dirty="0"/>
+              <a:t>~1 min.
+</a:t>
+            </a:r>
+          </a:p>
+          <a:p>
+            <a:endParaRPr lang="en-US"/>
+          </a:p>
+          <a:p>
+            <a:r>
+              <a:rPr lang="en-US" dirty="0"/>
+              <a:t>• Moodle produces two kinds of records.
+</a:t>
+            </a:r>
+          </a:p>
+          <a:p>
+            <a:r>
+              <a:rPr lang="en-US" dirty="0"/>
+              <a:t>• An event records what happened, like a failed login or a new course section.
+</a:t>
+            </a:r>
+          </a:p>
+          <a:p>
+            <a:r>
+              <a:rPr lang="en-US" dirty="0"/>
+              <a:t>• These are the same events that go into the log table.
+</a:t>
+            </a:r>
+          </a:p>
+          <a:p>
+            <a:r>
+              <a:rPr lang="en-US" dirty="0"/>
+              <a:t>• A timing records how long one run took.
+</a:t>
+            </a:r>
+          </a:p>
+          <a:p>
+            <a:r>
+              <a:rPr lang="en-US" dirty="0"/>
+              <a:t>• That can be a web request, a CLI run, a scheduled task or a web service call.
+</a:t>
+            </a:r>
+          </a:p>
+          <a:p>
+            <a:r>
+              <a:rPr lang="en-US" dirty="0"/>
+              <a:t>• One configuration sends both kinds.
+</a:t>
+            </a:r>
+          </a:p>
+          <a:p>
+            <a:r>
+              <a:rPr lang="en-US" dirty="0"/>
+              <a:t>• Official OpenTelemetry support came in Moodle 5.2.
+</a:t>
+            </a:r>
+          </a:p>
+          <a:p>
+            <a:r>
+              <a:rPr lang="en-US" dirty="0"/>
+              <a:t>• Older versions do not have it.</a:t>
+            </a:r>
           </a:p>
         </p:txBody>
       </p:sp>
@@ -3620,9 +5671,102 @@
           <a:p>
             <a:r>
               <a:rPr lang="en-US" dirty="0"/>
-              <a:t>~2 min. Say it the plain way first: for this talk OpenTelemetry is a shipper — it takes the data that Moodle produces, the events and the timings, and sends it to OpenSearch. Then what the project publishes, because the room will meet both kinds: the specification defines the record format and the OTLP network protocol; the programs and libraries implement it, one library set per language, PHP among them, plus the collector as a separate program. Then the table: four pieces, installed separately, none of them a package called OpenTelemetry. Land on the last line — nothing here stores or draws — so nobody expects a screen from OpenTelemetry.</a:t>
-            </a:r>
-            <a:endParaRPr lang="en-US" dirty="0"/>
+              <a:t>~2 min.
+</a:t>
+            </a:r>
+          </a:p>
+          <a:p>
+            <a:endParaRPr lang="en-US"/>
+          </a:p>
+          <a:p>
+            <a:r>
+              <a:rPr lang="en-US" dirty="0"/>
+              <a:t>• OpenTelemetry is a log shipper.
+</a:t>
+            </a:r>
+          </a:p>
+          <a:p>
+            <a:r>
+              <a:rPr lang="en-US" dirty="0"/>
+              <a:t>• It takes the events and timings from Moodle and sends them to OpenSearch.
+</a:t>
+            </a:r>
+          </a:p>
+          <a:p>
+            <a:r>
+              <a:rPr lang="en-US" dirty="0"/>
+              <a:t>• It is open source, Apache 2.0.
+</a:t>
+            </a:r>
+          </a:p>
+          <a:p>
+            <a:r>
+              <a:rPr lang="en-US" dirty="0"/>
+              <a:t>• There is no single package called OpenTelemetry.
+</a:t>
+            </a:r>
+          </a:p>
+          <a:p>
+            <a:r>
+              <a:rPr lang="en-US" dirty="0"/>
+              <a:t>• The project defines a record format and a network protocol called OTLP.
+</a:t>
+            </a:r>
+          </a:p>
+          <a:p>
+            <a:r>
+              <a:rPr lang="en-US" dirty="0"/>
+              <a:t>• It also publishes programs and libraries for each language.
+</a:t>
+            </a:r>
+          </a:p>
+          <a:p>
+            <a:r>
+              <a:rPr lang="en-US" dirty="0"/>
+              <a:t>• We use four of them.
+</a:t>
+            </a:r>
+          </a:p>
+          <a:p>
+            <a:r>
+              <a:rPr lang="en-US" dirty="0"/>
+              <a:t>• The PHP extension hooks into running PHP code.
+</a:t>
+            </a:r>
+          </a:p>
+          <a:p>
+            <a:r>
+              <a:rPr lang="en-US" dirty="0"/>
+              <a:t>• The SDK turns Moodle's data into records.
+</a:t>
+            </a:r>
+          </a:p>
+          <a:p>
+            <a:r>
+              <a:rPr lang="en-US" dirty="0"/>
+              <a:t>• The exporter sends the records over the network.
+</a:t>
+            </a:r>
+          </a:p>
+          <a:p>
+            <a:r>
+              <a:rPr lang="en-US" dirty="0"/>
+              <a:t>• The collector is a separate service that receives, filters and forwards them.
+</a:t>
+            </a:r>
+          </a:p>
+          <a:p>
+            <a:r>
+              <a:rPr lang="en-US" dirty="0"/>
+              <a:t>• None of these four stores or shows data.
+</a:t>
+            </a:r>
+          </a:p>
+          <a:p>
+            <a:r>
+              <a:rPr lang="en-US" dirty="0"/>
+              <a:t>• That is the job of OpenSearch.</a:t>
+            </a:r>
           </a:p>
         </p:txBody>
       </p:sp>
@@ -3708,9 +5852,88 @@
           <a:p>
             <a:r>
               <a:rPr lang="en-US" dirty="0"/>
-              <a:t>~1 min 30 s. Define indexing properly, because half the room will only know grep. The contrast to draw: grep reads every byte of every file every time; an index is built once at write time so the question is answered without reading the data. That is why "which of my 40 000 cron runs took over 30 seconds last month" is instant here and impossible in a log file. Two more facts they will need: one document per span and per log record, and the indices roll over monthly, which is where retention gets decided. The right-hand card is the case for OpenSearch over a database table or a log file: it grows by adding servers (the docs' own example is a 400 GB index split into 10 shards over 10 nodes), and it is Apache 2.0 with RPM and DEB packages, which the lead-in already covers with "open source". The last two bullets are the reasons it fits this pipeline: the OpenTelemetry Collector already has an OpenSearch exporter, and OpenSearch Dashboards already has the trace screens.</a:t>
-            </a:r>
-            <a:endParaRPr lang="en-US" dirty="0"/>
+              <a:t>~1 min 30 s.
+</a:t>
+            </a:r>
+          </a:p>
+          <a:p>
+            <a:endParaRPr lang="en-US"/>
+          </a:p>
+          <a:p>
+            <a:r>
+              <a:rPr lang="en-US" dirty="0"/>
+              <a:t>• OpenSearch is a search engine and document store.
+</a:t>
+            </a:r>
+          </a:p>
+          <a:p>
+            <a:r>
+              <a:rPr lang="en-US" dirty="0"/>
+              <a:t>• It is a fork of Elasticsearch, with a web front end called OpenSearch Dashboards.
+</a:t>
+            </a:r>
+          </a:p>
+          <a:p>
+            <a:r>
+              <a:rPr lang="en-US" dirty="0"/>
+              <a:t>• Every event becomes one document.
+</a:t>
+            </a:r>
+          </a:p>
+          <a:p>
+            <a:r>
+              <a:rPr lang="en-US" dirty="0"/>
+              <a:t>• OpenSearch indexes every field when it writes the document.
+</a:t>
+            </a:r>
+          </a:p>
+          <a:p>
+            <a:r>
+              <a:rPr lang="en-US" dirty="0"/>
+              <a:t>• So a search does not read all the data, the way grep does.
+</a:t>
+            </a:r>
+          </a:p>
+          <a:p>
+            <a:r>
+              <a:rPr lang="en-US" dirty="0"/>
+              <a:t>• That is why a question like "which cron runs took over 30 seconds last month" is instant, even across millions of records.
+</a:t>
+            </a:r>
+          </a:p>
+          <a:p>
+            <a:r>
+              <a:rPr lang="en-US" dirty="0"/>
+              <a:t>• It grows by adding servers.
+</a:t>
+            </a:r>
+          </a:p>
+          <a:p>
+            <a:r>
+              <a:rPr lang="en-US" dirty="0"/>
+              <a:t>• An index is split into shards over several nodes, with copies for safety.
+</a:t>
+            </a:r>
+          </a:p>
+          <a:p>
+            <a:r>
+              <a:rPr lang="en-US" dirty="0"/>
+              <a:t>• A retention policy deletes old indices on a schedule.
+</a:t>
+            </a:r>
+          </a:p>
+          <a:p>
+            <a:r>
+              <a:rPr lang="en-US" dirty="0"/>
+              <a:t>• It also fits this setup well.
+</a:t>
+            </a:r>
+          </a:p>
+          <a:p>
+            <a:r>
+              <a:rPr lang="en-US" dirty="0"/>
+              <a:t>• The collector has an OpenSearch exporter, and Dashboards has trace screens built in.</a:t>
+            </a:r>
           </a:p>
         </p:txBody>
       </p:sp>
@@ -3796,9 +6019,25 @@
           <a:p>
             <a:r>
               <a:rPr lang="en-US" dirty="0"/>
-              <a:t>Section runs ~2 min 30 s. This is the map they should photograph. Everything in the walk-through refers back to a numbered component on it.</a:t>
-            </a:r>
-            <a:endParaRPr lang="en-US" dirty="0"/>
+              <a:t>Section runs ~2 min 30 s.
+</a:t>
+            </a:r>
+          </a:p>
+          <a:p>
+            <a:endParaRPr lang="en-US"/>
+          </a:p>
+          <a:p>
+            <a:r>
+              <a:rPr lang="en-US" dirty="0"/>
+              <a:t>• Next is the map of the whole setup.
+</a:t>
+            </a:r>
+          </a:p>
+          <a:p>
+            <a:r>
+              <a:rPr lang="en-US" dirty="0"/>
+              <a:t>• Every installation step later refers to a number on it.</a:t>
+            </a:r>
           </a:p>
         </p:txBody>
       </p:sp>
@@ -3884,9 +6123,95 @@
           <a:p>
             <a:r>
               <a:rPr lang="en-US" dirty="0"/>
-              <a:t>~1 min. Photograph slide. This is the map for the whole hour — every later slide points back to a numbered component. Trace the arrow left to right with a finger while saying it: Moodle does the work, OpenTelemetry records and measures it and carries it, OpenSearch keeps it and answers questions about it. Say the boundary out loud: everything up to and including component 5 is one project, component 6 is a different one, and the join between them is a network hop you configure. The install question always comes, so answer it here: nothing in components 2 to 5 comes with Moodle — 2 is a PECL extension, 3 and 4 are PHP Composer packages, 5 is an OS package, all installed by you. What Moodle 5.2 shipped is one line of code that loads the PHP Composer packages if they exist — that is the whole reason this needs 5.2.</a:t>
-            </a:r>
-            <a:endParaRPr lang="en-US" dirty="0"/>
+              <a:t>~1 min.
+</a:t>
+            </a:r>
+          </a:p>
+          <a:p>
+            <a:endParaRPr lang="en-US"/>
+          </a:p>
+          <a:p>
+            <a:r>
+              <a:rPr lang="en-US" dirty="0"/>
+              <a:t>• There are six components.
+</a:t>
+            </a:r>
+          </a:p>
+          <a:p>
+            <a:r>
+              <a:rPr lang="en-US" dirty="0"/>
+              <a:t>• Moodle does the work.
+</a:t>
+            </a:r>
+          </a:p>
+          <a:p>
+            <a:r>
+              <a:rPr lang="en-US" dirty="0"/>
+              <a:t>• Components 2 to 5 are OpenTelemetry.
+</a:t>
+            </a:r>
+          </a:p>
+          <a:p>
+            <a:r>
+              <a:rPr lang="en-US" dirty="0"/>
+              <a:t>• They record the data, measure it and carry it.
+</a:t>
+            </a:r>
+          </a:p>
+          <a:p>
+            <a:r>
+              <a:rPr lang="en-US" dirty="0"/>
+              <a:t>• Component 6 is OpenSearch, which stores and searches.
+</a:t>
+            </a:r>
+          </a:p>
+          <a:p>
+            <a:r>
+              <a:rPr lang="en-US" dirty="0"/>
+              <a:t>• None of components 2 to 5 comes with Moodle.
+</a:t>
+            </a:r>
+          </a:p>
+          <a:p>
+            <a:r>
+              <a:rPr lang="en-US" dirty="0"/>
+              <a:t>• You install all four.
+</a:t>
+            </a:r>
+          </a:p>
+          <a:p>
+            <a:r>
+              <a:rPr lang="en-US" dirty="0"/>
+              <a:t>• Component 2 is a PECL extension.
+</a:t>
+            </a:r>
+          </a:p>
+          <a:p>
+            <a:r>
+              <a:rPr lang="en-US" dirty="0"/>
+              <a:t>• Components 3 and 4 are PHP Composer packages.
+</a:t>
+            </a:r>
+          </a:p>
+          <a:p>
+            <a:r>
+              <a:rPr lang="en-US" dirty="0"/>
+              <a:t>• Component 5 is an operating system package.
+</a:t>
+            </a:r>
+          </a:p>
+          <a:p>
+            <a:r>
+              <a:rPr lang="en-US" dirty="0"/>
+              <a:t>• Moodle 5.2 added one line of code that loads the Composer packages when they are present.
+</a:t>
+            </a:r>
+          </a:p>
+          <a:p>
+            <a:r>
+              <a:rPr lang="en-US" dirty="0"/>
+              <a:t>• That line is the reason you need Moodle 5.2.</a:t>
+            </a:r>
           </a:p>
         </p:txBody>
       </p:sp>

</xml_diff>